<commit_message>
Noah's Oct 21 edits: talking-point headers, explainers, one luxury ranking, WMN top 5, door rate cuts
- Talking points: drop the 'What we said · <meeting>' header
- Absorption explainer: drop P&L line 254/258; ELR explainer: drop Roundtable example
- Luxury/non-luxury level slides: one 33-store ranking, luxury rows shaded,
  per-row tick at the store's segment average
- Who's Moving Now: top 5
- CP Engine flow: cut three door rate designs (still in Open Decisions)

Co-Authored-By: Claude Opus 5.5 <noreply@anthropic.com>
Claude-Session: https://claude.ai/code/session_01Xa4nFVxuQGXmHARGph9WhS
</commit_message>
<xml_diff>
--- a/day2-deck/decks/Metric Explainers - Review.pptx
+++ b/day2-deck/decks/Metric Explainers - Review.pptx
@@ -959,7 +959,7 @@
             <a:r>
               <a:rPr lang="en-US" dirty="0"/>
               <a:t>Source: Definitions match the data slides: Qlik - Closed Repair Orders (all customer-pay ROs, by close month), Profit &amp; Loss and Productivity apps, Jan-Sep 2026 vs 2025, same-store, 33 stores. Worked example: Service Manager Roundtable, Nov 15, 2024, slide 21.PLACE: CP Engine, in front of CP ELR (and ahead of the door-rate slides).
-Example: Roundtable slide 21 table: same $25 tech rate, very different ELR by job; the seven jobs total 8.1 hours and $1,056 = $130/hr.</a:t>
+Roundtable worked example removed from the slide (Noah, Oct 21).</a:t>
             </a:r>
             <a:endParaRPr lang="en-US" dirty="0"/>
           </a:p>
@@ -7769,42 +7769,23 @@
       </p:sp>
       <p:sp>
         <p:nvSpPr>
-          <p:cNvPr id="8" name="Text 6"/>
-          <p:cNvSpPr txBox="1"/>
+          <p:cNvPr id="8" name="Shape 6"/>
+          <p:cNvSpPr/>
           <p:nvPr/>
         </p:nvSpPr>
         <p:spPr>
           <a:xfrm>
             <a:off x="457200" y="2340864"/>
-            <a:ext cx="1828800" cy="457200"/>
-          </a:xfrm>
-          <a:prstGeom prst="rect">
-            <a:avLst/>
-          </a:prstGeom>
-          <a:noFill/>
-          <a:ln/>
-        </p:spPr>
-        <p:txBody>
-          <a:bodyPr wrap="square" lIns="0" tIns="0" rIns="0" bIns="0" rtlCol="0" anchor="ctr"/>
-          <a:lstStyle/>
-          <a:p>
-            <a:pPr indent="0" marL="0">
-              <a:buNone/>
-            </a:pPr>
-            <a:r>
-              <a:rPr lang="en-US" sz="1400" b="1" spc="80" kern="0" dirty="0">
-                <a:solidFill>
-                  <a:srgbClr val="595959"/>
-                </a:solidFill>
-                <a:latin typeface="Inter" pitchFamily="34" charset="0"/>
-                <a:ea typeface="Inter" pitchFamily="34" charset="-122"/>
-                <a:cs typeface="Inter" pitchFamily="34" charset="-120"/>
-              </a:rPr>
-              <a:t>Roundtable example</a:t>
-            </a:r>
-            <a:endParaRPr lang="en-US" sz="1400" dirty="0"/>
-          </a:p>
-        </p:txBody>
+            <a:ext cx="4343400" cy="3648456"/>
+          </a:xfrm>
+          <a:prstGeom prst="rect">
+            <a:avLst/>
+          </a:prstGeom>
+          <a:solidFill>
+            <a:srgbClr val="FFFFFF"/>
+          </a:solidFill>
+          <a:ln/>
+        </p:spPr>
       </p:sp>
       <p:sp>
         <p:nvSpPr>
@@ -7814,8 +7795,8 @@
         </p:nvSpPr>
         <p:spPr>
           <a:xfrm>
-            <a:off x="2286000" y="2340864"/>
-            <a:ext cx="1801368" cy="457200"/>
+            <a:off x="4937760" y="2340864"/>
+            <a:ext cx="6793992" cy="3648456"/>
           </a:xfrm>
           <a:prstGeom prst="rect">
             <a:avLst/>
@@ -7823,12 +7804,7 @@
           <a:solidFill>
             <a:srgbClr val="FFFFFF"/>
           </a:solidFill>
-          <a:ln w="9525">
-            <a:solidFill>
-              <a:srgbClr val="D9D9D9"/>
-            </a:solidFill>
-            <a:prstDash val="solid"/>
-          </a:ln>
+          <a:ln/>
         </p:spPr>
       </p:sp>
       <p:sp>
@@ -7839,40 +7815,24 @@
         </p:nvSpPr>
         <p:spPr>
           <a:xfrm>
-            <a:off x="2359152" y="2340864"/>
-            <a:ext cx="1655064" cy="457200"/>
-          </a:xfrm>
-          <a:prstGeom prst="rect">
-            <a:avLst/>
-          </a:prstGeom>
-          <a:noFill/>
-          <a:ln/>
-        </p:spPr>
-        <p:txBody>
-          <a:bodyPr wrap="square" lIns="0" tIns="0" rIns="0" bIns="0" rtlCol="0" anchor="ctr">
-            <a:normAutofit/>
-          </a:bodyPr>
-          <a:lstStyle/>
-          <a:p>
-            <a:pPr algn="ctr" indent="0" marL="0">
-              <a:buNone/>
-            </a:pPr>
-            <a:r>
-              <a:rPr lang="en-US" sz="1400" dirty="0">
-                <a:solidFill>
-                  <a:srgbClr val="1A1A1A"/>
-                </a:solidFill>
-                <a:latin typeface="Inter" pitchFamily="34" charset="0"/>
-                <a:ea typeface="Inter" pitchFamily="34" charset="-122"/>
-                <a:cs typeface="Inter" pitchFamily="34" charset="-120"/>
-              </a:rPr>
-              <a:t>Tire rotation  </a:t>
-            </a:r>
-            <a:pPr algn="ctr" indent="0" marL="0">
-              <a:buNone/>
-            </a:pPr>
-            <a:r>
-              <a:rPr lang="en-US" sz="1400" b="1" dirty="0">
+            <a:off x="658368" y="2468880"/>
+            <a:ext cx="3931920" cy="292608"/>
+          </a:xfrm>
+          <a:prstGeom prst="rect">
+            <a:avLst/>
+          </a:prstGeom>
+          <a:noFill/>
+          <a:ln/>
+        </p:spPr>
+        <p:txBody>
+          <a:bodyPr wrap="square" lIns="0" tIns="0" rIns="0" bIns="0" rtlCol="0" anchor="ctr"/>
+          <a:lstStyle/>
+          <a:p>
+            <a:pPr indent="0" marL="0">
+              <a:buNone/>
+            </a:pPr>
+            <a:r>
+              <a:rPr lang="en-US" sz="1400" b="1" spc="100" kern="0" dirty="0">
                 <a:solidFill>
                   <a:srgbClr val="0B2C4A"/>
                 </a:solidFill>
@@ -7880,36 +7840,50 @@
                 <a:ea typeface="Inter" pitchFamily="34" charset="-122"/>
                 <a:cs typeface="Inter" pitchFamily="34" charset="-120"/>
               </a:rPr>
-              <a:t>$67/hr</a:t>
-            </a:r>
-            <a:endParaRPr lang="en-US" sz="1400" dirty="0"/>
-          </a:p>
-        </p:txBody>
-      </p:sp>
-      <p:sp>
-        <p:nvSpPr>
-          <p:cNvPr id="11" name="Shape 9"/>
-          <p:cNvSpPr/>
-          <p:nvPr/>
-        </p:nvSpPr>
-        <p:spPr>
-          <a:xfrm>
-            <a:off x="4197096" y="2340864"/>
-            <a:ext cx="1801368" cy="457200"/>
-          </a:xfrm>
-          <a:prstGeom prst="rect">
-            <a:avLst/>
-          </a:prstGeom>
-          <a:solidFill>
-            <a:srgbClr val="FFFFFF"/>
-          </a:solidFill>
-          <a:ln w="9525">
-            <a:solidFill>
-              <a:srgbClr val="D9D9D9"/>
-            </a:solidFill>
-            <a:prstDash val="solid"/>
-          </a:ln>
-        </p:spPr>
+              <a:t>WHY IT MATTERS</a:t>
+            </a:r>
+            <a:endParaRPr lang="en-US" sz="1400" dirty="0"/>
+          </a:p>
+        </p:txBody>
+      </p:sp>
+      <p:sp>
+        <p:nvSpPr>
+          <p:cNvPr id="11" name="Text 9"/>
+          <p:cNvSpPr txBox="1"/>
+          <p:nvPr/>
+        </p:nvSpPr>
+        <p:spPr>
+          <a:xfrm>
+            <a:off x="5138928" y="2468880"/>
+            <a:ext cx="6400800" cy="292608"/>
+          </a:xfrm>
+          <a:prstGeom prst="rect">
+            <a:avLst/>
+          </a:prstGeom>
+          <a:noFill/>
+          <a:ln/>
+        </p:spPr>
+        <p:txBody>
+          <a:bodyPr wrap="square" lIns="0" tIns="0" rIns="0" bIns="0" rtlCol="0" anchor="ctr"/>
+          <a:lstStyle/>
+          <a:p>
+            <a:pPr indent="0" marL="0">
+              <a:buNone/>
+            </a:pPr>
+            <a:r>
+              <a:rPr lang="en-US" sz="1400" b="1" spc="100" kern="0" dirty="0">
+                <a:solidFill>
+                  <a:srgbClr val="0B2C4A"/>
+                </a:solidFill>
+                <a:latin typeface="Inter" pitchFamily="34" charset="0"/>
+                <a:ea typeface="Inter" pitchFamily="34" charset="-122"/>
+                <a:cs typeface="Inter" pitchFamily="34" charset="-120"/>
+              </a:rPr>
+              <a:t>WHAT MOVES IT</a:t>
+            </a:r>
+            <a:endParaRPr lang="en-US" sz="1400" dirty="0"/>
+          </a:p>
+        </p:txBody>
       </p:sp>
       <p:sp>
         <p:nvSpPr>
@@ -7919,421 +7893,8 @@
         </p:nvSpPr>
         <p:spPr>
           <a:xfrm>
-            <a:off x="4270248" y="2340864"/>
-            <a:ext cx="1655064" cy="457200"/>
-          </a:xfrm>
-          <a:prstGeom prst="rect">
-            <a:avLst/>
-          </a:prstGeom>
-          <a:noFill/>
-          <a:ln/>
-        </p:spPr>
-        <p:txBody>
-          <a:bodyPr wrap="square" lIns="0" tIns="0" rIns="0" bIns="0" rtlCol="0" anchor="ctr">
-            <a:normAutofit/>
-          </a:bodyPr>
-          <a:lstStyle/>
-          <a:p>
-            <a:pPr algn="ctr" indent="0" marL="0">
-              <a:buNone/>
-            </a:pPr>
-            <a:r>
-              <a:rPr lang="en-US" sz="1400" dirty="0">
-                <a:solidFill>
-                  <a:srgbClr val="1A1A1A"/>
-                </a:solidFill>
-                <a:latin typeface="Inter" pitchFamily="34" charset="0"/>
-                <a:ea typeface="Inter" pitchFamily="34" charset="-122"/>
-                <a:cs typeface="Inter" pitchFamily="34" charset="-120"/>
-              </a:rPr>
-              <a:t>Oil change  </a:t>
-            </a:r>
-            <a:pPr algn="ctr" indent="0" marL="0">
-              <a:buNone/>
-            </a:pPr>
-            <a:r>
-              <a:rPr lang="en-US" sz="1400" b="1" dirty="0">
-                <a:solidFill>
-                  <a:srgbClr val="0B2C4A"/>
-                </a:solidFill>
-                <a:latin typeface="Inter" pitchFamily="34" charset="0"/>
-                <a:ea typeface="Inter" pitchFamily="34" charset="-122"/>
-                <a:cs typeface="Inter" pitchFamily="34" charset="-120"/>
-              </a:rPr>
-              <a:t>$80/hr</a:t>
-            </a:r>
-            <a:endParaRPr lang="en-US" sz="1400" dirty="0"/>
-          </a:p>
-        </p:txBody>
-      </p:sp>
-      <p:sp>
-        <p:nvSpPr>
-          <p:cNvPr id="13" name="Shape 11"/>
-          <p:cNvSpPr/>
-          <p:nvPr/>
-        </p:nvSpPr>
-        <p:spPr>
-          <a:xfrm>
-            <a:off x="6108192" y="2340864"/>
-            <a:ext cx="1801368" cy="457200"/>
-          </a:xfrm>
-          <a:prstGeom prst="rect">
-            <a:avLst/>
-          </a:prstGeom>
-          <a:solidFill>
-            <a:srgbClr val="FFFFFF"/>
-          </a:solidFill>
-          <a:ln w="9525">
-            <a:solidFill>
-              <a:srgbClr val="D9D9D9"/>
-            </a:solidFill>
-            <a:prstDash val="solid"/>
-          </a:ln>
-        </p:spPr>
-      </p:sp>
-      <p:sp>
-        <p:nvSpPr>
-          <p:cNvPr id="14" name="Text 12"/>
-          <p:cNvSpPr txBox="1"/>
-          <p:nvPr/>
-        </p:nvSpPr>
-        <p:spPr>
-          <a:xfrm>
-            <a:off x="6181344" y="2340864"/>
-            <a:ext cx="1655064" cy="457200"/>
-          </a:xfrm>
-          <a:prstGeom prst="rect">
-            <a:avLst/>
-          </a:prstGeom>
-          <a:noFill/>
-          <a:ln/>
-        </p:spPr>
-        <p:txBody>
-          <a:bodyPr wrap="square" lIns="0" tIns="0" rIns="0" bIns="0" rtlCol="0" anchor="ctr">
-            <a:normAutofit/>
-          </a:bodyPr>
-          <a:lstStyle/>
-          <a:p>
-            <a:pPr algn="ctr" indent="0" marL="0">
-              <a:buNone/>
-            </a:pPr>
-            <a:r>
-              <a:rPr lang="en-US" sz="1400" dirty="0">
-                <a:solidFill>
-                  <a:srgbClr val="1A1A1A"/>
-                </a:solidFill>
-                <a:latin typeface="Inter" pitchFamily="34" charset="0"/>
-                <a:ea typeface="Inter" pitchFamily="34" charset="-122"/>
-                <a:cs typeface="Inter" pitchFamily="34" charset="-120"/>
-              </a:rPr>
-              <a:t>Alignment  </a:t>
-            </a:r>
-            <a:pPr algn="ctr" indent="0" marL="0">
-              <a:buNone/>
-            </a:pPr>
-            <a:r>
-              <a:rPr lang="en-US" sz="1400" b="1" dirty="0">
-                <a:solidFill>
-                  <a:srgbClr val="0B2C4A"/>
-                </a:solidFill>
-                <a:latin typeface="Inter" pitchFamily="34" charset="0"/>
-                <a:ea typeface="Inter" pitchFamily="34" charset="-122"/>
-                <a:cs typeface="Inter" pitchFamily="34" charset="-120"/>
-              </a:rPr>
-              <a:t>$117/hr</a:t>
-            </a:r>
-            <a:endParaRPr lang="en-US" sz="1400" dirty="0"/>
-          </a:p>
-        </p:txBody>
-      </p:sp>
-      <p:sp>
-        <p:nvSpPr>
-          <p:cNvPr id="15" name="Shape 13"/>
-          <p:cNvSpPr/>
-          <p:nvPr/>
-        </p:nvSpPr>
-        <p:spPr>
-          <a:xfrm>
-            <a:off x="8019288" y="2340864"/>
-            <a:ext cx="1801368" cy="457200"/>
-          </a:xfrm>
-          <a:prstGeom prst="rect">
-            <a:avLst/>
-          </a:prstGeom>
-          <a:solidFill>
-            <a:srgbClr val="FFFFFF"/>
-          </a:solidFill>
-          <a:ln w="9525">
-            <a:solidFill>
-              <a:srgbClr val="D9D9D9"/>
-            </a:solidFill>
-            <a:prstDash val="solid"/>
-          </a:ln>
-        </p:spPr>
-      </p:sp>
-      <p:sp>
-        <p:nvSpPr>
-          <p:cNvPr id="16" name="Text 14"/>
-          <p:cNvSpPr txBox="1"/>
-          <p:nvPr/>
-        </p:nvSpPr>
-        <p:spPr>
-          <a:xfrm>
-            <a:off x="8092440" y="2340864"/>
-            <a:ext cx="1655064" cy="457200"/>
-          </a:xfrm>
-          <a:prstGeom prst="rect">
-            <a:avLst/>
-          </a:prstGeom>
-          <a:noFill/>
-          <a:ln/>
-        </p:spPr>
-        <p:txBody>
-          <a:bodyPr wrap="square" lIns="0" tIns="0" rIns="0" bIns="0" rtlCol="0" anchor="ctr">
-            <a:normAutofit/>
-          </a:bodyPr>
-          <a:lstStyle/>
-          <a:p>
-            <a:pPr algn="ctr" indent="0" marL="0">
-              <a:buNone/>
-            </a:pPr>
-            <a:r>
-              <a:rPr lang="en-US" sz="1400" dirty="0">
-                <a:solidFill>
-                  <a:srgbClr val="1A1A1A"/>
-                </a:solidFill>
-                <a:latin typeface="Inter" pitchFamily="34" charset="0"/>
-                <a:ea typeface="Inter" pitchFamily="34" charset="-122"/>
-                <a:cs typeface="Inter" pitchFamily="34" charset="-120"/>
-              </a:rPr>
-              <a:t>Steering rack  </a:t>
-            </a:r>
-            <a:pPr algn="ctr" indent="0" marL="0">
-              <a:buNone/>
-            </a:pPr>
-            <a:r>
-              <a:rPr lang="en-US" sz="1400" b="1" dirty="0">
-                <a:solidFill>
-                  <a:srgbClr val="0B2C4A"/>
-                </a:solidFill>
-                <a:latin typeface="Inter" pitchFamily="34" charset="0"/>
-                <a:ea typeface="Inter" pitchFamily="34" charset="-122"/>
-                <a:cs typeface="Inter" pitchFamily="34" charset="-120"/>
-              </a:rPr>
-              <a:t>$160/hr</a:t>
-            </a:r>
-            <a:endParaRPr lang="en-US" sz="1400" dirty="0"/>
-          </a:p>
-        </p:txBody>
-      </p:sp>
-      <p:sp>
-        <p:nvSpPr>
-          <p:cNvPr id="17" name="Shape 15"/>
-          <p:cNvSpPr/>
-          <p:nvPr/>
-        </p:nvSpPr>
-        <p:spPr>
-          <a:xfrm>
-            <a:off x="9930384" y="2340864"/>
-            <a:ext cx="1801368" cy="457200"/>
-          </a:xfrm>
-          <a:prstGeom prst="rect">
-            <a:avLst/>
-          </a:prstGeom>
-          <a:solidFill>
-            <a:srgbClr val="FFFFFF"/>
-          </a:solidFill>
-          <a:ln w="9525">
-            <a:solidFill>
-              <a:srgbClr val="D9D9D9"/>
-            </a:solidFill>
-            <a:prstDash val="solid"/>
-          </a:ln>
-        </p:spPr>
-      </p:sp>
-      <p:sp>
-        <p:nvSpPr>
-          <p:cNvPr id="18" name="Text 16"/>
-          <p:cNvSpPr txBox="1"/>
-          <p:nvPr/>
-        </p:nvSpPr>
-        <p:spPr>
-          <a:xfrm>
-            <a:off x="10003536" y="2340864"/>
-            <a:ext cx="1655064" cy="457200"/>
-          </a:xfrm>
-          <a:prstGeom prst="rect">
-            <a:avLst/>
-          </a:prstGeom>
-          <a:noFill/>
-          <a:ln/>
-        </p:spPr>
-        <p:txBody>
-          <a:bodyPr wrap="square" lIns="0" tIns="0" rIns="0" bIns="0" rtlCol="0" anchor="ctr">
-            <a:normAutofit/>
-          </a:bodyPr>
-          <a:lstStyle/>
-          <a:p>
-            <a:pPr algn="ctr" indent="0" marL="0">
-              <a:buNone/>
-            </a:pPr>
-            <a:r>
-              <a:rPr lang="en-US" sz="1400" dirty="0">
-                <a:solidFill>
-                  <a:srgbClr val="1A1A1A"/>
-                </a:solidFill>
-                <a:latin typeface="Inter" pitchFamily="34" charset="0"/>
-                <a:ea typeface="Inter" pitchFamily="34" charset="-122"/>
-                <a:cs typeface="Inter" pitchFamily="34" charset="-120"/>
-              </a:rPr>
-              <a:t>All 7 jobs  </a:t>
-            </a:r>
-            <a:pPr algn="ctr" indent="0" marL="0">
-              <a:buNone/>
-            </a:pPr>
-            <a:r>
-              <a:rPr lang="en-US" sz="1400" b="1" dirty="0">
-                <a:solidFill>
-                  <a:srgbClr val="0B2C4A"/>
-                </a:solidFill>
-                <a:latin typeface="Inter" pitchFamily="34" charset="0"/>
-                <a:ea typeface="Inter" pitchFamily="34" charset="-122"/>
-                <a:cs typeface="Inter" pitchFamily="34" charset="-120"/>
-              </a:rPr>
-              <a:t>$130/hr</a:t>
-            </a:r>
-            <a:endParaRPr lang="en-US" sz="1400" dirty="0"/>
-          </a:p>
-        </p:txBody>
-      </p:sp>
-      <p:sp>
-        <p:nvSpPr>
-          <p:cNvPr id="19" name="Shape 17"/>
-          <p:cNvSpPr/>
-          <p:nvPr/>
-        </p:nvSpPr>
-        <p:spPr>
-          <a:xfrm>
-            <a:off x="457200" y="2907792"/>
-            <a:ext cx="4343400" cy="3081528"/>
-          </a:xfrm>
-          <a:prstGeom prst="rect">
-            <a:avLst/>
-          </a:prstGeom>
-          <a:solidFill>
-            <a:srgbClr val="FFFFFF"/>
-          </a:solidFill>
-          <a:ln/>
-        </p:spPr>
-      </p:sp>
-      <p:sp>
-        <p:nvSpPr>
-          <p:cNvPr id="20" name="Shape 18"/>
-          <p:cNvSpPr/>
-          <p:nvPr/>
-        </p:nvSpPr>
-        <p:spPr>
-          <a:xfrm>
-            <a:off x="4937760" y="2907792"/>
-            <a:ext cx="6793992" cy="3081528"/>
-          </a:xfrm>
-          <a:prstGeom prst="rect">
-            <a:avLst/>
-          </a:prstGeom>
-          <a:solidFill>
-            <a:srgbClr val="FFFFFF"/>
-          </a:solidFill>
-          <a:ln/>
-        </p:spPr>
-      </p:sp>
-      <p:sp>
-        <p:nvSpPr>
-          <p:cNvPr id="21" name="Text 19"/>
-          <p:cNvSpPr txBox="1"/>
-          <p:nvPr/>
-        </p:nvSpPr>
-        <p:spPr>
-          <a:xfrm>
-            <a:off x="658368" y="3035808"/>
-            <a:ext cx="3931920" cy="292608"/>
-          </a:xfrm>
-          <a:prstGeom prst="rect">
-            <a:avLst/>
-          </a:prstGeom>
-          <a:noFill/>
-          <a:ln/>
-        </p:spPr>
-        <p:txBody>
-          <a:bodyPr wrap="square" lIns="0" tIns="0" rIns="0" bIns="0" rtlCol="0" anchor="ctr"/>
-          <a:lstStyle/>
-          <a:p>
-            <a:pPr indent="0" marL="0">
-              <a:buNone/>
-            </a:pPr>
-            <a:r>
-              <a:rPr lang="en-US" sz="1400" b="1" spc="100" kern="0" dirty="0">
-                <a:solidFill>
-                  <a:srgbClr val="0B2C4A"/>
-                </a:solidFill>
-                <a:latin typeface="Inter" pitchFamily="34" charset="0"/>
-                <a:ea typeface="Inter" pitchFamily="34" charset="-122"/>
-                <a:cs typeface="Inter" pitchFamily="34" charset="-120"/>
-              </a:rPr>
-              <a:t>WHY IT MATTERS</a:t>
-            </a:r>
-            <a:endParaRPr lang="en-US" sz="1400" dirty="0"/>
-          </a:p>
-        </p:txBody>
-      </p:sp>
-      <p:sp>
-        <p:nvSpPr>
-          <p:cNvPr id="22" name="Text 20"/>
-          <p:cNvSpPr txBox="1"/>
-          <p:nvPr/>
-        </p:nvSpPr>
-        <p:spPr>
-          <a:xfrm>
-            <a:off x="5138928" y="3035808"/>
-            <a:ext cx="6400800" cy="292608"/>
-          </a:xfrm>
-          <a:prstGeom prst="rect">
-            <a:avLst/>
-          </a:prstGeom>
-          <a:noFill/>
-          <a:ln/>
-        </p:spPr>
-        <p:txBody>
-          <a:bodyPr wrap="square" lIns="0" tIns="0" rIns="0" bIns="0" rtlCol="0" anchor="ctr"/>
-          <a:lstStyle/>
-          <a:p>
-            <a:pPr indent="0" marL="0">
-              <a:buNone/>
-            </a:pPr>
-            <a:r>
-              <a:rPr lang="en-US" sz="1400" b="1" spc="100" kern="0" dirty="0">
-                <a:solidFill>
-                  <a:srgbClr val="0B2C4A"/>
-                </a:solidFill>
-                <a:latin typeface="Inter" pitchFamily="34" charset="0"/>
-                <a:ea typeface="Inter" pitchFamily="34" charset="-122"/>
-                <a:cs typeface="Inter" pitchFamily="34" charset="-120"/>
-              </a:rPr>
-              <a:t>WHAT MOVES IT</a:t>
-            </a:r>
-            <a:endParaRPr lang="en-US" sz="1400" dirty="0"/>
-          </a:p>
-        </p:txBody>
-      </p:sp>
-      <p:sp>
-        <p:nvSpPr>
-          <p:cNvPr id="23" name="Text 21"/>
-          <p:cNvSpPr txBox="1"/>
-          <p:nvPr/>
-        </p:nvSpPr>
-        <p:spPr>
-          <a:xfrm>
-            <a:off x="658368" y="3410712"/>
-            <a:ext cx="3977640" cy="2441448"/>
+            <a:off x="658368" y="2843784"/>
+            <a:ext cx="3977640" cy="3008376"/>
           </a:xfrm>
           <a:prstGeom prst="rect">
             <a:avLst/>
@@ -8353,7 +7914,7 @@
               <a:buChar char="•"/>
             </a:pPr>
             <a:r>
-              <a:rPr lang="en-US" sz="1500" dirty="0">
+              <a:rPr lang="en-US" sz="1600" dirty="0">
                 <a:solidFill>
                   <a:srgbClr val="1A1A1A"/>
                 </a:solidFill>
@@ -8363,7 +7924,7 @@
               </a:rPr>
               <a:t>Every hour sold is worth the ELR, so it sets the value of the whole shop.</a:t>
             </a:r>
-            <a:endParaRPr lang="en-US" sz="1500" dirty="0"/>
+            <a:endParaRPr lang="en-US" sz="1600" dirty="0"/>
           </a:p>
           <a:p>
             <a:pPr marL="203200" indent="-203200">
@@ -8374,7 +7935,7 @@
               <a:buChar char="•"/>
             </a:pPr>
             <a:r>
-              <a:rPr lang="en-US" sz="1500" dirty="0">
+              <a:rPr lang="en-US" sz="1600" dirty="0">
                 <a:solidFill>
                   <a:srgbClr val="1A1A1A"/>
                 </a:solidFill>
@@ -8384,7 +7945,7 @@
               </a:rPr>
               <a:t>The gap to door rate is money given away. Our benchmark: CP ELR at least 70% of door rate.</a:t>
             </a:r>
-            <a:endParaRPr lang="en-US" sz="1500" dirty="0"/>
+            <a:endParaRPr lang="en-US" sz="1600" dirty="0"/>
           </a:p>
           <a:p>
             <a:pPr marL="203200" indent="-203200">
@@ -8395,7 +7956,7 @@
               <a:buChar char="•"/>
             </a:pPr>
             <a:r>
-              <a:rPr lang="en-US" sz="1500" dirty="0">
+              <a:rPr lang="en-US" sz="1600" dirty="0">
                 <a:solidFill>
                   <a:srgbClr val="1A1A1A"/>
                 </a:solidFill>
@@ -8405,20 +7966,20 @@
               </a:rPr>
               <a:t>It shows whether pricing, discounting and mix are under control.</a:t>
             </a:r>
-            <a:endParaRPr lang="en-US" sz="1500" dirty="0"/>
-          </a:p>
-        </p:txBody>
-      </p:sp>
-      <p:sp>
-        <p:nvSpPr>
-          <p:cNvPr id="24" name="Shape 22"/>
+            <a:endParaRPr lang="en-US" sz="1600" dirty="0"/>
+          </a:p>
+        </p:txBody>
+      </p:sp>
+      <p:sp>
+        <p:nvSpPr>
+          <p:cNvPr id="13" name="Shape 11"/>
           <p:cNvSpPr/>
           <p:nvPr/>
         </p:nvSpPr>
         <p:spPr>
           <a:xfrm>
-            <a:off x="5138928" y="3410712"/>
-            <a:ext cx="45720" cy="1133856"/>
+            <a:off x="5138928" y="2843784"/>
+            <a:ext cx="45720" cy="908304"/>
           </a:xfrm>
           <a:prstGeom prst="rect">
             <a:avLst/>
@@ -8431,14 +7992,14 @@
       </p:sp>
       <p:sp>
         <p:nvSpPr>
-          <p:cNvPr id="25" name="Text 23"/>
-          <p:cNvSpPr txBox="1"/>
-          <p:nvPr/>
-        </p:nvSpPr>
-        <p:spPr>
-          <a:xfrm>
-            <a:off x="5266944" y="3410712"/>
-            <a:ext cx="1877568" cy="1133856"/>
+          <p:cNvPr id="14" name="Text 12"/>
+          <p:cNvSpPr txBox="1"/>
+          <p:nvPr/>
+        </p:nvSpPr>
+        <p:spPr>
+          <a:xfrm>
+            <a:off x="5266944" y="2843784"/>
+            <a:ext cx="2962656" cy="908304"/>
           </a:xfrm>
           <a:prstGeom prst="rect">
             <a:avLst/>
@@ -8487,14 +8048,14 @@
       </p:sp>
       <p:sp>
         <p:nvSpPr>
-          <p:cNvPr id="26" name="Shape 24"/>
+          <p:cNvPr id="15" name="Shape 13"/>
           <p:cNvSpPr/>
           <p:nvPr/>
         </p:nvSpPr>
         <p:spPr>
           <a:xfrm>
-            <a:off x="7309104" y="3410712"/>
-            <a:ext cx="45720" cy="1133856"/>
+            <a:off x="8394192" y="2843784"/>
+            <a:ext cx="45720" cy="908304"/>
           </a:xfrm>
           <a:prstGeom prst="rect">
             <a:avLst/>
@@ -8507,14 +8068,14 @@
       </p:sp>
       <p:sp>
         <p:nvSpPr>
-          <p:cNvPr id="27" name="Text 25"/>
-          <p:cNvSpPr txBox="1"/>
-          <p:nvPr/>
-        </p:nvSpPr>
-        <p:spPr>
-          <a:xfrm>
-            <a:off x="7437120" y="3410712"/>
-            <a:ext cx="1877568" cy="1133856"/>
+          <p:cNvPr id="16" name="Text 14"/>
+          <p:cNvSpPr txBox="1"/>
+          <p:nvPr/>
+        </p:nvSpPr>
+        <p:spPr>
+          <a:xfrm>
+            <a:off x="8522208" y="2843784"/>
+            <a:ext cx="2962656" cy="908304"/>
           </a:xfrm>
           <a:prstGeom prst="rect">
             <a:avLst/>
@@ -8563,14 +8124,14 @@
       </p:sp>
       <p:sp>
         <p:nvSpPr>
-          <p:cNvPr id="28" name="Shape 26"/>
+          <p:cNvPr id="17" name="Shape 15"/>
           <p:cNvSpPr/>
           <p:nvPr/>
         </p:nvSpPr>
         <p:spPr>
           <a:xfrm>
-            <a:off x="9479280" y="3410712"/>
-            <a:ext cx="45720" cy="1133856"/>
+            <a:off x="5138928" y="3861816"/>
+            <a:ext cx="45720" cy="908304"/>
           </a:xfrm>
           <a:prstGeom prst="rect">
             <a:avLst/>
@@ -8583,14 +8144,14 @@
       </p:sp>
       <p:sp>
         <p:nvSpPr>
-          <p:cNvPr id="29" name="Text 27"/>
-          <p:cNvSpPr txBox="1"/>
-          <p:nvPr/>
-        </p:nvSpPr>
-        <p:spPr>
-          <a:xfrm>
-            <a:off x="9607296" y="3410712"/>
-            <a:ext cx="1877568" cy="1133856"/>
+          <p:cNvPr id="18" name="Text 16"/>
+          <p:cNvSpPr txBox="1"/>
+          <p:nvPr/>
+        </p:nvSpPr>
+        <p:spPr>
+          <a:xfrm>
+            <a:off x="5266944" y="3861816"/>
+            <a:ext cx="2962656" cy="908304"/>
           </a:xfrm>
           <a:prstGeom prst="rect">
             <a:avLst/>
@@ -8639,14 +8200,14 @@
       </p:sp>
       <p:sp>
         <p:nvSpPr>
-          <p:cNvPr id="30" name="Shape 28"/>
+          <p:cNvPr id="19" name="Shape 17"/>
           <p:cNvSpPr/>
           <p:nvPr/>
         </p:nvSpPr>
         <p:spPr>
           <a:xfrm>
-            <a:off x="5138928" y="4654296"/>
-            <a:ext cx="45720" cy="1133856"/>
+            <a:off x="8394192" y="3861816"/>
+            <a:ext cx="45720" cy="908304"/>
           </a:xfrm>
           <a:prstGeom prst="rect">
             <a:avLst/>
@@ -8659,14 +8220,14 @@
       </p:sp>
       <p:sp>
         <p:nvSpPr>
-          <p:cNvPr id="31" name="Text 29"/>
-          <p:cNvSpPr txBox="1"/>
-          <p:nvPr/>
-        </p:nvSpPr>
-        <p:spPr>
-          <a:xfrm>
-            <a:off x="5266944" y="4654296"/>
-            <a:ext cx="1877568" cy="1133856"/>
+          <p:cNvPr id="20" name="Text 18"/>
+          <p:cNvSpPr txBox="1"/>
+          <p:nvPr/>
+        </p:nvSpPr>
+        <p:spPr>
+          <a:xfrm>
+            <a:off x="8522208" y="3861816"/>
+            <a:ext cx="2962656" cy="908304"/>
           </a:xfrm>
           <a:prstGeom prst="rect">
             <a:avLst/>
@@ -8715,14 +8276,14 @@
       </p:sp>
       <p:sp>
         <p:nvSpPr>
-          <p:cNvPr id="32" name="Shape 30"/>
+          <p:cNvPr id="21" name="Shape 19"/>
           <p:cNvSpPr/>
           <p:nvPr/>
         </p:nvSpPr>
         <p:spPr>
           <a:xfrm>
-            <a:off x="7309104" y="4654296"/>
-            <a:ext cx="45720" cy="1133856"/>
+            <a:off x="5138928" y="4879848"/>
+            <a:ext cx="45720" cy="908304"/>
           </a:xfrm>
           <a:prstGeom prst="rect">
             <a:avLst/>
@@ -8735,14 +8296,14 @@
       </p:sp>
       <p:sp>
         <p:nvSpPr>
-          <p:cNvPr id="33" name="Text 31"/>
-          <p:cNvSpPr txBox="1"/>
-          <p:nvPr/>
-        </p:nvSpPr>
-        <p:spPr>
-          <a:xfrm>
-            <a:off x="7437120" y="4654296"/>
-            <a:ext cx="1877568" cy="1133856"/>
+          <p:cNvPr id="22" name="Text 20"/>
+          <p:cNvSpPr txBox="1"/>
+          <p:nvPr/>
+        </p:nvSpPr>
+        <p:spPr>
+          <a:xfrm>
+            <a:off x="5266944" y="4879848"/>
+            <a:ext cx="2962656" cy="908304"/>
           </a:xfrm>
           <a:prstGeom prst="rect">
             <a:avLst/>
@@ -8791,14 +8352,14 @@
       </p:sp>
       <p:sp>
         <p:nvSpPr>
-          <p:cNvPr id="34" name="Shape 32"/>
+          <p:cNvPr id="23" name="Shape 21"/>
           <p:cNvSpPr/>
           <p:nvPr/>
         </p:nvSpPr>
         <p:spPr>
           <a:xfrm>
-            <a:off x="9479280" y="4654296"/>
-            <a:ext cx="45720" cy="1133856"/>
+            <a:off x="8394192" y="4879848"/>
+            <a:ext cx="45720" cy="908304"/>
           </a:xfrm>
           <a:prstGeom prst="rect">
             <a:avLst/>
@@ -8811,14 +8372,14 @@
       </p:sp>
       <p:sp>
         <p:nvSpPr>
-          <p:cNvPr id="35" name="Text 33"/>
-          <p:cNvSpPr txBox="1"/>
-          <p:nvPr/>
-        </p:nvSpPr>
-        <p:spPr>
-          <a:xfrm>
-            <a:off x="9607296" y="4654296"/>
-            <a:ext cx="1877568" cy="1133856"/>
+          <p:cNvPr id="24" name="Text 22"/>
+          <p:cNvSpPr txBox="1"/>
+          <p:nvPr/>
+        </p:nvSpPr>
+        <p:spPr>
+          <a:xfrm>
+            <a:off x="8522208" y="4879848"/>
+            <a:ext cx="2962656" cy="908304"/>
           </a:xfrm>
           <a:prstGeom prst="rect">
             <a:avLst/>
@@ -8867,7 +8428,7 @@
       </p:sp>
       <p:sp>
         <p:nvSpPr>
-          <p:cNvPr id="36" name="Shape 34"/>
+          <p:cNvPr id="25" name="Shape 23"/>
           <p:cNvSpPr/>
           <p:nvPr/>
         </p:nvSpPr>
@@ -8887,7 +8448,7 @@
       </p:sp>
       <p:sp>
         <p:nvSpPr>
-          <p:cNvPr id="37" name="Text 35"/>
+          <p:cNvPr id="26" name="Text 24"/>
           <p:cNvSpPr txBox="1"/>
           <p:nvPr/>
         </p:nvSpPr>
@@ -13382,7 +12943,7 @@
                 <a:ea typeface="Inter" pitchFamily="34" charset="-122"/>
                 <a:cs typeface="Inter" pitchFamily="34" charset="-120"/>
               </a:rPr>
-              <a:t>How much of the store's fixed expenses service and parts gross pays for. P&amp;L line 254 divided by line 258.</a:t>
+              <a:t>How much of the store's fixed expenses service and parts gross pays for.</a:t>
             </a:r>
             <a:endParaRPr lang="en-US" sz="1500" dirty="0"/>
           </a:p>

</xml_diff>

<commit_message>
Gross section: What Is Fixed Ops Gross? explainer ahead of the gross charts
Co-Authored-By: Claude Opus 5.5 <noreply@anthropic.com>
Claude-Session: https://claude.ai/code/session_01Xa4nFVxuQGXmHARGph9WhS
</commit_message>
<xml_diff>
--- a/day2-deck/decks/Metric Explainers - Review.pptx
+++ b/day2-deck/decks/Metric Explainers - Review.pptx
@@ -17,9 +17,10 @@
     <p:sldId id="265" r:id="rId11"/>
     <p:sldId id="266" r:id="rId12"/>
     <p:sldId id="267" r:id="rId13"/>
+    <p:sldId id="268" r:id="rId14"/>
   </p:sldIdLst>
   <p:notesMasterIdLst>
-    <p:notesMasterId r:id="rId14"/>
+    <p:notesMasterId r:id="rId15"/>
   </p:notesMasterIdLst>
   <p:sldSz cx="12192000" cy="6858000"/>
   <p:notesSz cx="6858000" cy="12192000"/>
@@ -823,6 +824,95 @@
 </p:notes>
 </file>
 
+<file path=ppt/notesSlides/notesSlide13.xml><?xml version="1.0" encoding="utf-8"?>
+<p:notes xmlns:a="http://schemas.openxmlformats.org/drawingml/2006/main" xmlns:r="http://schemas.openxmlformats.org/officeDocument/2006/relationships" xmlns:p="http://schemas.openxmlformats.org/presentationml/2006/main">
+  <p:cSld>
+    <p:spTree>
+      <p:nvGrpSpPr>
+        <p:cNvPr id="1" name=""/>
+        <p:cNvGrpSpPr/>
+        <p:nvPr/>
+      </p:nvGrpSpPr>
+      <p:grpSpPr>
+        <a:xfrm>
+          <a:off x="0" y="0"/>
+          <a:ext cx="0" cy="0"/>
+          <a:chOff x="0" y="0"/>
+          <a:chExt cx="0" cy="0"/>
+        </a:xfrm>
+      </p:grpSpPr>
+      <p:sp>
+        <p:nvSpPr>
+          <p:cNvPr id="2" name="Slide Image Placeholder 1"/>
+          <p:cNvSpPr>
+            <a:spLocks noGrp="1" noRot="1" noChangeAspect="1"/>
+          </p:cNvSpPr>
+          <p:nvPr>
+            <p:ph type="sldImg"/>
+          </p:nvPr>
+        </p:nvSpPr>
+        <p:spPr/>
+      </p:sp>
+      <p:sp>
+        <p:nvSpPr>
+          <p:cNvPr id="3" name="Notes Placeholder 2"/>
+          <p:cNvSpPr>
+            <a:spLocks noGrp="1"/>
+          </p:cNvSpPr>
+          <p:nvPr>
+            <p:ph type="body" idx="1"/>
+          </p:nvPr>
+        </p:nvSpPr>
+        <p:spPr/>
+        <p:txBody>
+          <a:bodyPr/>
+          <a:lstStyle/>
+          <a:p>
+            <a:r>
+              <a:rPr lang="en-US" dirty="0"/>
+              <a:t>Source: Definitions match the data slides: Qlik - Closed Repair Orders (all customer-pay ROs, by close month), Profit &amp; Loss and Productivity apps, Jan-Sep 2026 vs 2025, same-store, 33 stores. Worked example: Service Manager Roundtable, Nov 15, 2024, slide 21.PLACE: Gross section, after Service Is Sales 2.0 and in front of Total Gross Profit - Fixed Ops.
+Source: Qlik Profit &amp; Loss, Total Gross Profit - Service and Total Gross Profit - Parts, same-store, INEOS excluded, GMC Prescott body shop gross excluded (as on the gross slides). Guarantees and bonuses paid off the RO post as unapplied labor, a cost-of-sale adjustment against service gross.</a:t>
+            </a:r>
+            <a:endParaRPr lang="en-US" dirty="0"/>
+          </a:p>
+        </p:txBody>
+      </p:sp>
+      <p:sp>
+        <p:nvSpPr>
+          <p:cNvPr id="4" name="Slide Number Placeholder 3"/>
+          <p:cNvSpPr>
+            <a:spLocks noGrp="1"/>
+          </p:cNvSpPr>
+          <p:nvPr>
+            <p:ph type="sldNum" sz="quarter" idx="10"/>
+          </p:nvPr>
+        </p:nvSpPr>
+        <p:spPr/>
+        <p:txBody>
+          <a:bodyPr/>
+          <a:lstStyle/>
+          <a:p>
+            <a:fld id="{F7021451-1387-4CA6-816F-3879F97B5CBC}" type="slidenum">
+              <a:rPr lang="en-US"/>
+              <a:t>13</a:t>
+            </a:fld>
+            <a:endParaRPr lang="en-US"/>
+          </a:p>
+        </p:txBody>
+      </p:sp>
+    </p:spTree>
+    <p:extLst>
+      <p:ext uri="{BB962C8B-B14F-4D97-AF65-F5344CB8AC3E}">
+        <p14:creationId xmlns:p14="http://schemas.microsoft.com/office/powerpoint/2010/main" val="1024086991"/>
+      </p:ext>
+    </p:extLst>
+  </p:cSld>
+  <p:clrMapOvr>
+    <a:masterClrMapping/>
+  </p:clrMapOvr>
+</p:notes>
+</file>
+
 <file path=ppt/notesSlides/notesSlide2.xml><?xml version="1.0" encoding="utf-8"?>
 <p:notes xmlns:a="http://schemas.openxmlformats.org/drawingml/2006/main" xmlns:r="http://schemas.openxmlformats.org/officeDocument/2006/relationships" xmlns:p="http://schemas.openxmlformats.org/presentationml/2006/main">
   <p:cSld>
@@ -6254,6 +6344,1137 @@
               <a:t>The rules keep non-tech time and data errors out of the numbers, and every store is measured the same way.</a:t>
             </a:r>
             <a:endParaRPr lang="en-US" sz="1500" dirty="0"/>
+          </a:p>
+        </p:txBody>
+      </p:sp>
+    </p:spTree>
+  </p:cSld>
+  <p:clrMapOvr>
+    <a:masterClrMapping/>
+  </p:clrMapOvr>
+</p:sld>
+</file>
+
+<file path=ppt/slides/slide13.xml><?xml version="1.0" encoding="utf-8"?>
+<p:sld xmlns:a="http://schemas.openxmlformats.org/drawingml/2006/main" xmlns:r="http://schemas.openxmlformats.org/officeDocument/2006/relationships" xmlns:p="http://schemas.openxmlformats.org/presentationml/2006/main">
+  <p:cSld name="Slide 13">
+    <p:bg>
+      <p:bgPr>
+        <a:solidFill>
+          <a:srgbClr val="EDEDED"/>
+        </a:solidFill>
+      </p:bgPr>
+    </p:bg>
+    <p:spTree>
+      <p:nvGrpSpPr>
+        <p:cNvPr id="1" name=""/>
+        <p:cNvGrpSpPr/>
+        <p:nvPr/>
+      </p:nvGrpSpPr>
+      <p:grpSpPr>
+        <a:xfrm>
+          <a:off x="0" y="0"/>
+          <a:ext cx="0" cy="0"/>
+          <a:chOff x="0" y="0"/>
+          <a:chExt cx="0" cy="0"/>
+        </a:xfrm>
+      </p:grpSpPr>
+      <p:sp>
+        <p:nvSpPr>
+          <p:cNvPr id="2" name="Shape 0"/>
+          <p:cNvSpPr/>
+          <p:nvPr/>
+        </p:nvSpPr>
+        <p:spPr>
+          <a:xfrm>
+            <a:off x="457200" y="402336"/>
+            <a:ext cx="50292" cy="192024"/>
+          </a:xfrm>
+          <a:prstGeom prst="rect">
+            <a:avLst/>
+          </a:prstGeom>
+          <a:solidFill>
+            <a:srgbClr val="2587C5"/>
+          </a:solidFill>
+          <a:ln/>
+        </p:spPr>
+      </p:sp>
+      <p:sp>
+        <p:nvSpPr>
+          <p:cNvPr id="3" name="Text 1"/>
+          <p:cNvSpPr txBox="1"/>
+          <p:nvPr/>
+        </p:nvSpPr>
+        <p:spPr>
+          <a:xfrm>
+            <a:off x="621792" y="338328"/>
+            <a:ext cx="8229600" cy="274320"/>
+          </a:xfrm>
+          <a:prstGeom prst="rect">
+            <a:avLst/>
+          </a:prstGeom>
+          <a:noFill/>
+          <a:ln/>
+        </p:spPr>
+        <p:txBody>
+          <a:bodyPr wrap="square" lIns="0" tIns="0" rIns="0" bIns="0" rtlCol="0" anchor="ctr"/>
+          <a:lstStyle/>
+          <a:p>
+            <a:pPr indent="0" marL="0">
+              <a:buNone/>
+            </a:pPr>
+            <a:r>
+              <a:rPr lang="en-US" sz="1400" b="1" spc="110" kern="0" dirty="0">
+                <a:solidFill>
+                  <a:srgbClr val="595959"/>
+                </a:solidFill>
+                <a:latin typeface="Inter" pitchFamily="34" charset="0"/>
+                <a:ea typeface="Inter" pitchFamily="34" charset="-122"/>
+                <a:cs typeface="Inter" pitchFamily="34" charset="-120"/>
+              </a:rPr>
+              <a:t>FIXED OPS GROSS</a:t>
+            </a:r>
+            <a:endParaRPr lang="en-US" sz="1400" dirty="0"/>
+          </a:p>
+        </p:txBody>
+      </p:sp>
+      <p:sp>
+        <p:nvSpPr>
+          <p:cNvPr id="4" name="Text 2"/>
+          <p:cNvSpPr txBox="1"/>
+          <p:nvPr/>
+        </p:nvSpPr>
+        <p:spPr>
+          <a:xfrm>
+            <a:off x="457200" y="640080"/>
+            <a:ext cx="11338560" cy="502920"/>
+          </a:xfrm>
+          <a:prstGeom prst="rect">
+            <a:avLst/>
+          </a:prstGeom>
+          <a:noFill/>
+          <a:ln/>
+        </p:spPr>
+        <p:txBody>
+          <a:bodyPr wrap="square" lIns="0" tIns="0" rIns="0" bIns="0" rtlCol="0" anchor="ctr"/>
+          <a:lstStyle/>
+          <a:p>
+            <a:pPr indent="0" marL="0">
+              <a:buNone/>
+            </a:pPr>
+            <a:r>
+              <a:rPr lang="en-US" sz="2800" dirty="0">
+                <a:solidFill>
+                  <a:srgbClr val="1A1A1A"/>
+                </a:solidFill>
+                <a:latin typeface="Inter" pitchFamily="34" charset="0"/>
+                <a:ea typeface="Inter" pitchFamily="34" charset="-122"/>
+                <a:cs typeface="Inter" pitchFamily="34" charset="-120"/>
+              </a:rPr>
+              <a:t>What Is Fixed Ops Gross?</a:t>
+            </a:r>
+            <a:endParaRPr lang="en-US" sz="2800" dirty="0"/>
+          </a:p>
+        </p:txBody>
+      </p:sp>
+      <p:sp>
+        <p:nvSpPr>
+          <p:cNvPr id="5" name="Shape 3"/>
+          <p:cNvSpPr/>
+          <p:nvPr/>
+        </p:nvSpPr>
+        <p:spPr>
+          <a:xfrm>
+            <a:off x="457200" y="1207008"/>
+            <a:ext cx="11274552" cy="1024128"/>
+          </a:xfrm>
+          <a:prstGeom prst="rect">
+            <a:avLst/>
+          </a:prstGeom>
+          <a:solidFill>
+            <a:srgbClr val="EDF4FA"/>
+          </a:solidFill>
+          <a:ln/>
+        </p:spPr>
+      </p:sp>
+      <p:sp>
+        <p:nvSpPr>
+          <p:cNvPr id="6" name="Text 4"/>
+          <p:cNvSpPr txBox="1"/>
+          <p:nvPr/>
+        </p:nvSpPr>
+        <p:spPr>
+          <a:xfrm>
+            <a:off x="685800" y="1243584"/>
+            <a:ext cx="10835640" cy="566928"/>
+          </a:xfrm>
+          <a:prstGeom prst="rect">
+            <a:avLst/>
+          </a:prstGeom>
+          <a:noFill/>
+          <a:ln/>
+        </p:spPr>
+        <p:txBody>
+          <a:bodyPr wrap="square" lIns="0" tIns="0" rIns="0" bIns="0" rtlCol="0" anchor="ctr">
+            <a:normAutofit/>
+          </a:bodyPr>
+          <a:lstStyle/>
+          <a:p>
+            <a:pPr indent="0" marL="0">
+              <a:buNone/>
+            </a:pPr>
+            <a:r>
+              <a:rPr lang="en-US" sz="2400" b="1" dirty="0">
+                <a:solidFill>
+                  <a:srgbClr val="0B2C4A"/>
+                </a:solidFill>
+                <a:latin typeface="Inter" pitchFamily="34" charset="0"/>
+                <a:ea typeface="Inter" pitchFamily="34" charset="-122"/>
+                <a:cs typeface="Inter" pitchFamily="34" charset="-120"/>
+              </a:rPr>
+              <a:t>Fixed ops gross  </a:t>
+            </a:r>
+            <a:pPr indent="0" marL="0">
+              <a:buNone/>
+            </a:pPr>
+            <a:r>
+              <a:rPr lang="en-US" sz="2400" b="1" dirty="0">
+                <a:solidFill>
+                  <a:srgbClr val="2587C5"/>
+                </a:solidFill>
+                <a:latin typeface="Inter" pitchFamily="34" charset="0"/>
+                <a:ea typeface="Inter" pitchFamily="34" charset="-122"/>
+                <a:cs typeface="Inter" pitchFamily="34" charset="-120"/>
+              </a:rPr>
+              <a:t>=  </a:t>
+            </a:r>
+            <a:pPr indent="0" marL="0">
+              <a:buNone/>
+            </a:pPr>
+            <a:r>
+              <a:rPr lang="en-US" sz="2400" b="1" dirty="0">
+                <a:solidFill>
+                  <a:srgbClr val="0B2C4A"/>
+                </a:solidFill>
+                <a:latin typeface="Inter" pitchFamily="34" charset="0"/>
+                <a:ea typeface="Inter" pitchFamily="34" charset="-122"/>
+                <a:cs typeface="Inter" pitchFamily="34" charset="-120"/>
+              </a:rPr>
+              <a:t>service gross  </a:t>
+            </a:r>
+            <a:pPr indent="0" marL="0">
+              <a:buNone/>
+            </a:pPr>
+            <a:r>
+              <a:rPr lang="en-US" sz="2400" b="1" dirty="0">
+                <a:solidFill>
+                  <a:srgbClr val="2587C5"/>
+                </a:solidFill>
+                <a:latin typeface="Inter" pitchFamily="34" charset="0"/>
+                <a:ea typeface="Inter" pitchFamily="34" charset="-122"/>
+                <a:cs typeface="Inter" pitchFamily="34" charset="-120"/>
+              </a:rPr>
+              <a:t>+  </a:t>
+            </a:r>
+            <a:pPr indent="0" marL="0">
+              <a:buNone/>
+            </a:pPr>
+            <a:r>
+              <a:rPr lang="en-US" sz="2400" b="1" dirty="0">
+                <a:solidFill>
+                  <a:srgbClr val="0B2C4A"/>
+                </a:solidFill>
+                <a:latin typeface="Inter" pitchFamily="34" charset="0"/>
+                <a:ea typeface="Inter" pitchFamily="34" charset="-122"/>
+                <a:cs typeface="Inter" pitchFamily="34" charset="-120"/>
+              </a:rPr>
+              <a:t>parts gross</a:t>
+            </a:r>
+            <a:endParaRPr lang="en-US" sz="2400" dirty="0"/>
+          </a:p>
+        </p:txBody>
+      </p:sp>
+      <p:sp>
+        <p:nvSpPr>
+          <p:cNvPr id="7" name="Text 5"/>
+          <p:cNvSpPr txBox="1"/>
+          <p:nvPr/>
+        </p:nvSpPr>
+        <p:spPr>
+          <a:xfrm>
+            <a:off x="685800" y="1783080"/>
+            <a:ext cx="10835640" cy="420624"/>
+          </a:xfrm>
+          <a:prstGeom prst="rect">
+            <a:avLst/>
+          </a:prstGeom>
+          <a:noFill/>
+          <a:ln/>
+        </p:spPr>
+        <p:txBody>
+          <a:bodyPr wrap="square" lIns="0" tIns="0" rIns="0" bIns="0" rtlCol="0" anchor="ctr"/>
+          <a:lstStyle/>
+          <a:p>
+            <a:pPr indent="0" marL="0">
+              <a:buNone/>
+            </a:pPr>
+            <a:r>
+              <a:rPr lang="en-US" sz="1400" dirty="0">
+                <a:solidFill>
+                  <a:srgbClr val="595959"/>
+                </a:solidFill>
+                <a:latin typeface="Inter" pitchFamily="34" charset="0"/>
+                <a:ea typeface="Inter" pitchFamily="34" charset="-122"/>
+                <a:cs typeface="Inter" pitchFamily="34" charset="-120"/>
+              </a:rPr>
+              <a:t>What each department keeps after the cost of what it sold: labor sale less technician cost, parts sale less parts cost.</a:t>
+            </a:r>
+            <a:endParaRPr lang="en-US" sz="1400" dirty="0"/>
+          </a:p>
+        </p:txBody>
+      </p:sp>
+      <p:sp>
+        <p:nvSpPr>
+          <p:cNvPr id="8" name="Text 6"/>
+          <p:cNvSpPr txBox="1"/>
+          <p:nvPr/>
+        </p:nvSpPr>
+        <p:spPr>
+          <a:xfrm>
+            <a:off x="457200" y="2340864"/>
+            <a:ext cx="1828800" cy="457200"/>
+          </a:xfrm>
+          <a:prstGeom prst="rect">
+            <a:avLst/>
+          </a:prstGeom>
+          <a:noFill/>
+          <a:ln/>
+        </p:spPr>
+        <p:txBody>
+          <a:bodyPr wrap="square" lIns="0" tIns="0" rIns="0" bIns="0" rtlCol="0" anchor="ctr"/>
+          <a:lstStyle/>
+          <a:p>
+            <a:pPr indent="0" marL="0">
+              <a:buNone/>
+            </a:pPr>
+            <a:r>
+              <a:rPr lang="en-US" sz="1400" b="1" spc="80" kern="0" dirty="0">
+                <a:solidFill>
+                  <a:srgbClr val="595959"/>
+                </a:solidFill>
+                <a:latin typeface="Inter" pitchFamily="34" charset="0"/>
+                <a:ea typeface="Inter" pitchFamily="34" charset="-122"/>
+                <a:cs typeface="Inter" pitchFamily="34" charset="-120"/>
+              </a:rPr>
+              <a:t>JAN–SEP 2026</a:t>
+            </a:r>
+            <a:endParaRPr lang="en-US" sz="1400" dirty="0"/>
+          </a:p>
+        </p:txBody>
+      </p:sp>
+      <p:sp>
+        <p:nvSpPr>
+          <p:cNvPr id="9" name="Shape 7"/>
+          <p:cNvSpPr/>
+          <p:nvPr/>
+        </p:nvSpPr>
+        <p:spPr>
+          <a:xfrm>
+            <a:off x="2286000" y="2340864"/>
+            <a:ext cx="3075432" cy="457200"/>
+          </a:xfrm>
+          <a:prstGeom prst="rect">
+            <a:avLst/>
+          </a:prstGeom>
+          <a:solidFill>
+            <a:srgbClr val="FFFFFF"/>
+          </a:solidFill>
+          <a:ln w="9525">
+            <a:solidFill>
+              <a:srgbClr val="D9D9D9"/>
+            </a:solidFill>
+            <a:prstDash val="solid"/>
+          </a:ln>
+        </p:spPr>
+      </p:sp>
+      <p:sp>
+        <p:nvSpPr>
+          <p:cNvPr id="10" name="Text 8"/>
+          <p:cNvSpPr txBox="1"/>
+          <p:nvPr/>
+        </p:nvSpPr>
+        <p:spPr>
+          <a:xfrm>
+            <a:off x="2359152" y="2340864"/>
+            <a:ext cx="2929128" cy="457200"/>
+          </a:xfrm>
+          <a:prstGeom prst="rect">
+            <a:avLst/>
+          </a:prstGeom>
+          <a:noFill/>
+          <a:ln/>
+        </p:spPr>
+        <p:txBody>
+          <a:bodyPr wrap="square" lIns="0" tIns="0" rIns="0" bIns="0" rtlCol="0" anchor="ctr">
+            <a:normAutofit/>
+          </a:bodyPr>
+          <a:lstStyle/>
+          <a:p>
+            <a:pPr algn="ctr" indent="0" marL="0">
+              <a:buNone/>
+            </a:pPr>
+            <a:r>
+              <a:rPr lang="en-US" sz="1400" dirty="0">
+                <a:solidFill>
+                  <a:srgbClr val="1A1A1A"/>
+                </a:solidFill>
+                <a:latin typeface="Inter" pitchFamily="34" charset="0"/>
+                <a:ea typeface="Inter" pitchFamily="34" charset="-122"/>
+                <a:cs typeface="Inter" pitchFamily="34" charset="-120"/>
+              </a:rPr>
+              <a:t>Service  </a:t>
+            </a:r>
+            <a:pPr algn="ctr" indent="0" marL="0">
+              <a:buNone/>
+            </a:pPr>
+            <a:r>
+              <a:rPr lang="en-US" sz="1400" b="1" dirty="0">
+                <a:solidFill>
+                  <a:srgbClr val="0B2C4A"/>
+                </a:solidFill>
+                <a:latin typeface="Inter" pitchFamily="34" charset="0"/>
+                <a:ea typeface="Inter" pitchFamily="34" charset="-122"/>
+                <a:cs typeface="Inter" pitchFamily="34" charset="-120"/>
+              </a:rPr>
+              <a:t>$126.87M</a:t>
+            </a:r>
+            <a:endParaRPr lang="en-US" sz="1400" dirty="0"/>
+          </a:p>
+        </p:txBody>
+      </p:sp>
+      <p:sp>
+        <p:nvSpPr>
+          <p:cNvPr id="11" name="Shape 9"/>
+          <p:cNvSpPr/>
+          <p:nvPr/>
+        </p:nvSpPr>
+        <p:spPr>
+          <a:xfrm>
+            <a:off x="5471160" y="2340864"/>
+            <a:ext cx="3075432" cy="457200"/>
+          </a:xfrm>
+          <a:prstGeom prst="rect">
+            <a:avLst/>
+          </a:prstGeom>
+          <a:solidFill>
+            <a:srgbClr val="FFFFFF"/>
+          </a:solidFill>
+          <a:ln w="9525">
+            <a:solidFill>
+              <a:srgbClr val="D9D9D9"/>
+            </a:solidFill>
+            <a:prstDash val="solid"/>
+          </a:ln>
+        </p:spPr>
+      </p:sp>
+      <p:sp>
+        <p:nvSpPr>
+          <p:cNvPr id="12" name="Text 10"/>
+          <p:cNvSpPr txBox="1"/>
+          <p:nvPr/>
+        </p:nvSpPr>
+        <p:spPr>
+          <a:xfrm>
+            <a:off x="5544312" y="2340864"/>
+            <a:ext cx="2929128" cy="457200"/>
+          </a:xfrm>
+          <a:prstGeom prst="rect">
+            <a:avLst/>
+          </a:prstGeom>
+          <a:noFill/>
+          <a:ln/>
+        </p:spPr>
+        <p:txBody>
+          <a:bodyPr wrap="square" lIns="0" tIns="0" rIns="0" bIns="0" rtlCol="0" anchor="ctr">
+            <a:normAutofit/>
+          </a:bodyPr>
+          <a:lstStyle/>
+          <a:p>
+            <a:pPr algn="ctr" indent="0" marL="0">
+              <a:buNone/>
+            </a:pPr>
+            <a:r>
+              <a:rPr lang="en-US" sz="1400" dirty="0">
+                <a:solidFill>
+                  <a:srgbClr val="1A1A1A"/>
+                </a:solidFill>
+                <a:latin typeface="Inter" pitchFamily="34" charset="0"/>
+                <a:ea typeface="Inter" pitchFamily="34" charset="-122"/>
+                <a:cs typeface="Inter" pitchFamily="34" charset="-120"/>
+              </a:rPr>
+              <a:t>Parts  </a:t>
+            </a:r>
+            <a:pPr algn="ctr" indent="0" marL="0">
+              <a:buNone/>
+            </a:pPr>
+            <a:r>
+              <a:rPr lang="en-US" sz="1400" b="1" dirty="0">
+                <a:solidFill>
+                  <a:srgbClr val="0B2C4A"/>
+                </a:solidFill>
+                <a:latin typeface="Inter" pitchFamily="34" charset="0"/>
+                <a:ea typeface="Inter" pitchFamily="34" charset="-122"/>
+                <a:cs typeface="Inter" pitchFamily="34" charset="-120"/>
+              </a:rPr>
+              <a:t>$61.93M</a:t>
+            </a:r>
+            <a:endParaRPr lang="en-US" sz="1400" dirty="0"/>
+          </a:p>
+        </p:txBody>
+      </p:sp>
+      <p:sp>
+        <p:nvSpPr>
+          <p:cNvPr id="13" name="Shape 11"/>
+          <p:cNvSpPr/>
+          <p:nvPr/>
+        </p:nvSpPr>
+        <p:spPr>
+          <a:xfrm>
+            <a:off x="8656320" y="2340864"/>
+            <a:ext cx="3075432" cy="457200"/>
+          </a:xfrm>
+          <a:prstGeom prst="rect">
+            <a:avLst/>
+          </a:prstGeom>
+          <a:solidFill>
+            <a:srgbClr val="FFFFFF"/>
+          </a:solidFill>
+          <a:ln w="9525">
+            <a:solidFill>
+              <a:srgbClr val="D9D9D9"/>
+            </a:solidFill>
+            <a:prstDash val="solid"/>
+          </a:ln>
+        </p:spPr>
+      </p:sp>
+      <p:sp>
+        <p:nvSpPr>
+          <p:cNvPr id="14" name="Text 12"/>
+          <p:cNvSpPr txBox="1"/>
+          <p:nvPr/>
+        </p:nvSpPr>
+        <p:spPr>
+          <a:xfrm>
+            <a:off x="8729472" y="2340864"/>
+            <a:ext cx="2929128" cy="457200"/>
+          </a:xfrm>
+          <a:prstGeom prst="rect">
+            <a:avLst/>
+          </a:prstGeom>
+          <a:noFill/>
+          <a:ln/>
+        </p:spPr>
+        <p:txBody>
+          <a:bodyPr wrap="square" lIns="0" tIns="0" rIns="0" bIns="0" rtlCol="0" anchor="ctr">
+            <a:normAutofit/>
+          </a:bodyPr>
+          <a:lstStyle/>
+          <a:p>
+            <a:pPr algn="ctr" indent="0" marL="0">
+              <a:buNone/>
+            </a:pPr>
+            <a:r>
+              <a:rPr lang="en-US" sz="1400" dirty="0">
+                <a:solidFill>
+                  <a:srgbClr val="1A1A1A"/>
+                </a:solidFill>
+                <a:latin typeface="Inter" pitchFamily="34" charset="0"/>
+                <a:ea typeface="Inter" pitchFamily="34" charset="-122"/>
+                <a:cs typeface="Inter" pitchFamily="34" charset="-120"/>
+              </a:rPr>
+              <a:t>Fixed ops  </a:t>
+            </a:r>
+            <a:pPr algn="ctr" indent="0" marL="0">
+              <a:buNone/>
+            </a:pPr>
+            <a:r>
+              <a:rPr lang="en-US" sz="1400" b="1" dirty="0">
+                <a:solidFill>
+                  <a:srgbClr val="0B2C4A"/>
+                </a:solidFill>
+                <a:latin typeface="Inter" pitchFamily="34" charset="0"/>
+                <a:ea typeface="Inter" pitchFamily="34" charset="-122"/>
+                <a:cs typeface="Inter" pitchFamily="34" charset="-120"/>
+              </a:rPr>
+              <a:t>$188.80M</a:t>
+            </a:r>
+            <a:endParaRPr lang="en-US" sz="1400" dirty="0"/>
+          </a:p>
+        </p:txBody>
+      </p:sp>
+      <p:sp>
+        <p:nvSpPr>
+          <p:cNvPr id="15" name="Shape 13"/>
+          <p:cNvSpPr/>
+          <p:nvPr/>
+        </p:nvSpPr>
+        <p:spPr>
+          <a:xfrm>
+            <a:off x="457200" y="2907792"/>
+            <a:ext cx="4343400" cy="3081528"/>
+          </a:xfrm>
+          <a:prstGeom prst="rect">
+            <a:avLst/>
+          </a:prstGeom>
+          <a:solidFill>
+            <a:srgbClr val="FFFFFF"/>
+          </a:solidFill>
+          <a:ln/>
+        </p:spPr>
+      </p:sp>
+      <p:sp>
+        <p:nvSpPr>
+          <p:cNvPr id="16" name="Shape 14"/>
+          <p:cNvSpPr/>
+          <p:nvPr/>
+        </p:nvSpPr>
+        <p:spPr>
+          <a:xfrm>
+            <a:off x="4937760" y="2907792"/>
+            <a:ext cx="6793992" cy="3081528"/>
+          </a:xfrm>
+          <a:prstGeom prst="rect">
+            <a:avLst/>
+          </a:prstGeom>
+          <a:solidFill>
+            <a:srgbClr val="FFFFFF"/>
+          </a:solidFill>
+          <a:ln/>
+        </p:spPr>
+      </p:sp>
+      <p:sp>
+        <p:nvSpPr>
+          <p:cNvPr id="17" name="Text 15"/>
+          <p:cNvSpPr txBox="1"/>
+          <p:nvPr/>
+        </p:nvSpPr>
+        <p:spPr>
+          <a:xfrm>
+            <a:off x="658368" y="3035808"/>
+            <a:ext cx="3931920" cy="292608"/>
+          </a:xfrm>
+          <a:prstGeom prst="rect">
+            <a:avLst/>
+          </a:prstGeom>
+          <a:noFill/>
+          <a:ln/>
+        </p:spPr>
+        <p:txBody>
+          <a:bodyPr wrap="square" lIns="0" tIns="0" rIns="0" bIns="0" rtlCol="0" anchor="ctr"/>
+          <a:lstStyle/>
+          <a:p>
+            <a:pPr indent="0" marL="0">
+              <a:buNone/>
+            </a:pPr>
+            <a:r>
+              <a:rPr lang="en-US" sz="1400" b="1" spc="100" kern="0" dirty="0">
+                <a:solidFill>
+                  <a:srgbClr val="0B2C4A"/>
+                </a:solidFill>
+                <a:latin typeface="Inter" pitchFamily="34" charset="0"/>
+                <a:ea typeface="Inter" pitchFamily="34" charset="-122"/>
+                <a:cs typeface="Inter" pitchFamily="34" charset="-120"/>
+              </a:rPr>
+              <a:t>HOW EACH IS BUILT</a:t>
+            </a:r>
+            <a:endParaRPr lang="en-US" sz="1400" dirty="0"/>
+          </a:p>
+        </p:txBody>
+      </p:sp>
+      <p:sp>
+        <p:nvSpPr>
+          <p:cNvPr id="18" name="Text 16"/>
+          <p:cNvSpPr txBox="1"/>
+          <p:nvPr/>
+        </p:nvSpPr>
+        <p:spPr>
+          <a:xfrm>
+            <a:off x="5138928" y="3035808"/>
+            <a:ext cx="6400800" cy="292608"/>
+          </a:xfrm>
+          <a:prstGeom prst="rect">
+            <a:avLst/>
+          </a:prstGeom>
+          <a:noFill/>
+          <a:ln/>
+        </p:spPr>
+        <p:txBody>
+          <a:bodyPr wrap="square" lIns="0" tIns="0" rIns="0" bIns="0" rtlCol="0" anchor="ctr"/>
+          <a:lstStyle/>
+          <a:p>
+            <a:pPr indent="0" marL="0">
+              <a:buNone/>
+            </a:pPr>
+            <a:r>
+              <a:rPr lang="en-US" sz="1400" b="1" spc="100" kern="0" dirty="0">
+                <a:solidFill>
+                  <a:srgbClr val="0B2C4A"/>
+                </a:solidFill>
+                <a:latin typeface="Inter" pitchFamily="34" charset="0"/>
+                <a:ea typeface="Inter" pitchFamily="34" charset="-122"/>
+                <a:cs typeface="Inter" pitchFamily="34" charset="-120"/>
+              </a:rPr>
+              <a:t>WHAT MOVES IT</a:t>
+            </a:r>
+            <a:endParaRPr lang="en-US" sz="1400" dirty="0"/>
+          </a:p>
+        </p:txBody>
+      </p:sp>
+      <p:sp>
+        <p:nvSpPr>
+          <p:cNvPr id="19" name="Text 17"/>
+          <p:cNvSpPr txBox="1"/>
+          <p:nvPr/>
+        </p:nvSpPr>
+        <p:spPr>
+          <a:xfrm>
+            <a:off x="658368" y="3410712"/>
+            <a:ext cx="3977640" cy="2441448"/>
+          </a:xfrm>
+          <a:prstGeom prst="rect">
+            <a:avLst/>
+          </a:prstGeom>
+          <a:noFill/>
+          <a:ln/>
+        </p:spPr>
+        <p:txBody>
+          <a:bodyPr wrap="square" lIns="0" tIns="0" rIns="0" bIns="0" rtlCol="0" anchor="t"/>
+          <a:lstStyle/>
+          <a:p>
+            <a:pPr marL="203200" indent="-203200">
+              <a:spcAft>
+                <a:spcPts val="600"/>
+              </a:spcAft>
+              <a:buSzPct val="100000"/>
+              <a:buChar char="•"/>
+            </a:pPr>
+            <a:r>
+              <a:rPr lang="en-US" sz="1500" dirty="0">
+                <a:solidFill>
+                  <a:srgbClr val="1A1A1A"/>
+                </a:solidFill>
+                <a:latin typeface="Inter" pitchFamily="34" charset="0"/>
+                <a:ea typeface="Inter" pitchFamily="34" charset="-122"/>
+                <a:cs typeface="Inter" pitchFamily="34" charset="-120"/>
+              </a:rPr>
+              <a:t>Service earns only on labor hours sold: the labor sale less what the technician is paid for the job.</a:t>
+            </a:r>
+            <a:endParaRPr lang="en-US" sz="1500" dirty="0"/>
+          </a:p>
+          <a:p>
+            <a:pPr marL="203200" indent="-203200">
+              <a:spcAft>
+                <a:spcPts val="600"/>
+              </a:spcAft>
+              <a:buSzPct val="100000"/>
+              <a:buChar char="•"/>
+            </a:pPr>
+            <a:r>
+              <a:rPr lang="en-US" sz="1500" dirty="0">
+                <a:solidFill>
+                  <a:srgbClr val="1A1A1A"/>
+                </a:solidFill>
+                <a:latin typeface="Inter" pitchFamily="34" charset="0"/>
+                <a:ea typeface="Inter" pitchFamily="34" charset="-122"/>
+                <a:cs typeface="Inter" pitchFamily="34" charset="-120"/>
+              </a:rPr>
+              <a:t>Parts sold on a service RO are parts gross, not service gross, even when an advisor sells them.</a:t>
+            </a:r>
+            <a:endParaRPr lang="en-US" sz="1500" dirty="0"/>
+          </a:p>
+          <a:p>
+            <a:pPr marL="203200" indent="-203200">
+              <a:spcAft>
+                <a:spcPts val="600"/>
+              </a:spcAft>
+              <a:buSzPct val="100000"/>
+              <a:buChar char="•"/>
+            </a:pPr>
+            <a:r>
+              <a:rPr lang="en-US" sz="1500" dirty="0">
+                <a:solidFill>
+                  <a:srgbClr val="1A1A1A"/>
+                </a:solidFill>
+                <a:latin typeface="Inter" pitchFamily="34" charset="0"/>
+                <a:ea typeface="Inter" pitchFamily="34" charset="-122"/>
+                <a:cs typeface="Inter" pitchFamily="34" charset="-120"/>
+              </a:rPr>
+              <a:t>Both include customer pay, warranty and internal work.</a:t>
+            </a:r>
+            <a:endParaRPr lang="en-US" sz="1500" dirty="0"/>
+          </a:p>
+        </p:txBody>
+      </p:sp>
+      <p:sp>
+        <p:nvSpPr>
+          <p:cNvPr id="20" name="Shape 18"/>
+          <p:cNvSpPr/>
+          <p:nvPr/>
+        </p:nvSpPr>
+        <p:spPr>
+          <a:xfrm>
+            <a:off x="5138928" y="3410712"/>
+            <a:ext cx="45720" cy="1133856"/>
+          </a:xfrm>
+          <a:prstGeom prst="rect">
+            <a:avLst/>
+          </a:prstGeom>
+          <a:solidFill>
+            <a:srgbClr val="2587C5"/>
+          </a:solidFill>
+          <a:ln/>
+        </p:spPr>
+      </p:sp>
+      <p:sp>
+        <p:nvSpPr>
+          <p:cNvPr id="21" name="Text 19"/>
+          <p:cNvSpPr txBox="1"/>
+          <p:nvPr/>
+        </p:nvSpPr>
+        <p:spPr>
+          <a:xfrm>
+            <a:off x="5266944" y="3410712"/>
+            <a:ext cx="2962656" cy="1133856"/>
+          </a:xfrm>
+          <a:prstGeom prst="rect">
+            <a:avLst/>
+          </a:prstGeom>
+          <a:noFill/>
+          <a:ln/>
+        </p:spPr>
+        <p:txBody>
+          <a:bodyPr wrap="square" lIns="0" tIns="0" rIns="0" bIns="0" rtlCol="0" anchor="t"/>
+          <a:lstStyle/>
+          <a:p>
+            <a:pPr indent="0" marL="0">
+              <a:buNone/>
+            </a:pPr>
+            <a:r>
+              <a:rPr lang="en-US" sz="1400" b="1" dirty="0">
+                <a:solidFill>
+                  <a:srgbClr val="1A1A1A"/>
+                </a:solidFill>
+                <a:latin typeface="Inter" pitchFamily="34" charset="0"/>
+                <a:ea typeface="Inter" pitchFamily="34" charset="-122"/>
+                <a:cs typeface="Inter" pitchFamily="34" charset="-120"/>
+              </a:rPr>
+              <a:t>Service: labor sale</a:t>
+            </a:r>
+            <a:endParaRPr lang="en-US" sz="1400" dirty="0"/>
+          </a:p>
+          <a:p>
+            <a:pPr indent="0" marL="0">
+              <a:buNone/>
+            </a:pPr>
+            <a:r>
+              <a:rPr lang="en-US" sz="1400" dirty="0">
+                <a:solidFill>
+                  <a:srgbClr val="595959"/>
+                </a:solidFill>
+                <a:latin typeface="Inter" pitchFamily="34" charset="0"/>
+                <a:ea typeface="Inter" pitchFamily="34" charset="-122"/>
+                <a:cs typeface="Inter" pitchFamily="34" charset="-120"/>
+              </a:rPr>
+              <a:t>Hours sold times the rate collected (ELR)</a:t>
+            </a:r>
+            <a:endParaRPr lang="en-US" sz="1400" dirty="0"/>
+          </a:p>
+        </p:txBody>
+      </p:sp>
+      <p:sp>
+        <p:nvSpPr>
+          <p:cNvPr id="22" name="Shape 20"/>
+          <p:cNvSpPr/>
+          <p:nvPr/>
+        </p:nvSpPr>
+        <p:spPr>
+          <a:xfrm>
+            <a:off x="8394192" y="3410712"/>
+            <a:ext cx="45720" cy="1133856"/>
+          </a:xfrm>
+          <a:prstGeom prst="rect">
+            <a:avLst/>
+          </a:prstGeom>
+          <a:solidFill>
+            <a:srgbClr val="2587C5"/>
+          </a:solidFill>
+          <a:ln/>
+        </p:spPr>
+      </p:sp>
+      <p:sp>
+        <p:nvSpPr>
+          <p:cNvPr id="23" name="Text 21"/>
+          <p:cNvSpPr txBox="1"/>
+          <p:nvPr/>
+        </p:nvSpPr>
+        <p:spPr>
+          <a:xfrm>
+            <a:off x="8522208" y="3410712"/>
+            <a:ext cx="2962656" cy="1133856"/>
+          </a:xfrm>
+          <a:prstGeom prst="rect">
+            <a:avLst/>
+          </a:prstGeom>
+          <a:noFill/>
+          <a:ln/>
+        </p:spPr>
+        <p:txBody>
+          <a:bodyPr wrap="square" lIns="0" tIns="0" rIns="0" bIns="0" rtlCol="0" anchor="t"/>
+          <a:lstStyle/>
+          <a:p>
+            <a:pPr indent="0" marL="0">
+              <a:buNone/>
+            </a:pPr>
+            <a:r>
+              <a:rPr lang="en-US" sz="1400" b="1" dirty="0">
+                <a:solidFill>
+                  <a:srgbClr val="1A1A1A"/>
+                </a:solidFill>
+                <a:latin typeface="Inter" pitchFamily="34" charset="0"/>
+                <a:ea typeface="Inter" pitchFamily="34" charset="-122"/>
+                <a:cs typeface="Inter" pitchFamily="34" charset="-120"/>
+              </a:rPr>
+              <a:t>Service: technician cost</a:t>
+            </a:r>
+            <a:endParaRPr lang="en-US" sz="1400" dirty="0"/>
+          </a:p>
+          <a:p>
+            <a:pPr indent="0" marL="0">
+              <a:buNone/>
+            </a:pPr>
+            <a:r>
+              <a:rPr lang="en-US" sz="1400" dirty="0">
+                <a:solidFill>
+                  <a:srgbClr val="595959"/>
+                </a:solidFill>
+                <a:latin typeface="Inter" pitchFamily="34" charset="0"/>
+                <a:ea typeface="Inter" pitchFamily="34" charset="-122"/>
+                <a:cs typeface="Inter" pitchFamily="34" charset="-120"/>
+              </a:rPr>
+              <a:t>Pay on the RO; guarantees and bonuses paid off the RO come out of gross too</a:t>
+            </a:r>
+            <a:endParaRPr lang="en-US" sz="1400" dirty="0"/>
+          </a:p>
+        </p:txBody>
+      </p:sp>
+      <p:sp>
+        <p:nvSpPr>
+          <p:cNvPr id="24" name="Shape 22"/>
+          <p:cNvSpPr/>
+          <p:nvPr/>
+        </p:nvSpPr>
+        <p:spPr>
+          <a:xfrm>
+            <a:off x="5138928" y="4654296"/>
+            <a:ext cx="45720" cy="1133856"/>
+          </a:xfrm>
+          <a:prstGeom prst="rect">
+            <a:avLst/>
+          </a:prstGeom>
+          <a:solidFill>
+            <a:srgbClr val="2587C5"/>
+          </a:solidFill>
+          <a:ln/>
+        </p:spPr>
+      </p:sp>
+      <p:sp>
+        <p:nvSpPr>
+          <p:cNvPr id="25" name="Text 23"/>
+          <p:cNvSpPr txBox="1"/>
+          <p:nvPr/>
+        </p:nvSpPr>
+        <p:spPr>
+          <a:xfrm>
+            <a:off x="5266944" y="4654296"/>
+            <a:ext cx="2962656" cy="1133856"/>
+          </a:xfrm>
+          <a:prstGeom prst="rect">
+            <a:avLst/>
+          </a:prstGeom>
+          <a:noFill/>
+          <a:ln/>
+        </p:spPr>
+        <p:txBody>
+          <a:bodyPr wrap="square" lIns="0" tIns="0" rIns="0" bIns="0" rtlCol="0" anchor="t"/>
+          <a:lstStyle/>
+          <a:p>
+            <a:pPr indent="0" marL="0">
+              <a:buNone/>
+            </a:pPr>
+            <a:r>
+              <a:rPr lang="en-US" sz="1400" b="1" dirty="0">
+                <a:solidFill>
+                  <a:srgbClr val="1A1A1A"/>
+                </a:solidFill>
+                <a:latin typeface="Inter" pitchFamily="34" charset="0"/>
+                <a:ea typeface="Inter" pitchFamily="34" charset="-122"/>
+                <a:cs typeface="Inter" pitchFamily="34" charset="-120"/>
+              </a:rPr>
+              <a:t>Parts: on the RO</a:t>
+            </a:r>
+            <a:endParaRPr lang="en-US" sz="1400" dirty="0"/>
+          </a:p>
+          <a:p>
+            <a:pPr indent="0" marL="0">
+              <a:buNone/>
+            </a:pPr>
+            <a:r>
+              <a:rPr lang="en-US" sz="1400" dirty="0">
+                <a:solidFill>
+                  <a:srgbClr val="595959"/>
+                </a:solidFill>
+                <a:latin typeface="Inter" pitchFamily="34" charset="0"/>
+                <a:ea typeface="Inter" pitchFamily="34" charset="-122"/>
+                <a:cs typeface="Inter" pitchFamily="34" charset="-120"/>
+              </a:rPr>
+              <a:t>Customer pay, warranty and internal parts sold through service</a:t>
+            </a:r>
+            <a:endParaRPr lang="en-US" sz="1400" dirty="0"/>
+          </a:p>
+        </p:txBody>
+      </p:sp>
+      <p:sp>
+        <p:nvSpPr>
+          <p:cNvPr id="26" name="Shape 24"/>
+          <p:cNvSpPr/>
+          <p:nvPr/>
+        </p:nvSpPr>
+        <p:spPr>
+          <a:xfrm>
+            <a:off x="8394192" y="4654296"/>
+            <a:ext cx="45720" cy="1133856"/>
+          </a:xfrm>
+          <a:prstGeom prst="rect">
+            <a:avLst/>
+          </a:prstGeom>
+          <a:solidFill>
+            <a:srgbClr val="2587C5"/>
+          </a:solidFill>
+          <a:ln/>
+        </p:spPr>
+      </p:sp>
+      <p:sp>
+        <p:nvSpPr>
+          <p:cNvPr id="27" name="Text 25"/>
+          <p:cNvSpPr txBox="1"/>
+          <p:nvPr/>
+        </p:nvSpPr>
+        <p:spPr>
+          <a:xfrm>
+            <a:off x="8522208" y="4654296"/>
+            <a:ext cx="2962656" cy="1133856"/>
+          </a:xfrm>
+          <a:prstGeom prst="rect">
+            <a:avLst/>
+          </a:prstGeom>
+          <a:noFill/>
+          <a:ln/>
+        </p:spPr>
+        <p:txBody>
+          <a:bodyPr wrap="square" lIns="0" tIns="0" rIns="0" bIns="0" rtlCol="0" anchor="t"/>
+          <a:lstStyle/>
+          <a:p>
+            <a:pPr indent="0" marL="0">
+              <a:buNone/>
+            </a:pPr>
+            <a:r>
+              <a:rPr lang="en-US" sz="1400" b="1" dirty="0">
+                <a:solidFill>
+                  <a:srgbClr val="1A1A1A"/>
+                </a:solidFill>
+                <a:latin typeface="Inter" pitchFamily="34" charset="0"/>
+                <a:ea typeface="Inter" pitchFamily="34" charset="-122"/>
+                <a:cs typeface="Inter" pitchFamily="34" charset="-120"/>
+              </a:rPr>
+              <a:t>Parts: over the counter</a:t>
+            </a:r>
+            <a:endParaRPr lang="en-US" sz="1400" dirty="0"/>
+          </a:p>
+          <a:p>
+            <a:pPr indent="0" marL="0">
+              <a:buNone/>
+            </a:pPr>
+            <a:r>
+              <a:rPr lang="en-US" sz="1400" dirty="0">
+                <a:solidFill>
+                  <a:srgbClr val="595959"/>
+                </a:solidFill>
+                <a:latin typeface="Inter" pitchFamily="34" charset="0"/>
+                <a:ea typeface="Inter" pitchFamily="34" charset="-122"/>
+                <a:cs typeface="Inter" pitchFamily="34" charset="-120"/>
+              </a:rPr>
+              <a:t>Counter retail, wholesale, tires and oil</a:t>
+            </a:r>
+            <a:endParaRPr lang="en-US" sz="1400" dirty="0"/>
+          </a:p>
+        </p:txBody>
+      </p:sp>
+      <p:sp>
+        <p:nvSpPr>
+          <p:cNvPr id="28" name="Shape 26"/>
+          <p:cNvSpPr/>
+          <p:nvPr/>
+        </p:nvSpPr>
+        <p:spPr>
+          <a:xfrm>
+            <a:off x="457200" y="6126480"/>
+            <a:ext cx="11274552" cy="371856"/>
+          </a:xfrm>
+          <a:prstGeom prst="rect">
+            <a:avLst/>
+          </a:prstGeom>
+          <a:solidFill>
+            <a:srgbClr val="E6F6EE"/>
+          </a:solidFill>
+          <a:ln/>
+        </p:spPr>
+      </p:sp>
+      <p:sp>
+        <p:nvSpPr>
+          <p:cNvPr id="29" name="Text 27"/>
+          <p:cNvSpPr txBox="1"/>
+          <p:nvPr/>
+        </p:nvSpPr>
+        <p:spPr>
+          <a:xfrm>
+            <a:off x="658368" y="6144768"/>
+            <a:ext cx="10927080" cy="335280"/>
+          </a:xfrm>
+          <a:prstGeom prst="rect">
+            <a:avLst/>
+          </a:prstGeom>
+          <a:noFill/>
+          <a:ln/>
+        </p:spPr>
+        <p:txBody>
+          <a:bodyPr wrap="square" lIns="0" tIns="0" rIns="0" bIns="0" rtlCol="0" anchor="ctr"/>
+          <a:lstStyle/>
+          <a:p>
+            <a:pPr indent="0" marL="0">
+              <a:buNone/>
+            </a:pPr>
+            <a:r>
+              <a:rPr lang="en-US" sz="1600" b="1" dirty="0">
+                <a:solidFill>
+                  <a:srgbClr val="0B7A4A"/>
+                </a:solidFill>
+                <a:latin typeface="Inter" pitchFamily="34" charset="0"/>
+                <a:ea typeface="Inter" pitchFamily="34" charset="-122"/>
+                <a:cs typeface="Inter" pitchFamily="34" charset="-120"/>
+              </a:rPr>
+              <a:t>Group: $188.80M fixed ops gross Jan–Sep 2026, up $7.47M (4.1%): service +$6.30M, parts +$1.17M.</a:t>
+            </a:r>
+            <a:endParaRPr lang="en-US" sz="1600" dirty="0"/>
           </a:p>
         </p:txBody>
       </p:sp>

</xml_diff>

<commit_message>
What Is Fixed Ops Gross?: technician cost names hourly pay, guarantees and bonuses as unapplied labor
Co-Authored-By: Claude Opus 5.5 <noreply@anthropic.com>
Claude-Session: https://claude.ai/code/session_01Xa4nFVxuQGXmHARGph9WhS
</commit_message>
<xml_diff>
--- a/day2-deck/decks/Metric Explainers - Review.pptx
+++ b/day2-deck/decks/Metric Explainers - Review.pptx
@@ -871,7 +871,7 @@
             <a:r>
               <a:rPr lang="en-US" dirty="0"/>
               <a:t>Source: Definitions match the data slides: Qlik - Closed Repair Orders (all customer-pay ROs, by close month), Profit &amp; Loss and Productivity apps, Jan-Sep 2026 vs 2025, same-store, 33 stores. Worked example: Service Manager Roundtable, Nov 15, 2024, slide 21.PLACE: Gross section, after Service Is Sales 2.0 and in front of Total Gross Profit - Fixed Ops.
-Source: Qlik Profit &amp; Loss, Total Gross Profit - Service and Total Gross Profit - Parts, same-store, INEOS excluded, GMC Prescott body shop gross excluded (as on the gross slides). Guarantees and bonuses paid off the RO post as unapplied labor, a cost-of-sale adjustment against service gross.</a:t>
+Source: Qlik Profit &amp; Loss, Total Gross Profit - Service and Total Gross Profit - Parts, same-store, INEOS excluded, GMC Prescott body shop gross excluded (as on the gross slides). Hourly technician pay, guarantees and bonuses paid off the RO post as unapplied labor: not charged on any repair order, a cost-of-sale adjustment that reduces service gross (Noah, Oct 23).</a:t>
             </a:r>
             <a:endParaRPr lang="en-US" dirty="0"/>
           </a:p>
@@ -7124,7 +7124,7 @@
         <p:spPr>
           <a:xfrm>
             <a:off x="5138928" y="3410712"/>
-            <a:ext cx="45720" cy="1133856"/>
+            <a:ext cx="45720" cy="1420837"/>
           </a:xfrm>
           <a:prstGeom prst="rect">
             <a:avLst/>
@@ -7144,7 +7144,7 @@
         <p:spPr>
           <a:xfrm>
             <a:off x="5266944" y="3410712"/>
-            <a:ext cx="2962656" cy="1133856"/>
+            <a:ext cx="2962656" cy="1420837"/>
           </a:xfrm>
           <a:prstGeom prst="rect">
             <a:avLst/>
@@ -7200,7 +7200,7 @@
         <p:spPr>
           <a:xfrm>
             <a:off x="8394192" y="3410712"/>
-            <a:ext cx="45720" cy="1133856"/>
+            <a:ext cx="45720" cy="1420837"/>
           </a:xfrm>
           <a:prstGeom prst="rect">
             <a:avLst/>
@@ -7220,7 +7220,7 @@
         <p:spPr>
           <a:xfrm>
             <a:off x="8522208" y="3410712"/>
-            <a:ext cx="2962656" cy="1133856"/>
+            <a:ext cx="2962656" cy="1420837"/>
           </a:xfrm>
           <a:prstGeom prst="rect">
             <a:avLst/>
@@ -7261,7 +7261,7 @@
                 <a:ea typeface="Inter" pitchFamily="34" charset="-122"/>
                 <a:cs typeface="Inter" pitchFamily="34" charset="-120"/>
               </a:rPr>
-              <a:t>Pay on the RO; guarantees and bonuses paid off the RO come out of gross too</a:t>
+              <a:t>Pay on the RO. Hourly pay, guarantees and bonuses paid off the RO are unapplied labor: not on the RO, but they lower gross</a:t>
             </a:r>
             <a:endParaRPr lang="en-US" sz="1400" dirty="0"/>
           </a:p>
@@ -7275,8 +7275,8 @@
         </p:nvSpPr>
         <p:spPr>
           <a:xfrm>
-            <a:off x="5138928" y="4654296"/>
-            <a:ext cx="45720" cy="1133856"/>
+            <a:off x="5138928" y="4941277"/>
+            <a:ext cx="45720" cy="846875"/>
           </a:xfrm>
           <a:prstGeom prst="rect">
             <a:avLst/>
@@ -7295,8 +7295,8 @@
         </p:nvSpPr>
         <p:spPr>
           <a:xfrm>
-            <a:off x="5266944" y="4654296"/>
-            <a:ext cx="2962656" cy="1133856"/>
+            <a:off x="5266944" y="4941277"/>
+            <a:ext cx="2962656" cy="846875"/>
           </a:xfrm>
           <a:prstGeom prst="rect">
             <a:avLst/>
@@ -7351,8 +7351,8 @@
         </p:nvSpPr>
         <p:spPr>
           <a:xfrm>
-            <a:off x="8394192" y="4654296"/>
-            <a:ext cx="45720" cy="1133856"/>
+            <a:off x="8394192" y="4941277"/>
+            <a:ext cx="45720" cy="846875"/>
           </a:xfrm>
           <a:prstGeom prst="rect">
             <a:avLst/>
@@ -7371,8 +7371,8 @@
         </p:nvSpPr>
         <p:spPr>
           <a:xfrm>
-            <a:off x="8522208" y="4654296"/>
-            <a:ext cx="2962656" cy="1133856"/>
+            <a:off x="8522208" y="4941277"/>
+            <a:ext cx="2962656" cy="846875"/>
           </a:xfrm>
           <a:prstGeom prst="rect">
             <a:avLst/>

</xml_diff>

<commit_message>
ELR explainer leads with work mix; luxury split and Acura review files deleted
Co-Authored-By: Claude Opus 5.5 <noreply@anthropic.com>
Claude-Session: https://claude.ai/code/session_01Xa4nFVxuQGXmHARGph9WhS
</commit_message>
<xml_diff>
--- a/day2-deck/decks/Metric Explainers - Review.pptx
+++ b/day2-deck/decks/Metric Explainers - Review.pptx
@@ -1049,7 +1049,8 @@
             <a:r>
               <a:rPr lang="en-US" dirty="0"/>
               <a:t>Source: Definitions match the data slides: Qlik - Closed Repair Orders (all customer-pay ROs, by close month), Profit &amp; Loss and Productivity apps, Jan-Sep 2026 vs 2025, same-store, 33 stores. Worked example: Service Manager Roundtable, Nov 15, 2024, slide 21.PLACE: CP Engine, in front of CP ELR (and ahead of the door-rate slides).
-Roundtable worked example removed from the slide (Noah, Oct 21).</a:t>
+Roundtable worked example removed from the slide (Noah, Oct 21).
+Talk track (Noah, Oct 23): to understand your ELR you have to understand your work mix. A shop that does more repair than maintenance will run a higher ELR, because the repair rate is higher; a shop that is mostly maintenance will run lower. There is nothing wrong with that, but you need to know your mix to know why your ELR is what it is. It matters because raising the repair rate may do less than raising the maintenance rate if most of your work is maintenance. Know your ELR for every labor operation.</a:t>
             </a:r>
             <a:endParaRPr lang="en-US" dirty="0"/>
           </a:p>
@@ -9114,7 +9115,7 @@
               <a:buChar char="•"/>
             </a:pPr>
             <a:r>
-              <a:rPr lang="en-US" sz="1600" dirty="0">
+              <a:rPr lang="en-US" sz="1500" dirty="0">
                 <a:solidFill>
                   <a:srgbClr val="1A1A1A"/>
                 </a:solidFill>
@@ -9122,9 +9123,9 @@
                 <a:ea typeface="Inter" pitchFamily="34" charset="-122"/>
                 <a:cs typeface="Inter" pitchFamily="34" charset="-120"/>
               </a:rPr>
-              <a:t>Every hour sold is worth the ELR, so it sets the value of the whole shop.</a:t>
-            </a:r>
-            <a:endParaRPr lang="en-US" sz="1600" dirty="0"/>
+              <a:t>Know your work mix: repair is priced above maintenance, so repair-heavy shops run a higher ELR, maintenance-heavy shops lower. Neither is wrong.</a:t>
+            </a:r>
+            <a:endParaRPr lang="en-US" sz="1500" dirty="0"/>
           </a:p>
           <a:p>
             <a:pPr marL="203200" indent="-203200">
@@ -9135,7 +9136,7 @@
               <a:buChar char="•"/>
             </a:pPr>
             <a:r>
-              <a:rPr lang="en-US" sz="1600" dirty="0">
+              <a:rPr lang="en-US" sz="1500" dirty="0">
                 <a:solidFill>
                   <a:srgbClr val="1A1A1A"/>
                 </a:solidFill>
@@ -9143,9 +9144,9 @@
                 <a:ea typeface="Inter" pitchFamily="34" charset="-122"/>
                 <a:cs typeface="Inter" pitchFamily="34" charset="-120"/>
               </a:rPr>
-              <a:t>The gap to door rate is money given away. Our benchmark: CP ELR at least 70% of door rate.</a:t>
-            </a:r>
-            <a:endParaRPr lang="en-US" sz="1600" dirty="0"/>
+              <a:t>If most of your work is maintenance, raising the maintenance rate moves ELR more than raising the repair rate.</a:t>
+            </a:r>
+            <a:endParaRPr lang="en-US" sz="1500" dirty="0"/>
           </a:p>
           <a:p>
             <a:pPr marL="203200" indent="-203200">
@@ -9156,7 +9157,7 @@
               <a:buChar char="•"/>
             </a:pPr>
             <a:r>
-              <a:rPr lang="en-US" sz="1600" dirty="0">
+              <a:rPr lang="en-US" sz="1500" dirty="0">
                 <a:solidFill>
                   <a:srgbClr val="1A1A1A"/>
                 </a:solidFill>
@@ -9164,9 +9165,30 @@
                 <a:ea typeface="Inter" pitchFamily="34" charset="-122"/>
                 <a:cs typeface="Inter" pitchFamily="34" charset="-120"/>
               </a:rPr>
-              <a:t>It shows whether pricing, discounting and mix are under control.</a:t>
-            </a:r>
-            <a:endParaRPr lang="en-US" sz="1600" dirty="0"/>
+              <a:t>Know the ELR on every labor operation.</a:t>
+            </a:r>
+            <a:endParaRPr lang="en-US" sz="1500" dirty="0"/>
+          </a:p>
+          <a:p>
+            <a:pPr marL="203200" indent="-203200">
+              <a:spcAft>
+                <a:spcPts val="600"/>
+              </a:spcAft>
+              <a:buSzPct val="100000"/>
+              <a:buChar char="•"/>
+            </a:pPr>
+            <a:r>
+              <a:rPr lang="en-US" sz="1500" dirty="0">
+                <a:solidFill>
+                  <a:srgbClr val="1A1A1A"/>
+                </a:solidFill>
+                <a:latin typeface="Inter" pitchFamily="34" charset="0"/>
+                <a:ea typeface="Inter" pitchFamily="34" charset="-122"/>
+                <a:cs typeface="Inter" pitchFamily="34" charset="-120"/>
+              </a:rPr>
+              <a:t>Benchmark: CP ELR at least 70% of door rate.</a:t>
+            </a:r>
+            <a:endParaRPr lang="en-US" sz="1500" dirty="0"/>
           </a:p>
         </p:txBody>
       </p:sp>

</xml_diff>

<commit_message>
What Is Effective Labor Rate?: previewed version into the deck
Co-Authored-By: Claude Opus 5.5 <noreply@anthropic.com>
Claude-Session: https://claude.ai/code/session_01Xa4nFVxuQGXmHARGph9WhS
</commit_message>
<xml_diff>
--- a/day2-deck/decks/Metric Explainers - Review.pptx
+++ b/day2-deck/decks/Metric Explainers - Review.pptx
@@ -1048,9 +1048,9 @@
           <a:p>
             <a:r>
               <a:rPr lang="en-US" dirty="0"/>
-              <a:t>Source: Definitions match the data slides: Qlik - Closed Repair Orders (all customer-pay ROs, by close month), Profit &amp; Loss and Productivity apps, Jan-Sep 2026 vs 2025, same-store, 33 stores. Worked example: Service Manager Roundtable, Nov 15, 2024, slide 21.PLACE: CP Engine, in front of CP ELR (and ahead of the door-rate slides).
+              <a:t>Source: Definitions match the data slides: Qlik - Closed Repair Orders (all customer-pay ROs, by close month), Profit &amp; Loss and Productivity apps, Jan-Sep 2026 vs 2025, same-store, 33 stores. Worked example: Service Manager Roundtable, Nov 15, 2024, slide 21.PLACE: Customer Pay, after CP Hours per RO and ahead of Labor Sale by Pay Type and the CP ELR slides.
 Roundtable worked example removed from the slide (Noah, Oct 21).
-Talk track (Noah, Oct 23): to understand your ELR you have to understand your work mix. A shop that does more repair than maintenance will run a higher ELR, because the repair rate is higher; a shop that is mostly maintenance will run lower. There is nothing wrong with that, but you need to know your mix to know why your ELR is what it is. It matters because raising the repair rate may do less than raising the maintenance rate if most of your work is maintenance. Know your ELR for every labor operation.</a:t>
+Talk track (Noah, Oct 23): to understand your ELR you have to understand your work mix. A shop that does more repair than maintenance will run a higher ELR, because the repair rate is higher; a shop that is mostly maintenance will run lower. There is nothing wrong with that, but you need to know your mix to know why your ELR is what it is. Raising the repair rate may do less than raising the maintenance rate if most of your work is maintenance. Know your ELR for every labor operation.</a:t>
             </a:r>
             <a:endParaRPr lang="en-US" dirty="0"/>
           </a:p>
@@ -9115,7 +9115,7 @@
               <a:buChar char="•"/>
             </a:pPr>
             <a:r>
-              <a:rPr lang="en-US" sz="1500" dirty="0">
+              <a:rPr lang="en-US" sz="1600" dirty="0">
                 <a:solidFill>
                   <a:srgbClr val="1A1A1A"/>
                 </a:solidFill>
@@ -9123,9 +9123,9 @@
                 <a:ea typeface="Inter" pitchFamily="34" charset="-122"/>
                 <a:cs typeface="Inter" pitchFamily="34" charset="-120"/>
               </a:rPr>
-              <a:t>Know your work mix: repair is priced above maintenance, so repair-heavy shops run a higher ELR, maintenance-heavy shops lower. Neither is wrong.</a:t>
-            </a:r>
-            <a:endParaRPr lang="en-US" sz="1500" dirty="0"/>
+              <a:t>Every hour sold is worth the ELR, so it sets the value of the whole shop. Know what you are charging.</a:t>
+            </a:r>
+            <a:endParaRPr lang="en-US" sz="1600" dirty="0"/>
           </a:p>
           <a:p>
             <a:pPr marL="203200" indent="-203200">
@@ -9136,7 +9136,7 @@
               <a:buChar char="•"/>
             </a:pPr>
             <a:r>
-              <a:rPr lang="en-US" sz="1500" dirty="0">
+              <a:rPr lang="en-US" sz="1600" dirty="0">
                 <a:solidFill>
                   <a:srgbClr val="1A1A1A"/>
                 </a:solidFill>
@@ -9144,9 +9144,9 @@
                 <a:ea typeface="Inter" pitchFamily="34" charset="-122"/>
                 <a:cs typeface="Inter" pitchFamily="34" charset="-120"/>
               </a:rPr>
-              <a:t>If most of your work is maintenance, raising the maintenance rate moves ELR more than raising the repair rate.</a:t>
-            </a:r>
-            <a:endParaRPr lang="en-US" sz="1500" dirty="0"/>
+              <a:t>It shows whether pricing, discounting and mix are under control.</a:t>
+            </a:r>
+            <a:endParaRPr lang="en-US" sz="1600" dirty="0"/>
           </a:p>
           <a:p>
             <a:pPr marL="203200" indent="-203200">
@@ -9157,7 +9157,7 @@
               <a:buChar char="•"/>
             </a:pPr>
             <a:r>
-              <a:rPr lang="en-US" sz="1500" dirty="0">
+              <a:rPr lang="en-US" sz="1600" dirty="0">
                 <a:solidFill>
                   <a:srgbClr val="1A1A1A"/>
                 </a:solidFill>
@@ -9165,30 +9165,9 @@
                 <a:ea typeface="Inter" pitchFamily="34" charset="-122"/>
                 <a:cs typeface="Inter" pitchFamily="34" charset="-120"/>
               </a:rPr>
-              <a:t>Know the ELR on every labor operation.</a:t>
-            </a:r>
-            <a:endParaRPr lang="en-US" sz="1500" dirty="0"/>
-          </a:p>
-          <a:p>
-            <a:pPr marL="203200" indent="-203200">
-              <a:spcAft>
-                <a:spcPts val="600"/>
-              </a:spcAft>
-              <a:buSzPct val="100000"/>
-              <a:buChar char="•"/>
-            </a:pPr>
-            <a:r>
-              <a:rPr lang="en-US" sz="1500" dirty="0">
-                <a:solidFill>
-                  <a:srgbClr val="1A1A1A"/>
-                </a:solidFill>
-                <a:latin typeface="Inter" pitchFamily="34" charset="0"/>
-                <a:ea typeface="Inter" pitchFamily="34" charset="-122"/>
-                <a:cs typeface="Inter" pitchFamily="34" charset="-120"/>
-              </a:rPr>
               <a:t>Benchmark: CP ELR at least 70% of door rate.</a:t>
             </a:r>
-            <a:endParaRPr lang="en-US" sz="1500" dirty="0"/>
+            <a:endParaRPr lang="en-US" sz="1600" dirty="0"/>
           </a:p>
         </p:txBody>
       </p:sp>
@@ -9201,7 +9180,7 @@
         <p:spPr>
           <a:xfrm>
             <a:off x="5138928" y="2843784"/>
-            <a:ext cx="45720" cy="908304"/>
+            <a:ext cx="45720" cy="1064924"/>
           </a:xfrm>
           <a:prstGeom prst="rect">
             <a:avLst/>
@@ -9221,7 +9200,7 @@
         <p:spPr>
           <a:xfrm>
             <a:off x="5266944" y="2843784"/>
-            <a:ext cx="2962656" cy="908304"/>
+            <a:ext cx="2962656" cy="1064924"/>
           </a:xfrm>
           <a:prstGeom prst="rect">
             <a:avLst/>
@@ -9245,7 +9224,7 @@
                 <a:ea typeface="Inter" pitchFamily="34" charset="-122"/>
                 <a:cs typeface="Inter" pitchFamily="34" charset="-120"/>
               </a:rPr>
-              <a:t>Door rate</a:t>
+              <a:t>Work mix</a:t>
             </a:r>
             <a:endParaRPr lang="en-US" sz="1400" dirty="0"/>
           </a:p>
@@ -9262,7 +9241,7 @@
                 <a:ea typeface="Inter" pitchFamily="34" charset="-122"/>
                 <a:cs typeface="Inter" pitchFamily="34" charset="-120"/>
               </a:rPr>
-              <a:t>The posted rate, set from a market labor study</a:t>
+              <a:t>Repair is priced above maintenance: repair-heavy shops run a higher ELR, maintenance-heavy lower. Neither is wrong.</a:t>
             </a:r>
             <a:endParaRPr lang="en-US" sz="1400" dirty="0"/>
           </a:p>
@@ -9277,7 +9256,7 @@
         <p:spPr>
           <a:xfrm>
             <a:off x="8394192" y="2843784"/>
-            <a:ext cx="45720" cy="908304"/>
+            <a:ext cx="45720" cy="1064924"/>
           </a:xfrm>
           <a:prstGeom prst="rect">
             <a:avLst/>
@@ -9297,7 +9276,7 @@
         <p:spPr>
           <a:xfrm>
             <a:off x="8522208" y="2843784"/>
-            <a:ext cx="2962656" cy="908304"/>
+            <a:ext cx="2962656" cy="1064924"/>
           </a:xfrm>
           <a:prstGeom prst="rect">
             <a:avLst/>
@@ -9338,7 +9317,7 @@
                 <a:ea typeface="Inter" pitchFamily="34" charset="-122"/>
                 <a:cs typeface="Inter" pitchFamily="34" charset="-120"/>
               </a:rPr>
-              <a:t>Menus and loss leaders below door rate pull ELR down</a:t>
+              <a:t>If most of your hours are maintenance, the maintenance rate moves ELR more than the repair rate</a:t>
             </a:r>
             <a:endParaRPr lang="en-US" sz="1400" dirty="0"/>
           </a:p>
@@ -9352,8 +9331,8 @@
         </p:nvSpPr>
         <p:spPr>
           <a:xfrm>
-            <a:off x="5138928" y="3861816"/>
-            <a:ext cx="45720" cy="908304"/>
+            <a:off x="5138928" y="4018436"/>
+            <a:ext cx="45720" cy="829994"/>
           </a:xfrm>
           <a:prstGeom prst="rect">
             <a:avLst/>
@@ -9372,8 +9351,8 @@
         </p:nvSpPr>
         <p:spPr>
           <a:xfrm>
-            <a:off x="5266944" y="3861816"/>
-            <a:ext cx="2962656" cy="908304"/>
+            <a:off x="5266944" y="4018436"/>
+            <a:ext cx="2962656" cy="829994"/>
           </a:xfrm>
           <a:prstGeom prst="rect">
             <a:avLst/>
@@ -9397,7 +9376,7 @@
                 <a:ea typeface="Inter" pitchFamily="34" charset="-122"/>
                 <a:cs typeface="Inter" pitchFamily="34" charset="-120"/>
               </a:rPr>
-              <a:t>Work mix</a:t>
+              <a:t>ELR by labor operation</a:t>
             </a:r>
             <a:endParaRPr lang="en-US" sz="1400" dirty="0"/>
           </a:p>
@@ -9414,7 +9393,7 @@
                 <a:ea typeface="Inter" pitchFamily="34" charset="-122"/>
                 <a:cs typeface="Inter" pitchFamily="34" charset="-120"/>
               </a:rPr>
-              <a:t>Repair work raises ELR; quick maintenance lowers it</a:t>
+              <a:t>Know what every op code collects per hour, not just the store total</a:t>
             </a:r>
             <a:endParaRPr lang="en-US" sz="1400" dirty="0"/>
           </a:p>
@@ -9428,8 +9407,8 @@
         </p:nvSpPr>
         <p:spPr>
           <a:xfrm>
-            <a:off x="8394192" y="3861816"/>
-            <a:ext cx="45720" cy="908304"/>
+            <a:off x="8394192" y="4018436"/>
+            <a:ext cx="45720" cy="829994"/>
           </a:xfrm>
           <a:prstGeom prst="rect">
             <a:avLst/>
@@ -9448,8 +9427,8 @@
         </p:nvSpPr>
         <p:spPr>
           <a:xfrm>
-            <a:off x="8522208" y="3861816"/>
-            <a:ext cx="2962656" cy="908304"/>
+            <a:off x="8522208" y="4018436"/>
+            <a:ext cx="2962656" cy="829994"/>
           </a:xfrm>
           <a:prstGeom prst="rect">
             <a:avLst/>
@@ -9473,7 +9452,7 @@
                 <a:ea typeface="Inter" pitchFamily="34" charset="-122"/>
                 <a:cs typeface="Inter" pitchFamily="34" charset="-120"/>
               </a:rPr>
-              <a:t>Discounts</a:t>
+              <a:t>Door rate and labor grid</a:t>
             </a:r>
             <a:endParaRPr lang="en-US" sz="1400" dirty="0"/>
           </a:p>
@@ -9490,7 +9469,7 @@
                 <a:ea typeface="Inter" pitchFamily="34" charset="-122"/>
                 <a:cs typeface="Inter" pitchFamily="34" charset="-120"/>
               </a:rPr>
-              <a:t>Every discount lowers ELR. Run them through ADC so we can see them.</a:t>
+              <a:t>Posted rate from a market labor study; a grid prices longer repair jobs higher</a:t>
             </a:r>
             <a:endParaRPr lang="en-US" sz="1400" dirty="0"/>
           </a:p>
@@ -9504,8 +9483,8 @@
         </p:nvSpPr>
         <p:spPr>
           <a:xfrm>
-            <a:off x="5138928" y="4879848"/>
-            <a:ext cx="45720" cy="908304"/>
+            <a:off x="5138928" y="4958158"/>
+            <a:ext cx="45720" cy="829994"/>
           </a:xfrm>
           <a:prstGeom prst="rect">
             <a:avLst/>
@@ -9524,8 +9503,8 @@
         </p:nvSpPr>
         <p:spPr>
           <a:xfrm>
-            <a:off x="5266944" y="4879848"/>
-            <a:ext cx="2962656" cy="908304"/>
+            <a:off x="5266944" y="4958158"/>
+            <a:ext cx="2962656" cy="829994"/>
           </a:xfrm>
           <a:prstGeom prst="rect">
             <a:avLst/>
@@ -9549,7 +9528,7 @@
                 <a:ea typeface="Inter" pitchFamily="34" charset="-122"/>
                 <a:cs typeface="Inter" pitchFamily="34" charset="-120"/>
               </a:rPr>
-              <a:t>Labor grid</a:t>
+              <a:t>Discounts</a:t>
             </a:r>
             <a:endParaRPr lang="en-US" sz="1400" dirty="0"/>
           </a:p>
@@ -9566,7 +9545,7 @@
                 <a:ea typeface="Inter" pitchFamily="34" charset="-122"/>
                 <a:cs typeface="Inter" pitchFamily="34" charset="-120"/>
               </a:rPr>
-              <a:t>Prices longer jobs differently; should lift ELR on repair work</a:t>
+              <a:t>Every discount lowers ELR. Run them through ADC so we can see them.</a:t>
             </a:r>
             <a:endParaRPr lang="en-US" sz="1400" dirty="0"/>
           </a:p>
@@ -9580,8 +9559,8 @@
         </p:nvSpPr>
         <p:spPr>
           <a:xfrm>
-            <a:off x="8394192" y="4879848"/>
-            <a:ext cx="45720" cy="908304"/>
+            <a:off x="8394192" y="4958158"/>
+            <a:ext cx="45720" cy="829994"/>
           </a:xfrm>
           <a:prstGeom prst="rect">
             <a:avLst/>
@@ -9600,8 +9579,8 @@
         </p:nvSpPr>
         <p:spPr>
           <a:xfrm>
-            <a:off x="8522208" y="4879848"/>
-            <a:ext cx="2962656" cy="908304"/>
+            <a:off x="8522208" y="4958158"/>
+            <a:ext cx="2962656" cy="829994"/>
           </a:xfrm>
           <a:prstGeom prst="rect">
             <a:avLst/>

</xml_diff>

<commit_message>
Round 2: callback top 5 with 100% count; hours per RO, labor GP, parts GP wording
Co-Authored-By: Claude Opus 5.5 <noreply@anthropic.com>
Claude-Session: https://claude.ai/code/session_01Xa4nFVxuQGXmHARGph9WhS
</commit_message>
<xml_diff>
--- a/day2-deck/decks/Metric Explainers - Review.pptx
+++ b/day2-deck/decks/Metric Explainers - Review.pptx
@@ -7761,7 +7761,7 @@
                 <a:ea typeface="Inter" pitchFamily="34" charset="-122"/>
                 <a:cs typeface="Inter" pitchFamily="34" charset="-120"/>
               </a:rPr>
-              <a:t>How much labor time we sell on the average customer-pay visit.</a:t>
+              <a:t>The labor hours we sell, on average, every time a customer-pay car comes through the drive.</a:t>
             </a:r>
             <a:endParaRPr lang="en-US" sz="1500" dirty="0"/>
           </a:p>
@@ -8142,7 +8142,7 @@
                 <a:ea typeface="Inter" pitchFamily="34" charset="-122"/>
                 <a:cs typeface="Inter" pitchFamily="34" charset="-120"/>
               </a:rPr>
-              <a:t>It shows where the lift came from: labor $ per RO up from $200 to $250 with hours flat is a price increase, not more work.</a:t>
+              <a:t>It shows where the lift came from: if labor sales per RO go up but hours per RO stay flat, we are charging more, not selling more.</a:t>
             </a:r>
             <a:endParaRPr lang="en-US" sz="1500" dirty="0"/>
           </a:p>
@@ -12419,7 +12419,7 @@
                 <a:ea typeface="Inter" pitchFamily="34" charset="-122"/>
                 <a:cs typeface="Inter" pitchFamily="34" charset="-120"/>
               </a:rPr>
-              <a:t>The target range is 78% to 80%: not too high, not too low. Hold it by matching the tech to the job, not by squeezing tech pay.</a:t>
+              <a:t>The target range is 78% to 80%: not too high, not too low. Hold it by matching the tech to the work, not by squeezing tech pay.</a:t>
             </a:r>
             <a:endParaRPr lang="en-US" sz="1500" dirty="0"/>
           </a:p>
@@ -12440,7 +12440,7 @@
                 <a:ea typeface="Inter" pitchFamily="34" charset="-122"/>
                 <a:cs typeface="Inter" pitchFamily="34" charset="-120"/>
               </a:rPr>
-              <a:t>Too low means tech cost is out of line with what the job sells for.</a:t>
+              <a:t>Too low means our labor price is too low for what we pay the tech, or tech cost is too high for what we charge.</a:t>
             </a:r>
             <a:endParaRPr lang="en-US" sz="1500" dirty="0"/>
           </a:p>
@@ -12672,7 +12672,7 @@
                 <a:ea typeface="Inter" pitchFamily="34" charset="-122"/>
                 <a:cs typeface="Inter" pitchFamily="34" charset="-120"/>
               </a:rPr>
-              <a:t>Right tech, right job</a:t>
+              <a:t>Right tech, right work</a:t>
             </a:r>
             <a:endParaRPr lang="en-US" sz="1400" dirty="0"/>
           </a:p>
@@ -13569,7 +13569,7 @@
                 <a:ea typeface="Inter" pitchFamily="34" charset="-122"/>
                 <a:cs typeface="Inter" pitchFamily="34" charset="-120"/>
               </a:rPr>
-              <a:t>Know how it is set up, check parts actually sell at matrix prices, and review it against your gross goals</a:t>
+              <a:t>Know how it is set up, make sure pricing follows the matrix setup, and review it against your gross goals</a:t>
             </a:r>
             <a:endParaRPr lang="en-US" sz="1400" dirty="0"/>
           </a:p>

</xml_diff>

<commit_message>
Round 3: labor GP retention line; parts GP why-it-matters from Noah's five reasons
Co-Authored-By: Claude Opus 5.5 <noreply@anthropic.com>
Claude-Session: https://claude.ai/code/session_01Xa4nFVxuQGXmHARGph9WhS
</commit_message>
<xml_diff>
--- a/day2-deck/decks/Metric Explainers - Review.pptx
+++ b/day2-deck/decks/Metric Explainers - Review.pptx
@@ -1406,7 +1406,8 @@
             <a:r>
               <a:rPr lang="en-US" dirty="0"/>
               <a:t>Source: Definitions match the data slides: Qlik - Closed Repair Orders (all customer-pay ROs, by close month), Profit &amp; Loss and Productivity apps, Jan-Sep 2026 vs 2025, same-store, 33 stores. Worked example: Service Manager Roundtable, Nov 15, 2024, slide 21.PLACE: CP Engine, in front of CP Parts Gross Profit %.
-Why understand your parts pricing matrix (Noah, Oct 26): (1) Maximize gross profit: price parts to maximize profitability; find gross without more volume. (2) Consistent pricing: every customer charged the same for the same part; no incorrect prices from bad setups or manual overrides. (3) Stay competitive: avoid markups that make repairs too expensive; balance profit with price on higher-cost parts. (4) Check the matrix is applied: parts actually sell at matrix prices; find parts, labor types or transactions that bypass it. (5) Warranty reimbursement: customer-pay parts pricing drives the warranty parts reimbursement rate, so good pricing supports a higher rate and more warranty gross. (6) Control the strategy: know how your matrix is configured and review it against your gross profit goals. Takeaway: the matrix is one of the most effective tools for improving profit without more volume.</a:t>
+Why understand your parts pricing matrix (Noah, Oct 26): (1) Maximize gross profit: price parts to maximize profitability; find gross without more volume. (2) Consistent pricing: every customer charged the same for the same part; no incorrect prices from bad setups or manual overrides. (3) Stay competitive: avoid markups that make repairs too expensive; balance profit with price on higher-cost parts. (4) Check the matrix is applied: parts actually sell at matrix prices; find parts, labor types or transactions that bypass it. (5) Warranty reimbursement: customer-pay parts pricing drives the warranty parts reimbursement rate, so good pricing supports a higher rate and more warranty gross. (6) Control the strategy: know how your matrix is configured and review it against your gross profit goals. Takeaway: the matrix is one of the most effective tools for improving profit without more volume.
+5 reasons parts gross profit % matters (Noah, Oct 26): (1) Maximizes profitability: higher GP % earns more from the same volume; small improvements add up over a year. (2) Measures pricing effectiveness: are parts sold at the right prices; where to improve matrices, discounts and markups. (3) Controls discounts and cost increases: shows when discounting cuts profit, and when rising parts costs are not reflected in selling prices. (4) Supports dealership profit: parts gross covers department expenses, adds to net profit and helps fixed ops absorb store overhead. (5) Identifies opportunities: compare against targets, history and other stores; find weak categories (customer pay, wholesale, warranty, internal). Takeaway: parts GP % measures how well we turn parts sales into profit; raising it is one of the most direct ways to grow profit without more volume.</a:t>
             </a:r>
             <a:endParaRPr lang="en-US" dirty="0"/>
           </a:p>
@@ -12461,7 +12462,7 @@
                 <a:ea typeface="Inter" pitchFamily="34" charset="-122"/>
                 <a:cs typeface="Inter" pitchFamily="34" charset="-120"/>
               </a:rPr>
-              <a:t>Too high can mean techs are underpaid on the work they do, which costs us techs.</a:t>
+              <a:t>Too high can mean techs are underpaid, which can cost us technicians and hurt retention.</a:t>
             </a:r>
             <a:endParaRPr lang="en-US" sz="1500" dirty="0"/>
           </a:p>
@@ -13443,7 +13444,7 @@
               <a:buChar char="•"/>
             </a:pPr>
             <a:r>
-              <a:rPr lang="en-US" sz="1600" dirty="0">
+              <a:rPr lang="en-US" sz="1500" dirty="0">
                 <a:solidFill>
                   <a:srgbClr val="1A1A1A"/>
                 </a:solidFill>
@@ -13451,9 +13452,9 @@
                 <a:ea typeface="Inter" pitchFamily="34" charset="-122"/>
                 <a:cs typeface="Inter" pitchFamily="34" charset="-120"/>
               </a:rPr>
-              <a:t>The pricing matrix raises gross without selling one more part.</a:t>
-            </a:r>
-            <a:endParaRPr lang="en-US" sz="1600" dirty="0"/>
+              <a:t>More profit from the same parts sales: small gains add up over a year.</a:t>
+            </a:r>
+            <a:endParaRPr lang="en-US" sz="1500" dirty="0"/>
           </a:p>
           <a:p>
             <a:pPr marL="203200" indent="-203200">
@@ -13464,7 +13465,7 @@
               <a:buChar char="•"/>
             </a:pPr>
             <a:r>
-              <a:rPr lang="en-US" sz="1600" dirty="0">
+              <a:rPr lang="en-US" sz="1500" dirty="0">
                 <a:solidFill>
                   <a:srgbClr val="1A1A1A"/>
                 </a:solidFill>
@@ -13472,9 +13473,9 @@
                 <a:ea typeface="Inter" pitchFamily="34" charset="-122"/>
                 <a:cs typeface="Inter" pitchFamily="34" charset="-120"/>
               </a:rPr>
-              <a:t>Consistent pricing: the same part costs every customer the same.</a:t>
-            </a:r>
-            <a:endParaRPr lang="en-US" sz="1600" dirty="0"/>
+              <a:t>It shows whether parts sell at the right price: matrix, markups and discounts.</a:t>
+            </a:r>
+            <a:endParaRPr lang="en-US" sz="1500" dirty="0"/>
           </a:p>
           <a:p>
             <a:pPr marL="203200" indent="-203200">
@@ -13485,7 +13486,7 @@
               <a:buChar char="•"/>
             </a:pPr>
             <a:r>
-              <a:rPr lang="en-US" sz="1600" dirty="0">
+              <a:rPr lang="en-US" sz="1500" dirty="0">
                 <a:solidFill>
                   <a:srgbClr val="1A1A1A"/>
                 </a:solidFill>
@@ -13493,9 +13494,30 @@
                 <a:ea typeface="Inter" pitchFamily="34" charset="-122"/>
                 <a:cs typeface="Inter" pitchFamily="34" charset="-120"/>
               </a:rPr>
+              <a:t>It flags heavy discounting, or cost increases we have not passed on.</a:t>
+            </a:r>
+            <a:endParaRPr lang="en-US" sz="1500" dirty="0"/>
+          </a:p>
+          <a:p>
+            <a:pPr marL="203200" indent="-203200">
+              <a:spcAft>
+                <a:spcPts val="600"/>
+              </a:spcAft>
+              <a:buSzPct val="100000"/>
+              <a:buChar char="•"/>
+            </a:pPr>
+            <a:r>
+              <a:rPr lang="en-US" sz="1500" dirty="0">
+                <a:solidFill>
+                  <a:srgbClr val="1A1A1A"/>
+                </a:solidFill>
+                <a:latin typeface="Inter" pitchFamily="34" charset="0"/>
+                <a:ea typeface="Inter" pitchFamily="34" charset="-122"/>
+                <a:cs typeface="Inter" pitchFamily="34" charset="-120"/>
+              </a:rPr>
               <a:t>CP parts pricing supports the warranty parts reimbursement rate.</a:t>
             </a:r>
-            <a:endParaRPr lang="en-US" sz="1600" dirty="0"/>
+            <a:endParaRPr lang="en-US" sz="1500" dirty="0"/>
           </a:p>
         </p:txBody>
       </p:sp>

</xml_diff>

<commit_message>
Round 4: parts GP keeps 37 cents; tracking lever
Co-Authored-By: Claude Opus 5.5 <noreply@anthropic.com>
Claude-Session: https://claude.ai/code/session_01Xa4nFVxuQGXmHARGph9WhS
</commit_message>
<xml_diff>
--- a/day2-deck/decks/Metric Explainers - Review.pptx
+++ b/day2-deck/decks/Metric Explainers - Review.pptx
@@ -1407,7 +1407,8 @@
               <a:rPr lang="en-US" dirty="0"/>
               <a:t>Source: Definitions match the data slides: Qlik - Closed Repair Orders (all customer-pay ROs, by close month), Profit &amp; Loss and Productivity apps, Jan-Sep 2026 vs 2025, same-store, 33 stores. Worked example: Service Manager Roundtable, Nov 15, 2024, slide 21.PLACE: CP Engine, in front of CP Parts Gross Profit %.
 Why understand your parts pricing matrix (Noah, Oct 26): (1) Maximize gross profit: price parts to maximize profitability; find gross without more volume. (2) Consistent pricing: every customer charged the same for the same part; no incorrect prices from bad setups or manual overrides. (3) Stay competitive: avoid markups that make repairs too expensive; balance profit with price on higher-cost parts. (4) Check the matrix is applied: parts actually sell at matrix prices; find parts, labor types or transactions that bypass it. (5) Warranty reimbursement: customer-pay parts pricing drives the warranty parts reimbursement rate, so good pricing supports a higher rate and more warranty gross. (6) Control the strategy: know how your matrix is configured and review it against your gross profit goals. Takeaway: the matrix is one of the most effective tools for improving profit without more volume.
-5 reasons parts gross profit % matters (Noah, Oct 26): (1) Maximizes profitability: higher GP % earns more from the same volume; small improvements add up over a year. (2) Measures pricing effectiveness: are parts sold at the right prices; where to improve matrices, discounts and markups. (3) Controls discounts and cost increases: shows when discounting cuts profit, and when rising parts costs are not reflected in selling prices. (4) Supports dealership profit: parts gross covers department expenses, adds to net profit and helps fixed ops absorb store overhead. (5) Identifies opportunities: compare against targets, history and other stores; find weak categories (customer pay, wholesale, warranty, internal). Takeaway: parts GP % measures how well we turn parts sales into profit; raising it is one of the most direct ways to grow profit without more volume.</a:t>
+5 reasons parts gross profit % matters (Noah, Oct 26): (1) Maximizes profitability: higher GP % earns more from the same volume; small improvements add up over a year. (2) Measures pricing effectiveness: are parts sold at the right prices; where to improve matrices, discounts and markups. (3) Controls discounts and cost increases: shows when discounting cuts profit, and when rising parts costs are not reflected in selling prices. (4) Supports dealership profit: parts gross covers department expenses, adds to net profit and helps fixed ops absorb store overhead. (5) Identifies opportunities: compare against targets, history and other stores; find weak categories (customer pay, wholesale, warranty, internal). Takeaway: parts GP % measures how well we turn parts sales into profit; raising it is one of the most direct ways to grow profit without more volume.
+37 cents (Oct 26): P&amp;L Detail, Jan-Sep 2026 same-store, parts department profit $22.75M / parts gross $61.93M = 36.7% (2025 37.1%); service 21.8% (2025 18.9%); new and used lose money at the department level; parts beats service in 31 of 33 stores (not Honda Henderson, VW Henderson). F&amp;I income less F&amp;I commissions is higher (about 80%) but F&amp;I is not a P&amp;L department and its other costs sit in new and used, so say 'department'. Department view: about $87M of other income (doc fees, packs, factory money, holdback) is booked outside the departments.</a:t>
             </a:r>
             <a:endParaRPr lang="en-US" dirty="0"/>
           </a:p>
@@ -13452,7 +13453,7 @@
                 <a:ea typeface="Inter" pitchFamily="34" charset="-122"/>
                 <a:cs typeface="Inter" pitchFamily="34" charset="-120"/>
               </a:rPr>
-              <a:t>More profit from the same parts sales: small gains add up over a year.</a:t>
+              <a:t>Parts keeps about 37¢ of every gross dollar after its own expenses, the most of any department (service 22¢): margin goes almost straight to the bottom line.</a:t>
             </a:r>
             <a:endParaRPr lang="en-US" sz="1500" dirty="0"/>
           </a:p>
@@ -13909,6 +13910,82 @@
         </p:nvSpPr>
         <p:spPr>
           <a:xfrm>
+            <a:off x="8394192" y="4986210"/>
+            <a:ext cx="45720" cy="801942"/>
+          </a:xfrm>
+          <a:prstGeom prst="rect">
+            <a:avLst/>
+          </a:prstGeom>
+          <a:solidFill>
+            <a:srgbClr val="2587C5"/>
+          </a:solidFill>
+          <a:ln/>
+        </p:spPr>
+      </p:sp>
+      <p:sp>
+        <p:nvSpPr>
+          <p:cNvPr id="24" name="Text 22"/>
+          <p:cNvSpPr txBox="1"/>
+          <p:nvPr/>
+        </p:nvSpPr>
+        <p:spPr>
+          <a:xfrm>
+            <a:off x="8522208" y="4986210"/>
+            <a:ext cx="2962656" cy="801942"/>
+          </a:xfrm>
+          <a:prstGeom prst="rect">
+            <a:avLst/>
+          </a:prstGeom>
+          <a:noFill/>
+          <a:ln/>
+        </p:spPr>
+        <p:txBody>
+          <a:bodyPr wrap="square" lIns="0" tIns="0" rIns="0" bIns="0" rtlCol="0" anchor="t"/>
+          <a:lstStyle/>
+          <a:p>
+            <a:pPr indent="0" marL="0">
+              <a:buNone/>
+            </a:pPr>
+            <a:r>
+              <a:rPr lang="en-US" sz="1400" b="1" dirty="0">
+                <a:solidFill>
+                  <a:srgbClr val="1A1A1A"/>
+                </a:solidFill>
+                <a:latin typeface="Inter" pitchFamily="34" charset="0"/>
+                <a:ea typeface="Inter" pitchFamily="34" charset="-122"/>
+                <a:cs typeface="Inter" pitchFamily="34" charset="-120"/>
+              </a:rPr>
+              <a:t>Tracking</a:t>
+            </a:r>
+            <a:endParaRPr lang="en-US" sz="1400" dirty="0"/>
+          </a:p>
+          <a:p>
+            <a:pPr indent="0" marL="0">
+              <a:buNone/>
+            </a:pPr>
+            <a:r>
+              <a:rPr lang="en-US" sz="1400" dirty="0">
+                <a:solidFill>
+                  <a:srgbClr val="595959"/>
+                </a:solidFill>
+                <a:latin typeface="Inter" pitchFamily="34" charset="0"/>
+                <a:ea typeface="Inter" pitchFamily="34" charset="-122"/>
+                <a:cs typeface="Inter" pitchFamily="34" charset="-120"/>
+              </a:rPr>
+              <a:t>Know your parts GP % every day, know where you stand, and adjust as needed</a:t>
+            </a:r>
+            <a:endParaRPr lang="en-US" sz="1400" dirty="0"/>
+          </a:p>
+        </p:txBody>
+      </p:sp>
+      <p:sp>
+        <p:nvSpPr>
+          <p:cNvPr id="25" name="Shape 23"/>
+          <p:cNvSpPr/>
+          <p:nvPr/>
+        </p:nvSpPr>
+        <p:spPr>
+          <a:xfrm>
             <a:off x="457200" y="6126480"/>
             <a:ext cx="11274552" cy="371856"/>
           </a:xfrm>
@@ -13923,7 +14000,7 @@
       </p:sp>
       <p:sp>
         <p:nvSpPr>
-          <p:cNvPr id="24" name="Text 22"/>
+          <p:cNvPr id="26" name="Text 24"/>
           <p:cNvSpPr txBox="1"/>
           <p:nvPr/>
         </p:nvSpPr>

</xml_diff>

<commit_message>
Day 2 deck round 5: maintenance and people wording, flat-rate pay plans, tighter opcode axes, period on variance slides, whole-number formats
Co-Authored-By: Claude Opus 5.5 <noreply@anthropic.com>
Claude-Session: https://claude.ai/code/session_01Xa4nFVxuQGXmHARGph9WhS
</commit_message>
<xml_diff>
--- a/day2-deck/decks/Metric Explainers - Review.pptx
+++ b/day2-deck/decks/Metric Explainers - Review.pptx
@@ -5810,7 +5810,7 @@
                 <a:ea typeface="Inter" pitchFamily="34" charset="-122"/>
                 <a:cs typeface="Inter" pitchFamily="34" charset="-120"/>
               </a:rPr>
-              <a:t>Service technicians, express technicians, service team leaders and shop foremen: everyone whose job is to flag hours on the line</a:t>
+              <a:t>Service technicians, express technicians, service team leaders and shop foremen: everyone whose job is to produce sold hours</a:t>
             </a:r>
             <a:endParaRPr lang="en-US" sz="1600" dirty="0"/>
           </a:p>
@@ -6118,7 +6118,7 @@
                 <a:ea typeface="Inter" pitchFamily="34" charset="-122"/>
                 <a:cs typeface="Inter" pitchFamily="34" charset="-120"/>
               </a:rPr>
-              <a:t>Keying errors removed</a:t>
+              <a:t>Keying errors</a:t>
             </a:r>
             <a:endParaRPr lang="en-US" sz="1400" dirty="0"/>
           </a:p>
@@ -6135,7 +6135,7 @@
                 <a:ea typeface="Inter" pitchFamily="34" charset="-122"/>
                 <a:cs typeface="Inter" pitchFamily="34" charset="-120"/>
               </a:rPr>
-              <a:t>45 lines, such as 940 hours keyed on one $0 line</a:t>
+              <a:t>Example: 940 hours keyed on a single $0 line</a:t>
             </a:r>
             <a:endParaRPr lang="en-US" sz="1400" dirty="0"/>
           </a:p>
@@ -6194,7 +6194,7 @@
                 <a:ea typeface="Inter" pitchFamily="34" charset="-122"/>
                 <a:cs typeface="Inter" pitchFamily="34" charset="-120"/>
               </a:rPr>
-              <a:t>Shared codes</a:t>
+              <a:t>Shared tech numbers</a:t>
             </a:r>
             <a:endParaRPr lang="en-US" sz="1400" dirty="0"/>
           </a:p>
@@ -6211,7 +6211,7 @@
                 <a:ea typeface="Inter" pitchFamily="34" charset="-122"/>
                 <a:cs typeface="Inter" pitchFamily="34" charset="-120"/>
               </a:rPr>
-              <a:t>Pooled codes (MULT, 999, 77777) aren't credited to anyone</a:t>
+              <a:t>Example: hours flagged to a shop code like 999, not a person</a:t>
             </a:r>
             <a:endParaRPr lang="en-US" sz="1400" dirty="0"/>
           </a:p>

</xml_diff>

<commit_message>
Day 2 deck round 6: value of the unknown tile, flat-rate wording, How We Measured It period and who counts, share-of-gross period; services-count variance review
Co-Authored-By: Claude Opus 5.5 <noreply@anthropic.com>
Claude-Session: https://claude.ai/code/session_01Xa4nFVxuQGXmHARGph9WhS
</commit_message>
<xml_diff>
--- a/day2-deck/decks/Metric Explainers - Review.pptx
+++ b/day2-deck/decks/Metric Explainers - Review.pptx
@@ -782,6 +782,7 @@
             <a:r>
               <a:rPr lang="en-US" dirty="0"/>
               <a:t>Source: Definitions match the data slides: Qlik - Closed Repair Orders (all customer-pay ROs, by close month), Profit &amp; Loss and Productivity apps, Jan-Sep 2026 vs 2025, same-store, 33 stores. Worked example: Service Manager Roundtable, Nov 15, 2024, slide 21.PLACE: right after 'What Is Technician Proficiency?'.
+Period: pay periods Dec 25, 2025 to Oct 9, 2026, matched by tech number, all pay types; labelled Jan-Sep 2026 YTD on the slide (Noah, Oct 26: closest the pay periods allow).
 Rules as applied on the proficiency slides (Oct 16 2026). Express techs at stores that pool express hours are mostly excluded by the 10% rule.</a:t>
             </a:r>
             <a:endParaRPr lang="en-US" dirty="0"/>
@@ -5649,7 +5650,7 @@
                 <a:ea typeface="Inter" pitchFamily="34" charset="-122"/>
                 <a:cs typeface="Inter" pitchFamily="34" charset="-120"/>
               </a:rPr>
-              <a:t>Matched by tech number, all pay types, Dec 25, 2025 to Oct 9, 2026. Store = total sold hours / total worked hours.</a:t>
+              <a:t>January through September 2026, year to date. Store = total sold hours / total worked hours.</a:t>
             </a:r>
             <a:endParaRPr lang="en-US" sz="1500" dirty="0"/>
           </a:p>
@@ -5802,7 +5803,7 @@
               <a:buChar char="•"/>
             </a:pPr>
             <a:r>
-              <a:rPr lang="en-US" sz="1600" dirty="0">
+              <a:rPr lang="en-US" sz="1500" dirty="0">
                 <a:solidFill>
                   <a:srgbClr val="1A1A1A"/>
                 </a:solidFill>
@@ -5810,9 +5811,9 @@
                 <a:ea typeface="Inter" pitchFamily="34" charset="-122"/>
                 <a:cs typeface="Inter" pitchFamily="34" charset="-120"/>
               </a:rPr>
-              <a:t>Service technicians, express technicians, service team leaders and shop foremen: everyone whose job is to produce sold hours</a:t>
-            </a:r>
-            <a:endParaRPr lang="en-US" sz="1600" dirty="0"/>
+              <a:t>Service technicians and express technicians</a:t>
+            </a:r>
+            <a:endParaRPr lang="en-US" sz="1500" dirty="0"/>
           </a:p>
           <a:p>
             <a:pPr marL="203200" indent="-203200">
@@ -5823,7 +5824,7 @@
               <a:buChar char="•"/>
             </a:pPr>
             <a:r>
-              <a:rPr lang="en-US" sz="1600" dirty="0">
+              <a:rPr lang="en-US" sz="1500" dirty="0">
                 <a:solidFill>
                   <a:srgbClr val="1A1A1A"/>
                 </a:solidFill>
@@ -5831,9 +5832,51 @@
                 <a:ea typeface="Inter" pitchFamily="34" charset="-122"/>
                 <a:cs typeface="Inter" pitchFamily="34" charset="-120"/>
               </a:rPr>
+              <a:t>Service team leaders and shop foremen</a:t>
+            </a:r>
+            <a:endParaRPr lang="en-US" sz="1500" dirty="0"/>
+          </a:p>
+          <a:p>
+            <a:pPr marL="203200" indent="-203200">
+              <a:spcAft>
+                <a:spcPts val="600"/>
+              </a:spcAft>
+              <a:buSzPct val="100000"/>
+              <a:buChar char="•"/>
+            </a:pPr>
+            <a:r>
+              <a:rPr lang="en-US" sz="1500" dirty="0">
+                <a:solidFill>
+                  <a:srgbClr val="1A1A1A"/>
+                </a:solidFill>
+                <a:latin typeface="Inter" pitchFamily="34" charset="0"/>
+                <a:ea typeface="Inter" pitchFamily="34" charset="-122"/>
+                <a:cs typeface="Inter" pitchFamily="34" charset="-120"/>
+              </a:rPr>
+              <a:t>Everyone whose job is to produce sold hours</a:t>
+            </a:r>
+            <a:endParaRPr lang="en-US" sz="1500" dirty="0"/>
+          </a:p>
+          <a:p>
+            <a:pPr marL="203200" indent="-203200">
+              <a:spcAft>
+                <a:spcPts val="600"/>
+              </a:spcAft>
+              <a:buSzPct val="100000"/>
+              <a:buChar char="•"/>
+            </a:pPr>
+            <a:r>
+              <a:rPr lang="en-US" sz="1500" dirty="0">
+                <a:solidFill>
+                  <a:srgbClr val="1A1A1A"/>
+                </a:solidFill>
+                <a:latin typeface="Inter" pitchFamily="34" charset="0"/>
+                <a:ea typeface="Inter" pitchFamily="34" charset="-122"/>
+                <a:cs typeface="Inter" pitchFamily="34" charset="-120"/>
+              </a:rPr>
               <a:t>Not counted: body shop, detail and tint</a:t>
             </a:r>
-            <a:endParaRPr lang="en-US" sz="1600" dirty="0"/>
+            <a:endParaRPr lang="en-US" sz="1500" dirty="0"/>
           </a:p>
         </p:txBody>
       </p:sp>

</xml_diff>

<commit_message>
Proficiency/efficiency/productivity definitions slide; movers turnaround blue bar example (TURN=1)
Co-Authored-By: Claude Opus 5.5 <noreply@anthropic.com>
Claude-Session: https://claude.ai/code/session_01Xa4nFVxuQGXmHARGph9WhS
</commit_message>
<xml_diff>
--- a/day2-deck/decks/Metric Explainers - Review.pptx
+++ b/day2-deck/decks/Metric Explainers - Review.pptx
@@ -18,9 +18,10 @@
     <p:sldId id="266" r:id="rId12"/>
     <p:sldId id="267" r:id="rId13"/>
     <p:sldId id="268" r:id="rId14"/>
+    <p:sldId id="269" r:id="rId15"/>
   </p:sldIdLst>
   <p:notesMasterIdLst>
-    <p:notesMasterId r:id="rId15"/>
+    <p:notesMasterId r:id="rId16"/>
   </p:notesMasterIdLst>
   <p:sldSz cx="12192000" cy="6858000"/>
   <p:notesSz cx="6858000" cy="12192000"/>
@@ -914,6 +915,95 @@
 </p:notes>
 </file>
 
+<file path=ppt/notesSlides/notesSlide14.xml><?xml version="1.0" encoding="utf-8"?>
+<p:notes xmlns:a="http://schemas.openxmlformats.org/drawingml/2006/main" xmlns:r="http://schemas.openxmlformats.org/officeDocument/2006/relationships" xmlns:p="http://schemas.openxmlformats.org/presentationml/2006/main">
+  <p:cSld>
+    <p:spTree>
+      <p:nvGrpSpPr>
+        <p:cNvPr id="1" name=""/>
+        <p:cNvGrpSpPr/>
+        <p:nvPr/>
+      </p:nvGrpSpPr>
+      <p:grpSpPr>
+        <a:xfrm>
+          <a:off x="0" y="0"/>
+          <a:ext cx="0" cy="0"/>
+          <a:chOff x="0" y="0"/>
+          <a:chExt cx="0" cy="0"/>
+        </a:xfrm>
+      </p:grpSpPr>
+      <p:sp>
+        <p:nvSpPr>
+          <p:cNvPr id="2" name="Slide Image Placeholder 1"/>
+          <p:cNvSpPr>
+            <a:spLocks noGrp="1" noRot="1" noChangeAspect="1"/>
+          </p:cNvSpPr>
+          <p:nvPr>
+            <p:ph type="sldImg"/>
+          </p:nvPr>
+        </p:nvSpPr>
+        <p:spPr/>
+      </p:sp>
+      <p:sp>
+        <p:nvSpPr>
+          <p:cNvPr id="3" name="Notes Placeholder 2"/>
+          <p:cNvSpPr>
+            <a:spLocks noGrp="1"/>
+          </p:cNvSpPr>
+          <p:nvPr>
+            <p:ph type="body" idx="1"/>
+          </p:nvPr>
+        </p:nvSpPr>
+        <p:spPr/>
+        <p:txBody>
+          <a:bodyPr/>
+          <a:lstStyle/>
+          <a:p>
+            <a:r>
+              <a:rPr lang="en-US" dirty="0"/>
+              <a:t>Source: Standard service-department definitions. Proficiency on the store slides = Qlik sold hours ÷ ADP regular + overtime hours. Efficiency and productivity need DMS time clocked on ROs, which this data does not include, so they are defined here but not measured.PLACE: right after the Technician Proficiency explainer, before How We Measured It (Noah, Oct 27).
+Talk track: proficiency is the one we measure; efficiency and productivity explain why it is low. High efficiency with low proficiency means the tech is waiting. 'Productivity' here is the technician measure, not the Fixed Ops Productivity section (gross and ROs per employee).</a:t>
+            </a:r>
+            <a:endParaRPr lang="en-US" dirty="0"/>
+          </a:p>
+        </p:txBody>
+      </p:sp>
+      <p:sp>
+        <p:nvSpPr>
+          <p:cNvPr id="4" name="Slide Number Placeholder 3"/>
+          <p:cNvSpPr>
+            <a:spLocks noGrp="1"/>
+          </p:cNvSpPr>
+          <p:nvPr>
+            <p:ph type="sldNum" sz="quarter" idx="10"/>
+          </p:nvPr>
+        </p:nvSpPr>
+        <p:spPr/>
+        <p:txBody>
+          <a:bodyPr/>
+          <a:lstStyle/>
+          <a:p>
+            <a:fld id="{F7021451-1387-4CA6-816F-3879F97B5CBC}" type="slidenum">
+              <a:rPr lang="en-US"/>
+              <a:t>14</a:t>
+            </a:fld>
+            <a:endParaRPr lang="en-US"/>
+          </a:p>
+        </p:txBody>
+      </p:sp>
+    </p:spTree>
+    <p:extLst>
+      <p:ext uri="{BB962C8B-B14F-4D97-AF65-F5344CB8AC3E}">
+        <p14:creationId xmlns:p14="http://schemas.microsoft.com/office/powerpoint/2010/main" val="1024086991"/>
+      </p:ext>
+    </p:extLst>
+  </p:cSld>
+  <p:clrMapOvr>
+    <a:masterClrMapping/>
+  </p:clrMapOvr>
+</p:notes>
+</file>
+
 <file path=ppt/notesSlides/notesSlide2.xml><?xml version="1.0" encoding="utf-8"?>
 <p:notes xmlns:a="http://schemas.openxmlformats.org/drawingml/2006/main" xmlns:r="http://schemas.openxmlformats.org/officeDocument/2006/relationships" xmlns:p="http://schemas.openxmlformats.org/presentationml/2006/main">
   <p:cSld>
@@ -7523,6 +7613,672 @@
               <a:t>Group: $188.80M fixed ops gross Jan–Sep 2026, up $7.47M (4.1%): service +$6.30M, parts +$1.17M.</a:t>
             </a:r>
             <a:endParaRPr lang="en-US" sz="1600" dirty="0"/>
+          </a:p>
+        </p:txBody>
+      </p:sp>
+    </p:spTree>
+  </p:cSld>
+  <p:clrMapOvr>
+    <a:masterClrMapping/>
+  </p:clrMapOvr>
+</p:sld>
+</file>
+
+<file path=ppt/slides/slide14.xml><?xml version="1.0" encoding="utf-8"?>
+<p:sld xmlns:a="http://schemas.openxmlformats.org/drawingml/2006/main" xmlns:r="http://schemas.openxmlformats.org/officeDocument/2006/relationships" xmlns:p="http://schemas.openxmlformats.org/presentationml/2006/main">
+  <p:cSld name="Slide 14">
+    <p:bg>
+      <p:bgPr>
+        <a:solidFill>
+          <a:srgbClr val="EDEDED"/>
+        </a:solidFill>
+      </p:bgPr>
+    </p:bg>
+    <p:spTree>
+      <p:nvGrpSpPr>
+        <p:cNvPr id="1" name=""/>
+        <p:cNvGrpSpPr/>
+        <p:nvPr/>
+      </p:nvGrpSpPr>
+      <p:grpSpPr>
+        <a:xfrm>
+          <a:off x="0" y="0"/>
+          <a:ext cx="0" cy="0"/>
+          <a:chOff x="0" y="0"/>
+          <a:chExt cx="0" cy="0"/>
+        </a:xfrm>
+      </p:grpSpPr>
+      <p:sp>
+        <p:nvSpPr>
+          <p:cNvPr id="2" name="Shape 0"/>
+          <p:cNvSpPr/>
+          <p:nvPr/>
+        </p:nvSpPr>
+        <p:spPr>
+          <a:xfrm>
+            <a:off x="457200" y="402336"/>
+            <a:ext cx="50292" cy="192024"/>
+          </a:xfrm>
+          <a:prstGeom prst="rect">
+            <a:avLst/>
+          </a:prstGeom>
+          <a:solidFill>
+            <a:srgbClr val="2587C5"/>
+          </a:solidFill>
+          <a:ln/>
+        </p:spPr>
+      </p:sp>
+      <p:sp>
+        <p:nvSpPr>
+          <p:cNvPr id="3" name="Text 1"/>
+          <p:cNvSpPr txBox="1"/>
+          <p:nvPr/>
+        </p:nvSpPr>
+        <p:spPr>
+          <a:xfrm>
+            <a:off x="621792" y="338328"/>
+            <a:ext cx="8229600" cy="274320"/>
+          </a:xfrm>
+          <a:prstGeom prst="rect">
+            <a:avLst/>
+          </a:prstGeom>
+          <a:noFill/>
+          <a:ln/>
+        </p:spPr>
+        <p:txBody>
+          <a:bodyPr wrap="square" lIns="0" tIns="0" rIns="0" bIns="0" rtlCol="0" anchor="ctr"/>
+          <a:lstStyle/>
+          <a:p>
+            <a:pPr indent="0" marL="0">
+              <a:buNone/>
+            </a:pPr>
+            <a:r>
+              <a:rPr lang="en-US" sz="1400" b="1" spc="110" kern="0" dirty="0">
+                <a:solidFill>
+                  <a:srgbClr val="595959"/>
+                </a:solidFill>
+                <a:latin typeface="Inter" pitchFamily="34" charset="0"/>
+                <a:ea typeface="Inter" pitchFamily="34" charset="-122"/>
+                <a:cs typeface="Inter" pitchFamily="34" charset="-120"/>
+              </a:rPr>
+              <a:t>TECHNICIAN PROFICIENCY</a:t>
+            </a:r>
+            <a:endParaRPr lang="en-US" sz="1400" dirty="0"/>
+          </a:p>
+        </p:txBody>
+      </p:sp>
+      <p:sp>
+        <p:nvSpPr>
+          <p:cNvPr id="4" name="Text 2"/>
+          <p:cNvSpPr txBox="1"/>
+          <p:nvPr/>
+        </p:nvSpPr>
+        <p:spPr>
+          <a:xfrm>
+            <a:off x="457200" y="640080"/>
+            <a:ext cx="11338560" cy="502920"/>
+          </a:xfrm>
+          <a:prstGeom prst="rect">
+            <a:avLst/>
+          </a:prstGeom>
+          <a:noFill/>
+          <a:ln/>
+        </p:spPr>
+        <p:txBody>
+          <a:bodyPr wrap="square" lIns="0" tIns="0" rIns="0" bIns="0" rtlCol="0" anchor="ctr"/>
+          <a:lstStyle/>
+          <a:p>
+            <a:pPr indent="0" marL="0">
+              <a:buNone/>
+            </a:pPr>
+            <a:r>
+              <a:rPr lang="en-US" sz="2800" dirty="0">
+                <a:solidFill>
+                  <a:srgbClr val="1A1A1A"/>
+                </a:solidFill>
+                <a:latin typeface="Inter" pitchFamily="34" charset="0"/>
+                <a:ea typeface="Inter" pitchFamily="34" charset="-122"/>
+                <a:cs typeface="Inter" pitchFamily="34" charset="-120"/>
+              </a:rPr>
+              <a:t>Proficiency, Efficiency and Productivity</a:t>
+            </a:r>
+            <a:endParaRPr lang="en-US" sz="2800" dirty="0"/>
+          </a:p>
+        </p:txBody>
+      </p:sp>
+      <p:sp>
+        <p:nvSpPr>
+          <p:cNvPr id="5" name="Shape 3"/>
+          <p:cNvSpPr/>
+          <p:nvPr/>
+        </p:nvSpPr>
+        <p:spPr>
+          <a:xfrm>
+            <a:off x="457200" y="1207008"/>
+            <a:ext cx="11274552" cy="5148072"/>
+          </a:xfrm>
+          <a:prstGeom prst="rect">
+            <a:avLst/>
+          </a:prstGeom>
+          <a:solidFill>
+            <a:srgbClr val="FFFFFF"/>
+          </a:solidFill>
+          <a:ln/>
+        </p:spPr>
+      </p:sp>
+      <p:sp>
+        <p:nvSpPr>
+          <p:cNvPr id="6" name="Shape 4"/>
+          <p:cNvSpPr/>
+          <p:nvPr/>
+        </p:nvSpPr>
+        <p:spPr>
+          <a:xfrm>
+            <a:off x="713232" y="1481328"/>
+            <a:ext cx="3453384" cy="3017520"/>
+          </a:xfrm>
+          <a:prstGeom prst="rect">
+            <a:avLst/>
+          </a:prstGeom>
+          <a:solidFill>
+            <a:srgbClr val="F7F7F7"/>
+          </a:solidFill>
+          <a:ln/>
+        </p:spPr>
+      </p:sp>
+      <p:sp>
+        <p:nvSpPr>
+          <p:cNvPr id="7" name="Shape 5"/>
+          <p:cNvSpPr/>
+          <p:nvPr/>
+        </p:nvSpPr>
+        <p:spPr>
+          <a:xfrm>
+            <a:off x="713232" y="1481328"/>
+            <a:ext cx="3453384" cy="64008"/>
+          </a:xfrm>
+          <a:prstGeom prst="rect">
+            <a:avLst/>
+          </a:prstGeom>
+          <a:solidFill>
+            <a:srgbClr val="2587C5"/>
+          </a:solidFill>
+          <a:ln/>
+        </p:spPr>
+      </p:sp>
+      <p:sp>
+        <p:nvSpPr>
+          <p:cNvPr id="8" name="Text 6"/>
+          <p:cNvSpPr txBox="1"/>
+          <p:nvPr/>
+        </p:nvSpPr>
+        <p:spPr>
+          <a:xfrm>
+            <a:off x="896112" y="1691640"/>
+            <a:ext cx="3087624" cy="566928"/>
+          </a:xfrm>
+          <a:prstGeom prst="rect">
+            <a:avLst/>
+          </a:prstGeom>
+          <a:noFill/>
+          <a:ln/>
+        </p:spPr>
+        <p:txBody>
+          <a:bodyPr wrap="square" lIns="0" tIns="0" rIns="0" bIns="0" rtlCol="0" anchor="t"/>
+          <a:lstStyle/>
+          <a:p>
+            <a:pPr indent="0" marL="0">
+              <a:buNone/>
+            </a:pPr>
+            <a:r>
+              <a:rPr lang="en-US" sz="1400" b="1" spc="80" kern="0" dirty="0">
+                <a:solidFill>
+                  <a:srgbClr val="595959"/>
+                </a:solidFill>
+                <a:latin typeface="Inter" pitchFamily="34" charset="0"/>
+                <a:ea typeface="Inter" pitchFamily="34" charset="-122"/>
+                <a:cs typeface="Inter" pitchFamily="34" charset="-120"/>
+              </a:rPr>
+              <a:t>PROFICIENCY</a:t>
+            </a:r>
+            <a:endParaRPr lang="en-US" sz="1400" dirty="0"/>
+          </a:p>
+        </p:txBody>
+      </p:sp>
+      <p:sp>
+        <p:nvSpPr>
+          <p:cNvPr id="9" name="Text 7"/>
+          <p:cNvSpPr txBox="1"/>
+          <p:nvPr/>
+        </p:nvSpPr>
+        <p:spPr>
+          <a:xfrm>
+            <a:off x="896112" y="2286000"/>
+            <a:ext cx="3087624" cy="868680"/>
+          </a:xfrm>
+          <a:prstGeom prst="rect">
+            <a:avLst/>
+          </a:prstGeom>
+          <a:noFill/>
+          <a:ln/>
+        </p:spPr>
+        <p:txBody>
+          <a:bodyPr wrap="square" lIns="0" tIns="0" rIns="0" bIns="0" rtlCol="0" anchor="ctr">
+            <a:normAutofit/>
+          </a:bodyPr>
+          <a:lstStyle/>
+          <a:p>
+            <a:pPr indent="0" marL="0">
+              <a:buNone/>
+            </a:pPr>
+            <a:r>
+              <a:rPr lang="en-US" sz="2600" b="1" dirty="0">
+                <a:solidFill>
+                  <a:srgbClr val="0B2C4A"/>
+                </a:solidFill>
+                <a:latin typeface="Inter" pitchFamily="34" charset="0"/>
+                <a:ea typeface="Inter" pitchFamily="34" charset="-122"/>
+                <a:cs typeface="Inter" pitchFamily="34" charset="-120"/>
+              </a:rPr>
+              <a:t>Sold hours ÷ hours worked</a:t>
+            </a:r>
+            <a:endParaRPr lang="en-US" sz="2600" dirty="0"/>
+          </a:p>
+        </p:txBody>
+      </p:sp>
+      <p:sp>
+        <p:nvSpPr>
+          <p:cNvPr id="10" name="Text 8"/>
+          <p:cNvSpPr txBox="1"/>
+          <p:nvPr/>
+        </p:nvSpPr>
+        <p:spPr>
+          <a:xfrm>
+            <a:off x="896112" y="3200400"/>
+            <a:ext cx="3087624" cy="1188720"/>
+          </a:xfrm>
+          <a:prstGeom prst="rect">
+            <a:avLst/>
+          </a:prstGeom>
+          <a:noFill/>
+          <a:ln/>
+        </p:spPr>
+        <p:txBody>
+          <a:bodyPr wrap="square" lIns="0" tIns="0" rIns="0" bIns="0" rtlCol="0" anchor="t"/>
+          <a:lstStyle/>
+          <a:p>
+            <a:pPr indent="0" marL="0">
+              <a:buNone/>
+            </a:pPr>
+            <a:r>
+              <a:rPr lang="en-US" sz="1500" dirty="0">
+                <a:solidFill>
+                  <a:srgbClr val="1A1A1A"/>
+                </a:solidFill>
+                <a:latin typeface="Inter" pitchFamily="34" charset="0"/>
+                <a:ea typeface="Inter" pitchFamily="34" charset="-122"/>
+                <a:cs typeface="Inter" pitchFamily="34" charset="-120"/>
+              </a:rPr>
+              <a:t>How many hours a tech flags for every hour they are at work. The measure on these slides: 85% target, group 94.7%.</a:t>
+            </a:r>
+            <a:endParaRPr lang="en-US" sz="1500" dirty="0"/>
+          </a:p>
+        </p:txBody>
+      </p:sp>
+      <p:sp>
+        <p:nvSpPr>
+          <p:cNvPr id="11" name="Shape 9"/>
+          <p:cNvSpPr/>
+          <p:nvPr/>
+        </p:nvSpPr>
+        <p:spPr>
+          <a:xfrm>
+            <a:off x="4367784" y="1481328"/>
+            <a:ext cx="3453384" cy="3017520"/>
+          </a:xfrm>
+          <a:prstGeom prst="rect">
+            <a:avLst/>
+          </a:prstGeom>
+          <a:solidFill>
+            <a:srgbClr val="F7F7F7"/>
+          </a:solidFill>
+          <a:ln/>
+        </p:spPr>
+      </p:sp>
+      <p:sp>
+        <p:nvSpPr>
+          <p:cNvPr id="12" name="Shape 10"/>
+          <p:cNvSpPr/>
+          <p:nvPr/>
+        </p:nvSpPr>
+        <p:spPr>
+          <a:xfrm>
+            <a:off x="4367784" y="1481328"/>
+            <a:ext cx="3453384" cy="64008"/>
+          </a:xfrm>
+          <a:prstGeom prst="rect">
+            <a:avLst/>
+          </a:prstGeom>
+          <a:solidFill>
+            <a:srgbClr val="2587C5"/>
+          </a:solidFill>
+          <a:ln/>
+        </p:spPr>
+      </p:sp>
+      <p:sp>
+        <p:nvSpPr>
+          <p:cNvPr id="13" name="Text 11"/>
+          <p:cNvSpPr txBox="1"/>
+          <p:nvPr/>
+        </p:nvSpPr>
+        <p:spPr>
+          <a:xfrm>
+            <a:off x="4550664" y="1691640"/>
+            <a:ext cx="3087624" cy="566928"/>
+          </a:xfrm>
+          <a:prstGeom prst="rect">
+            <a:avLst/>
+          </a:prstGeom>
+          <a:noFill/>
+          <a:ln/>
+        </p:spPr>
+        <p:txBody>
+          <a:bodyPr wrap="square" lIns="0" tIns="0" rIns="0" bIns="0" rtlCol="0" anchor="t"/>
+          <a:lstStyle/>
+          <a:p>
+            <a:pPr indent="0" marL="0">
+              <a:buNone/>
+            </a:pPr>
+            <a:r>
+              <a:rPr lang="en-US" sz="1400" b="1" spc="80" kern="0" dirty="0">
+                <a:solidFill>
+                  <a:srgbClr val="595959"/>
+                </a:solidFill>
+                <a:latin typeface="Inter" pitchFamily="34" charset="0"/>
+                <a:ea typeface="Inter" pitchFamily="34" charset="-122"/>
+                <a:cs typeface="Inter" pitchFamily="34" charset="-120"/>
+              </a:rPr>
+              <a:t>EFFICIENCY</a:t>
+            </a:r>
+            <a:endParaRPr lang="en-US" sz="1400" dirty="0"/>
+          </a:p>
+        </p:txBody>
+      </p:sp>
+      <p:sp>
+        <p:nvSpPr>
+          <p:cNvPr id="14" name="Text 12"/>
+          <p:cNvSpPr txBox="1"/>
+          <p:nvPr/>
+        </p:nvSpPr>
+        <p:spPr>
+          <a:xfrm>
+            <a:off x="4550664" y="2286000"/>
+            <a:ext cx="3087624" cy="868680"/>
+          </a:xfrm>
+          <a:prstGeom prst="rect">
+            <a:avLst/>
+          </a:prstGeom>
+          <a:noFill/>
+          <a:ln/>
+        </p:spPr>
+        <p:txBody>
+          <a:bodyPr wrap="square" lIns="0" tIns="0" rIns="0" bIns="0" rtlCol="0" anchor="ctr">
+            <a:normAutofit/>
+          </a:bodyPr>
+          <a:lstStyle/>
+          <a:p>
+            <a:pPr indent="0" marL="0">
+              <a:buNone/>
+            </a:pPr>
+            <a:r>
+              <a:rPr lang="en-US" sz="2600" b="1" dirty="0">
+                <a:solidFill>
+                  <a:srgbClr val="0B2C4A"/>
+                </a:solidFill>
+                <a:latin typeface="Inter" pitchFamily="34" charset="0"/>
+                <a:ea typeface="Inter" pitchFamily="34" charset="-122"/>
+                <a:cs typeface="Inter" pitchFamily="34" charset="-120"/>
+              </a:rPr>
+              <a:t>Sold hours ÷ hours on ROs</a:t>
+            </a:r>
+            <a:endParaRPr lang="en-US" sz="2600" dirty="0"/>
+          </a:p>
+        </p:txBody>
+      </p:sp>
+      <p:sp>
+        <p:nvSpPr>
+          <p:cNvPr id="15" name="Text 13"/>
+          <p:cNvSpPr txBox="1"/>
+          <p:nvPr/>
+        </p:nvSpPr>
+        <p:spPr>
+          <a:xfrm>
+            <a:off x="4550664" y="3200400"/>
+            <a:ext cx="3087624" cy="1188720"/>
+          </a:xfrm>
+          <a:prstGeom prst="rect">
+            <a:avLst/>
+          </a:prstGeom>
+          <a:noFill/>
+          <a:ln/>
+        </p:spPr>
+        <p:txBody>
+          <a:bodyPr wrap="square" lIns="0" tIns="0" rIns="0" bIns="0" rtlCol="0" anchor="t"/>
+          <a:lstStyle/>
+          <a:p>
+            <a:pPr indent="0" marL="0">
+              <a:buNone/>
+            </a:pPr>
+            <a:r>
+              <a:rPr lang="en-US" sz="1500" dirty="0">
+                <a:solidFill>
+                  <a:srgbClr val="1A1A1A"/>
+                </a:solidFill>
+                <a:latin typeface="Inter" pitchFamily="34" charset="0"/>
+                <a:ea typeface="Inter" pitchFamily="34" charset="-122"/>
+                <a:cs typeface="Inter" pitchFamily="34" charset="-120"/>
+              </a:rPr>
+              <a:t>How fast a tech does the work: hours flagged against the time actually clocked on repair orders. Over 100% beats book time.</a:t>
+            </a:r>
+            <a:endParaRPr lang="en-US" sz="1500" dirty="0"/>
+          </a:p>
+        </p:txBody>
+      </p:sp>
+      <p:sp>
+        <p:nvSpPr>
+          <p:cNvPr id="16" name="Shape 14"/>
+          <p:cNvSpPr/>
+          <p:nvPr/>
+        </p:nvSpPr>
+        <p:spPr>
+          <a:xfrm>
+            <a:off x="8022336" y="1481328"/>
+            <a:ext cx="3453384" cy="3017520"/>
+          </a:xfrm>
+          <a:prstGeom prst="rect">
+            <a:avLst/>
+          </a:prstGeom>
+          <a:solidFill>
+            <a:srgbClr val="F7F7F7"/>
+          </a:solidFill>
+          <a:ln/>
+        </p:spPr>
+      </p:sp>
+      <p:sp>
+        <p:nvSpPr>
+          <p:cNvPr id="17" name="Shape 15"/>
+          <p:cNvSpPr/>
+          <p:nvPr/>
+        </p:nvSpPr>
+        <p:spPr>
+          <a:xfrm>
+            <a:off x="8022336" y="1481328"/>
+            <a:ext cx="3453384" cy="64008"/>
+          </a:xfrm>
+          <a:prstGeom prst="rect">
+            <a:avLst/>
+          </a:prstGeom>
+          <a:solidFill>
+            <a:srgbClr val="2587C5"/>
+          </a:solidFill>
+          <a:ln/>
+        </p:spPr>
+      </p:sp>
+      <p:sp>
+        <p:nvSpPr>
+          <p:cNvPr id="18" name="Text 16"/>
+          <p:cNvSpPr txBox="1"/>
+          <p:nvPr/>
+        </p:nvSpPr>
+        <p:spPr>
+          <a:xfrm>
+            <a:off x="8205216" y="1691640"/>
+            <a:ext cx="3087624" cy="566928"/>
+          </a:xfrm>
+          <a:prstGeom prst="rect">
+            <a:avLst/>
+          </a:prstGeom>
+          <a:noFill/>
+          <a:ln/>
+        </p:spPr>
+        <p:txBody>
+          <a:bodyPr wrap="square" lIns="0" tIns="0" rIns="0" bIns="0" rtlCol="0" anchor="t"/>
+          <a:lstStyle/>
+          <a:p>
+            <a:pPr indent="0" marL="0">
+              <a:buNone/>
+            </a:pPr>
+            <a:r>
+              <a:rPr lang="en-US" sz="1400" b="1" spc="80" kern="0" dirty="0">
+                <a:solidFill>
+                  <a:srgbClr val="595959"/>
+                </a:solidFill>
+                <a:latin typeface="Inter" pitchFamily="34" charset="0"/>
+                <a:ea typeface="Inter" pitchFamily="34" charset="-122"/>
+                <a:cs typeface="Inter" pitchFamily="34" charset="-120"/>
+              </a:rPr>
+              <a:t>PRODUCTIVITY</a:t>
+            </a:r>
+            <a:endParaRPr lang="en-US" sz="1400" dirty="0"/>
+          </a:p>
+        </p:txBody>
+      </p:sp>
+      <p:sp>
+        <p:nvSpPr>
+          <p:cNvPr id="19" name="Text 17"/>
+          <p:cNvSpPr txBox="1"/>
+          <p:nvPr/>
+        </p:nvSpPr>
+        <p:spPr>
+          <a:xfrm>
+            <a:off x="8205216" y="2286000"/>
+            <a:ext cx="3087624" cy="868680"/>
+          </a:xfrm>
+          <a:prstGeom prst="rect">
+            <a:avLst/>
+          </a:prstGeom>
+          <a:noFill/>
+          <a:ln/>
+        </p:spPr>
+        <p:txBody>
+          <a:bodyPr wrap="square" lIns="0" tIns="0" rIns="0" bIns="0" rtlCol="0" anchor="ctr">
+            <a:normAutofit/>
+          </a:bodyPr>
+          <a:lstStyle/>
+          <a:p>
+            <a:pPr indent="0" marL="0">
+              <a:buNone/>
+            </a:pPr>
+            <a:r>
+              <a:rPr lang="en-US" sz="2600" b="1" dirty="0">
+                <a:solidFill>
+                  <a:srgbClr val="0B2C4A"/>
+                </a:solidFill>
+                <a:latin typeface="Inter" pitchFamily="34" charset="0"/>
+                <a:ea typeface="Inter" pitchFamily="34" charset="-122"/>
+                <a:cs typeface="Inter" pitchFamily="34" charset="-120"/>
+              </a:rPr>
+              <a:t>Hours on ROs ÷ hours worked</a:t>
+            </a:r>
+            <a:endParaRPr lang="en-US" sz="2600" dirty="0"/>
+          </a:p>
+        </p:txBody>
+      </p:sp>
+      <p:sp>
+        <p:nvSpPr>
+          <p:cNvPr id="20" name="Text 18"/>
+          <p:cNvSpPr txBox="1"/>
+          <p:nvPr/>
+        </p:nvSpPr>
+        <p:spPr>
+          <a:xfrm>
+            <a:off x="8205216" y="3200400"/>
+            <a:ext cx="3087624" cy="1188720"/>
+          </a:xfrm>
+          <a:prstGeom prst="rect">
+            <a:avLst/>
+          </a:prstGeom>
+          <a:noFill/>
+          <a:ln/>
+        </p:spPr>
+        <p:txBody>
+          <a:bodyPr wrap="square" lIns="0" tIns="0" rIns="0" bIns="0" rtlCol="0" anchor="t"/>
+          <a:lstStyle/>
+          <a:p>
+            <a:pPr indent="0" marL="0">
+              <a:buNone/>
+            </a:pPr>
+            <a:r>
+              <a:rPr lang="en-US" sz="1500" dirty="0">
+                <a:solidFill>
+                  <a:srgbClr val="1A1A1A"/>
+                </a:solidFill>
+                <a:latin typeface="Inter" pitchFamily="34" charset="0"/>
+                <a:ea typeface="Inter" pitchFamily="34" charset="-122"/>
+                <a:cs typeface="Inter" pitchFamily="34" charset="-120"/>
+              </a:rPr>
+              <a:t>How much of the day a tech spends on customer work instead of waiting on parts, dispatch or approvals.</a:t>
+            </a:r>
+            <a:endParaRPr lang="en-US" sz="1500" dirty="0"/>
+          </a:p>
+        </p:txBody>
+      </p:sp>
+      <p:sp>
+        <p:nvSpPr>
+          <p:cNvPr id="21" name="Text 19"/>
+          <p:cNvSpPr txBox="1"/>
+          <p:nvPr/>
+        </p:nvSpPr>
+        <p:spPr>
+          <a:xfrm>
+            <a:off x="713232" y="4709160"/>
+            <a:ext cx="10762488" cy="914400"/>
+          </a:xfrm>
+          <a:prstGeom prst="rect">
+            <a:avLst/>
+          </a:prstGeom>
+          <a:noFill/>
+          <a:ln/>
+        </p:spPr>
+        <p:txBody>
+          <a:bodyPr wrap="square" lIns="0" tIns="0" rIns="0" bIns="0" rtlCol="0" anchor="ctr"/>
+          <a:lstStyle/>
+          <a:p>
+            <a:pPr indent="0" marL="0">
+              <a:buNone/>
+            </a:pPr>
+            <a:r>
+              <a:rPr lang="en-US" sz="1700" dirty="0">
+                <a:solidFill>
+                  <a:srgbClr val="1A1A1A"/>
+                </a:solidFill>
+                <a:latin typeface="Inter" pitchFamily="34" charset="0"/>
+                <a:ea typeface="Inter" pitchFamily="34" charset="-122"/>
+                <a:cs typeface="Inter" pitchFamily="34" charset="-120"/>
+              </a:rPr>
+              <a:t>Proficiency = efficiency × productivity. A fast tech with nothing to work on is efficient but not proficient: the fix is dispatch, parts and approvals, not the tech.</a:t>
+            </a:r>
+            <a:endParaRPr lang="en-US" sz="1700" dirty="0"/>
           </a:p>
         </p:txBody>
       </p:sp>

</xml_diff>

<commit_message>
Proficiency/efficiency/productivity slide rebuilt with Noah's definitions and a labelled example
Co-Authored-By: Claude Opus 5.5 <noreply@anthropic.com>
Claude-Session: https://claude.ai/code/session_01Xa4nFVxuQGXmHARGph9WhS
</commit_message>
<xml_diff>
--- a/day2-deck/decks/Metric Explainers - Review.pptx
+++ b/day2-deck/decks/Metric Explainers - Review.pptx
@@ -961,8 +961,8 @@
           <a:p>
             <a:r>
               <a:rPr lang="en-US" dirty="0"/>
-              <a:t>Source: Standard service-department definitions. Proficiency on the store slides = Qlik sold hours ÷ ADP regular + overtime hours. Efficiency and productivity need DMS time clocked on ROs, which this data does not include, so they are defined here but not measured.PLACE: right after the Technician Proficiency explainer, before How We Measured It (Noah, Oct 27).
-Talk track: proficiency is the one we measure; efficiency and productivity explain why it is low. High efficiency with low proficiency means the tech is waiting. 'Productivity' here is the technician measure, not the Fixed Ops Productivity section (gross and ROs per employee).</a:t>
+              <a:t>Source: Standard service-department definitions. On the store slides, proficiency = Qlik hours flagged (sold hours) ÷ ADP regular + overtime hours, which stand in for available hours. Efficiency and productivity need DMS time clocked to repair orders, which this data does not include, so they are defined here but not measured. The example is illustrative, not a store or technician.PLACE: right after the Technician Proficiency explainer, before How We Measured It (Noah, Oct 27).
+Talk track: walk the example left to right. The tech was on repair orders 6 of 8 hours (75% productive) and flagged 7.5 hours in those 6 (125% efficient), so 7.5 flagged hours for 8 available (93.75% proficient). Proficiency is the one we measure: 85% target, group 94.7%. 'Productivity' here is the technician measure, not the Fixed Ops Productivity section (gross and ROs per employee).</a:t>
             </a:r>
             <a:endParaRPr lang="en-US" dirty="0"/>
           </a:p>
@@ -7755,7 +7755,7 @@
         <p:spPr>
           <a:xfrm>
             <a:off x="457200" y="1207008"/>
-            <a:ext cx="11274552" cy="5148072"/>
+            <a:ext cx="11274552" cy="4782312"/>
           </a:xfrm>
           <a:prstGeom prst="rect">
             <a:avLst/>
@@ -7774,8 +7774,8 @@
         </p:nvSpPr>
         <p:spPr>
           <a:xfrm>
-            <a:off x="713232" y="1481328"/>
-            <a:ext cx="3453384" cy="3017520"/>
+            <a:off x="713232" y="1417320"/>
+            <a:ext cx="3453384" cy="2926080"/>
           </a:xfrm>
           <a:prstGeom prst="rect">
             <a:avLst/>
@@ -7794,7 +7794,7 @@
         </p:nvSpPr>
         <p:spPr>
           <a:xfrm>
-            <a:off x="713232" y="1481328"/>
+            <a:off x="713232" y="1417320"/>
             <a:ext cx="3453384" cy="64008"/>
           </a:xfrm>
           <a:prstGeom prst="rect">
@@ -7814,8 +7814,47 @@
         </p:nvSpPr>
         <p:spPr>
           <a:xfrm>
-            <a:off x="896112" y="1691640"/>
-            <a:ext cx="3087624" cy="566928"/>
+            <a:off x="896112" y="1600200"/>
+            <a:ext cx="3087624" cy="274320"/>
+          </a:xfrm>
+          <a:prstGeom prst="rect">
+            <a:avLst/>
+          </a:prstGeom>
+          <a:noFill/>
+          <a:ln/>
+        </p:spPr>
+        <p:txBody>
+          <a:bodyPr wrap="square" lIns="0" tIns="0" rIns="0" bIns="0" rtlCol="0" anchor="ctr"/>
+          <a:lstStyle/>
+          <a:p>
+            <a:pPr indent="0" marL="0">
+              <a:buNone/>
+            </a:pPr>
+            <a:r>
+              <a:rPr lang="en-US" sz="1400" b="1" spc="80" kern="0" dirty="0">
+                <a:solidFill>
+                  <a:srgbClr val="595959"/>
+                </a:solidFill>
+                <a:latin typeface="Inter" pitchFamily="34" charset="0"/>
+                <a:ea typeface="Inter" pitchFamily="34" charset="-122"/>
+                <a:cs typeface="Inter" pitchFamily="34" charset="-120"/>
+              </a:rPr>
+              <a:t>PRODUCTIVITY</a:t>
+            </a:r>
+            <a:endParaRPr lang="en-US" sz="1400" dirty="0"/>
+          </a:p>
+        </p:txBody>
+      </p:sp>
+      <p:sp>
+        <p:nvSpPr>
+          <p:cNvPr id="9" name="Text 7"/>
+          <p:cNvSpPr txBox="1"/>
+          <p:nvPr/>
+        </p:nvSpPr>
+        <p:spPr>
+          <a:xfrm>
+            <a:off x="896112" y="1920240"/>
+            <a:ext cx="3087624" cy="685800"/>
           </a:xfrm>
           <a:prstGeom prst="rect">
             <a:avLst/>
@@ -7831,29 +7870,29 @@
               <a:buNone/>
             </a:pPr>
             <a:r>
-              <a:rPr lang="en-US" sz="1400" b="1" spc="80" kern="0" dirty="0">
-                <a:solidFill>
-                  <a:srgbClr val="595959"/>
-                </a:solidFill>
-                <a:latin typeface="Inter" pitchFamily="34" charset="0"/>
-                <a:ea typeface="Inter" pitchFamily="34" charset="-122"/>
-                <a:cs typeface="Inter" pitchFamily="34" charset="-120"/>
-              </a:rPr>
-              <a:t>PROFICIENCY</a:t>
-            </a:r>
-            <a:endParaRPr lang="en-US" sz="1400" dirty="0"/>
-          </a:p>
-        </p:txBody>
-      </p:sp>
-      <p:sp>
-        <p:nvSpPr>
-          <p:cNvPr id="9" name="Text 7"/>
-          <p:cNvSpPr txBox="1"/>
-          <p:nvPr/>
-        </p:nvSpPr>
-        <p:spPr>
-          <a:xfrm>
-            <a:off x="896112" y="2286000"/>
+              <a:rPr lang="en-US" sz="1800" b="1" dirty="0">
+                <a:solidFill>
+                  <a:srgbClr val="0B2C4A"/>
+                </a:solidFill>
+                <a:latin typeface="Inter" pitchFamily="34" charset="0"/>
+                <a:ea typeface="Inter" pitchFamily="34" charset="-122"/>
+                <a:cs typeface="Inter" pitchFamily="34" charset="-120"/>
+              </a:rPr>
+              <a:t>Hours clocked to repair orders ÷ available hours</a:t>
+            </a:r>
+            <a:endParaRPr lang="en-US" sz="1800" dirty="0"/>
+          </a:p>
+        </p:txBody>
+      </p:sp>
+      <p:sp>
+        <p:nvSpPr>
+          <p:cNvPr id="10" name="Text 8"/>
+          <p:cNvSpPr txBox="1"/>
+          <p:nvPr/>
+        </p:nvSpPr>
+        <p:spPr>
+          <a:xfrm>
+            <a:off x="896112" y="2679192"/>
             <a:ext cx="3087624" cy="868680"/>
           </a:xfrm>
           <a:prstGeom prst="rect">
@@ -7863,47 +7902,6 @@
           <a:ln/>
         </p:spPr>
         <p:txBody>
-          <a:bodyPr wrap="square" lIns="0" tIns="0" rIns="0" bIns="0" rtlCol="0" anchor="ctr">
-            <a:normAutofit/>
-          </a:bodyPr>
-          <a:lstStyle/>
-          <a:p>
-            <a:pPr indent="0" marL="0">
-              <a:buNone/>
-            </a:pPr>
-            <a:r>
-              <a:rPr lang="en-US" sz="2600" b="1" dirty="0">
-                <a:solidFill>
-                  <a:srgbClr val="0B2C4A"/>
-                </a:solidFill>
-                <a:latin typeface="Inter" pitchFamily="34" charset="0"/>
-                <a:ea typeface="Inter" pitchFamily="34" charset="-122"/>
-                <a:cs typeface="Inter" pitchFamily="34" charset="-120"/>
-              </a:rPr>
-              <a:t>Sold hours ÷ hours worked</a:t>
-            </a:r>
-            <a:endParaRPr lang="en-US" sz="2600" dirty="0"/>
-          </a:p>
-        </p:txBody>
-      </p:sp>
-      <p:sp>
-        <p:nvSpPr>
-          <p:cNvPr id="10" name="Text 8"/>
-          <p:cNvSpPr txBox="1"/>
-          <p:nvPr/>
-        </p:nvSpPr>
-        <p:spPr>
-          <a:xfrm>
-            <a:off x="896112" y="3200400"/>
-            <a:ext cx="3087624" cy="1188720"/>
-          </a:xfrm>
-          <a:prstGeom prst="rect">
-            <a:avLst/>
-          </a:prstGeom>
-          <a:noFill/>
-          <a:ln/>
-        </p:spPr>
-        <p:txBody>
           <a:bodyPr wrap="square" lIns="0" tIns="0" rIns="0" bIns="0" rtlCol="0" anchor="t"/>
           <a:lstStyle/>
           <a:p>
@@ -7919,7 +7917,7 @@
                 <a:ea typeface="Inter" pitchFamily="34" charset="-122"/>
                 <a:cs typeface="Inter" pitchFamily="34" charset="-120"/>
               </a:rPr>
-              <a:t>How many hours a tech flags for every hour they are at work. The measure on these slides: 85% target, group 94.7%.</a:t>
+              <a:t>How much of the technician's available time was spent on repair orders?</a:t>
             </a:r>
             <a:endParaRPr lang="en-US" sz="1500" dirty="0"/>
           </a:p>
@@ -7933,8 +7931,106 @@
         </p:nvSpPr>
         <p:spPr>
           <a:xfrm>
-            <a:off x="4367784" y="1481328"/>
-            <a:ext cx="3453384" cy="3017520"/>
+            <a:off x="896112" y="3584448"/>
+            <a:ext cx="3087624" cy="10973"/>
+          </a:xfrm>
+          <a:prstGeom prst="rect">
+            <a:avLst/>
+          </a:prstGeom>
+          <a:solidFill>
+            <a:srgbClr val="D9D9D9"/>
+          </a:solidFill>
+          <a:ln/>
+        </p:spPr>
+      </p:sp>
+      <p:sp>
+        <p:nvSpPr>
+          <p:cNvPr id="12" name="Text 10"/>
+          <p:cNvSpPr txBox="1"/>
+          <p:nvPr/>
+        </p:nvSpPr>
+        <p:spPr>
+          <a:xfrm>
+            <a:off x="896112" y="3657600"/>
+            <a:ext cx="3087624" cy="310896"/>
+          </a:xfrm>
+          <a:prstGeom prst="rect">
+            <a:avLst/>
+          </a:prstGeom>
+          <a:noFill/>
+          <a:ln/>
+        </p:spPr>
+        <p:txBody>
+          <a:bodyPr wrap="square" lIns="0" tIns="0" rIns="0" bIns="0" rtlCol="0" anchor="ctr"/>
+          <a:lstStyle/>
+          <a:p>
+            <a:pPr indent="0" marL="0">
+              <a:buNone/>
+            </a:pPr>
+            <a:r>
+              <a:rPr lang="en-US" sz="1600" b="1" dirty="0">
+                <a:solidFill>
+                  <a:srgbClr val="0B2C4A"/>
+                </a:solidFill>
+                <a:latin typeface="Inter" pitchFamily="34" charset="0"/>
+                <a:ea typeface="Inter" pitchFamily="34" charset="-122"/>
+                <a:cs typeface="Inter" pitchFamily="34" charset="-120"/>
+              </a:rPr>
+              <a:t>Example: 6 ÷ 8 = 75%</a:t>
+            </a:r>
+            <a:endParaRPr lang="en-US" sz="1600" dirty="0"/>
+          </a:p>
+        </p:txBody>
+      </p:sp>
+      <p:sp>
+        <p:nvSpPr>
+          <p:cNvPr id="13" name="Text 11"/>
+          <p:cNvSpPr txBox="1"/>
+          <p:nvPr/>
+        </p:nvSpPr>
+        <p:spPr>
+          <a:xfrm>
+            <a:off x="896112" y="3977640"/>
+            <a:ext cx="3087624" cy="274320"/>
+          </a:xfrm>
+          <a:prstGeom prst="rect">
+            <a:avLst/>
+          </a:prstGeom>
+          <a:noFill/>
+          <a:ln/>
+        </p:spPr>
+        <p:txBody>
+          <a:bodyPr wrap="square" lIns="0" tIns="0" rIns="0" bIns="0" rtlCol="0" anchor="ctr"/>
+          <a:lstStyle/>
+          <a:p>
+            <a:pPr indent="0" marL="0">
+              <a:buNone/>
+            </a:pPr>
+            <a:r>
+              <a:rPr lang="en-US" sz="1400" dirty="0">
+                <a:solidFill>
+                  <a:srgbClr val="595959"/>
+                </a:solidFill>
+                <a:latin typeface="Inter" pitchFamily="34" charset="0"/>
+                <a:ea typeface="Inter" pitchFamily="34" charset="-122"/>
+                <a:cs typeface="Inter" pitchFamily="34" charset="-120"/>
+              </a:rPr>
+              <a:t>Not measured in our data</a:t>
+            </a:r>
+            <a:endParaRPr lang="en-US" sz="1400" dirty="0"/>
+          </a:p>
+        </p:txBody>
+      </p:sp>
+      <p:sp>
+        <p:nvSpPr>
+          <p:cNvPr id="14" name="Shape 12"/>
+          <p:cNvSpPr/>
+          <p:nvPr/>
+        </p:nvSpPr>
+        <p:spPr>
+          <a:xfrm>
+            <a:off x="4367784" y="1417320"/>
+            <a:ext cx="3453384" cy="2926080"/>
           </a:xfrm>
           <a:prstGeom prst="rect">
             <a:avLst/>
@@ -7947,13 +8043,13 @@
       </p:sp>
       <p:sp>
         <p:nvSpPr>
-          <p:cNvPr id="12" name="Shape 10"/>
+          <p:cNvPr id="15" name="Shape 13"/>
           <p:cNvSpPr/>
           <p:nvPr/>
         </p:nvSpPr>
         <p:spPr>
           <a:xfrm>
-            <a:off x="4367784" y="1481328"/>
+            <a:off x="4367784" y="1417320"/>
             <a:ext cx="3453384" cy="64008"/>
           </a:xfrm>
           <a:prstGeom prst="rect">
@@ -7967,14 +8063,53 @@
       </p:sp>
       <p:sp>
         <p:nvSpPr>
-          <p:cNvPr id="13" name="Text 11"/>
-          <p:cNvSpPr txBox="1"/>
-          <p:nvPr/>
-        </p:nvSpPr>
-        <p:spPr>
-          <a:xfrm>
-            <a:off x="4550664" y="1691640"/>
-            <a:ext cx="3087624" cy="566928"/>
+          <p:cNvPr id="16" name="Text 14"/>
+          <p:cNvSpPr txBox="1"/>
+          <p:nvPr/>
+        </p:nvSpPr>
+        <p:spPr>
+          <a:xfrm>
+            <a:off x="4550664" y="1600200"/>
+            <a:ext cx="3087624" cy="274320"/>
+          </a:xfrm>
+          <a:prstGeom prst="rect">
+            <a:avLst/>
+          </a:prstGeom>
+          <a:noFill/>
+          <a:ln/>
+        </p:spPr>
+        <p:txBody>
+          <a:bodyPr wrap="square" lIns="0" tIns="0" rIns="0" bIns="0" rtlCol="0" anchor="ctr"/>
+          <a:lstStyle/>
+          <a:p>
+            <a:pPr indent="0" marL="0">
+              <a:buNone/>
+            </a:pPr>
+            <a:r>
+              <a:rPr lang="en-US" sz="1400" b="1" spc="80" kern="0" dirty="0">
+                <a:solidFill>
+                  <a:srgbClr val="595959"/>
+                </a:solidFill>
+                <a:latin typeface="Inter" pitchFamily="34" charset="0"/>
+                <a:ea typeface="Inter" pitchFamily="34" charset="-122"/>
+                <a:cs typeface="Inter" pitchFamily="34" charset="-120"/>
+              </a:rPr>
+              <a:t>EFFICIENCY</a:t>
+            </a:r>
+            <a:endParaRPr lang="en-US" sz="1400" dirty="0"/>
+          </a:p>
+        </p:txBody>
+      </p:sp>
+      <p:sp>
+        <p:nvSpPr>
+          <p:cNvPr id="17" name="Text 15"/>
+          <p:cNvSpPr txBox="1"/>
+          <p:nvPr/>
+        </p:nvSpPr>
+        <p:spPr>
+          <a:xfrm>
+            <a:off x="4550664" y="1920240"/>
+            <a:ext cx="3087624" cy="685800"/>
           </a:xfrm>
           <a:prstGeom prst="rect">
             <a:avLst/>
@@ -7990,6 +8125,222 @@
               <a:buNone/>
             </a:pPr>
             <a:r>
+              <a:rPr lang="en-US" sz="1800" b="1" dirty="0">
+                <a:solidFill>
+                  <a:srgbClr val="0B2C4A"/>
+                </a:solidFill>
+                <a:latin typeface="Inter" pitchFamily="34" charset="0"/>
+                <a:ea typeface="Inter" pitchFamily="34" charset="-122"/>
+                <a:cs typeface="Inter" pitchFamily="34" charset="-120"/>
+              </a:rPr>
+              <a:t>Hours flagged ÷ hours clocked to repair orders</a:t>
+            </a:r>
+            <a:endParaRPr lang="en-US" sz="1800" dirty="0"/>
+          </a:p>
+        </p:txBody>
+      </p:sp>
+      <p:sp>
+        <p:nvSpPr>
+          <p:cNvPr id="18" name="Text 16"/>
+          <p:cNvSpPr txBox="1"/>
+          <p:nvPr/>
+        </p:nvSpPr>
+        <p:spPr>
+          <a:xfrm>
+            <a:off x="4550664" y="2679192"/>
+            <a:ext cx="3087624" cy="868680"/>
+          </a:xfrm>
+          <a:prstGeom prst="rect">
+            <a:avLst/>
+          </a:prstGeom>
+          <a:noFill/>
+          <a:ln/>
+        </p:spPr>
+        <p:txBody>
+          <a:bodyPr wrap="square" lIns="0" tIns="0" rIns="0" bIns="0" rtlCol="0" anchor="t"/>
+          <a:lstStyle/>
+          <a:p>
+            <a:pPr indent="0" marL="0">
+              <a:buNone/>
+            </a:pPr>
+            <a:r>
+              <a:rPr lang="en-US" sz="1500" dirty="0">
+                <a:solidFill>
+                  <a:srgbClr val="1A1A1A"/>
+                </a:solidFill>
+                <a:latin typeface="Inter" pitchFamily="34" charset="0"/>
+                <a:ea typeface="Inter" pitchFamily="34" charset="-122"/>
+                <a:cs typeface="Inter" pitchFamily="34" charset="-120"/>
+              </a:rPr>
+              <a:t>How many labor hours did the technician produce for each hour clocked to repair orders?</a:t>
+            </a:r>
+            <a:endParaRPr lang="en-US" sz="1500" dirty="0"/>
+          </a:p>
+        </p:txBody>
+      </p:sp>
+      <p:sp>
+        <p:nvSpPr>
+          <p:cNvPr id="19" name="Shape 17"/>
+          <p:cNvSpPr/>
+          <p:nvPr/>
+        </p:nvSpPr>
+        <p:spPr>
+          <a:xfrm>
+            <a:off x="4550664" y="3584448"/>
+            <a:ext cx="3087624" cy="10973"/>
+          </a:xfrm>
+          <a:prstGeom prst="rect">
+            <a:avLst/>
+          </a:prstGeom>
+          <a:solidFill>
+            <a:srgbClr val="D9D9D9"/>
+          </a:solidFill>
+          <a:ln/>
+        </p:spPr>
+      </p:sp>
+      <p:sp>
+        <p:nvSpPr>
+          <p:cNvPr id="20" name="Text 18"/>
+          <p:cNvSpPr txBox="1"/>
+          <p:nvPr/>
+        </p:nvSpPr>
+        <p:spPr>
+          <a:xfrm>
+            <a:off x="4550664" y="3657600"/>
+            <a:ext cx="3087624" cy="310896"/>
+          </a:xfrm>
+          <a:prstGeom prst="rect">
+            <a:avLst/>
+          </a:prstGeom>
+          <a:noFill/>
+          <a:ln/>
+        </p:spPr>
+        <p:txBody>
+          <a:bodyPr wrap="square" lIns="0" tIns="0" rIns="0" bIns="0" rtlCol="0" anchor="ctr"/>
+          <a:lstStyle/>
+          <a:p>
+            <a:pPr indent="0" marL="0">
+              <a:buNone/>
+            </a:pPr>
+            <a:r>
+              <a:rPr lang="en-US" sz="1600" b="1" dirty="0">
+                <a:solidFill>
+                  <a:srgbClr val="0B2C4A"/>
+                </a:solidFill>
+                <a:latin typeface="Inter" pitchFamily="34" charset="0"/>
+                <a:ea typeface="Inter" pitchFamily="34" charset="-122"/>
+                <a:cs typeface="Inter" pitchFamily="34" charset="-120"/>
+              </a:rPr>
+              <a:t>Example: 7.5 ÷ 6 = 125%</a:t>
+            </a:r>
+            <a:endParaRPr lang="en-US" sz="1600" dirty="0"/>
+          </a:p>
+        </p:txBody>
+      </p:sp>
+      <p:sp>
+        <p:nvSpPr>
+          <p:cNvPr id="21" name="Text 19"/>
+          <p:cNvSpPr txBox="1"/>
+          <p:nvPr/>
+        </p:nvSpPr>
+        <p:spPr>
+          <a:xfrm>
+            <a:off x="4550664" y="3977640"/>
+            <a:ext cx="3087624" cy="274320"/>
+          </a:xfrm>
+          <a:prstGeom prst="rect">
+            <a:avLst/>
+          </a:prstGeom>
+          <a:noFill/>
+          <a:ln/>
+        </p:spPr>
+        <p:txBody>
+          <a:bodyPr wrap="square" lIns="0" tIns="0" rIns="0" bIns="0" rtlCol="0" anchor="ctr"/>
+          <a:lstStyle/>
+          <a:p>
+            <a:pPr indent="0" marL="0">
+              <a:buNone/>
+            </a:pPr>
+            <a:r>
+              <a:rPr lang="en-US" sz="1400" dirty="0">
+                <a:solidFill>
+                  <a:srgbClr val="595959"/>
+                </a:solidFill>
+                <a:latin typeface="Inter" pitchFamily="34" charset="0"/>
+                <a:ea typeface="Inter" pitchFamily="34" charset="-122"/>
+                <a:cs typeface="Inter" pitchFamily="34" charset="-120"/>
+              </a:rPr>
+              <a:t>Not measured in our data</a:t>
+            </a:r>
+            <a:endParaRPr lang="en-US" sz="1400" dirty="0"/>
+          </a:p>
+        </p:txBody>
+      </p:sp>
+      <p:sp>
+        <p:nvSpPr>
+          <p:cNvPr id="22" name="Shape 20"/>
+          <p:cNvSpPr/>
+          <p:nvPr/>
+        </p:nvSpPr>
+        <p:spPr>
+          <a:xfrm>
+            <a:off x="8022336" y="1417320"/>
+            <a:ext cx="3453384" cy="2926080"/>
+          </a:xfrm>
+          <a:prstGeom prst="rect">
+            <a:avLst/>
+          </a:prstGeom>
+          <a:solidFill>
+            <a:srgbClr val="F7F7F7"/>
+          </a:solidFill>
+          <a:ln/>
+        </p:spPr>
+      </p:sp>
+      <p:sp>
+        <p:nvSpPr>
+          <p:cNvPr id="23" name="Shape 21"/>
+          <p:cNvSpPr/>
+          <p:nvPr/>
+        </p:nvSpPr>
+        <p:spPr>
+          <a:xfrm>
+            <a:off x="8022336" y="1417320"/>
+            <a:ext cx="3453384" cy="64008"/>
+          </a:xfrm>
+          <a:prstGeom prst="rect">
+            <a:avLst/>
+          </a:prstGeom>
+          <a:solidFill>
+            <a:srgbClr val="2587C5"/>
+          </a:solidFill>
+          <a:ln/>
+        </p:spPr>
+      </p:sp>
+      <p:sp>
+        <p:nvSpPr>
+          <p:cNvPr id="24" name="Text 22"/>
+          <p:cNvSpPr txBox="1"/>
+          <p:nvPr/>
+        </p:nvSpPr>
+        <p:spPr>
+          <a:xfrm>
+            <a:off x="8205216" y="1600200"/>
+            <a:ext cx="3087624" cy="274320"/>
+          </a:xfrm>
+          <a:prstGeom prst="rect">
+            <a:avLst/>
+          </a:prstGeom>
+          <a:noFill/>
+          <a:ln/>
+        </p:spPr>
+        <p:txBody>
+          <a:bodyPr wrap="square" lIns="0" tIns="0" rIns="0" bIns="0" rtlCol="0" anchor="ctr"/>
+          <a:lstStyle/>
+          <a:p>
+            <a:pPr indent="0" marL="0">
+              <a:buNone/>
+            </a:pPr>
+            <a:r>
               <a:rPr lang="en-US" sz="1400" b="1" spc="80" kern="0" dirty="0">
                 <a:solidFill>
                   <a:srgbClr val="595959"/>
@@ -7998,21 +8349,60 @@
                 <a:ea typeface="Inter" pitchFamily="34" charset="-122"/>
                 <a:cs typeface="Inter" pitchFamily="34" charset="-120"/>
               </a:rPr>
-              <a:t>EFFICIENCY</a:t>
-            </a:r>
-            <a:endParaRPr lang="en-US" sz="1400" dirty="0"/>
-          </a:p>
-        </p:txBody>
-      </p:sp>
-      <p:sp>
-        <p:nvSpPr>
-          <p:cNvPr id="14" name="Text 12"/>
-          <p:cNvSpPr txBox="1"/>
-          <p:nvPr/>
-        </p:nvSpPr>
-        <p:spPr>
-          <a:xfrm>
-            <a:off x="4550664" y="2286000"/>
+              <a:t>PROFICIENCY</a:t>
+            </a:r>
+            <a:endParaRPr lang="en-US" sz="1400" dirty="0"/>
+          </a:p>
+        </p:txBody>
+      </p:sp>
+      <p:sp>
+        <p:nvSpPr>
+          <p:cNvPr id="25" name="Text 23"/>
+          <p:cNvSpPr txBox="1"/>
+          <p:nvPr/>
+        </p:nvSpPr>
+        <p:spPr>
+          <a:xfrm>
+            <a:off x="8205216" y="1920240"/>
+            <a:ext cx="3087624" cy="685800"/>
+          </a:xfrm>
+          <a:prstGeom prst="rect">
+            <a:avLst/>
+          </a:prstGeom>
+          <a:noFill/>
+          <a:ln/>
+        </p:spPr>
+        <p:txBody>
+          <a:bodyPr wrap="square" lIns="0" tIns="0" rIns="0" bIns="0" rtlCol="0" anchor="t"/>
+          <a:lstStyle/>
+          <a:p>
+            <a:pPr indent="0" marL="0">
+              <a:buNone/>
+            </a:pPr>
+            <a:r>
+              <a:rPr lang="en-US" sz="1800" b="1" dirty="0">
+                <a:solidFill>
+                  <a:srgbClr val="0B2C4A"/>
+                </a:solidFill>
+                <a:latin typeface="Inter" pitchFamily="34" charset="0"/>
+                <a:ea typeface="Inter" pitchFamily="34" charset="-122"/>
+                <a:cs typeface="Inter" pitchFamily="34" charset="-120"/>
+              </a:rPr>
+              <a:t>Hours flagged ÷ available hours</a:t>
+            </a:r>
+            <a:endParaRPr lang="en-US" sz="1800" dirty="0"/>
+          </a:p>
+        </p:txBody>
+      </p:sp>
+      <p:sp>
+        <p:nvSpPr>
+          <p:cNvPr id="26" name="Text 24"/>
+          <p:cNvSpPr txBox="1"/>
+          <p:nvPr/>
+        </p:nvSpPr>
+        <p:spPr>
+          <a:xfrm>
+            <a:off x="8205216" y="2679192"/>
             <a:ext cx="3087624" cy="868680"/>
           </a:xfrm>
           <a:prstGeom prst="rect">
@@ -8022,16 +8412,73 @@
           <a:ln/>
         </p:spPr>
         <p:txBody>
-          <a:bodyPr wrap="square" lIns="0" tIns="0" rIns="0" bIns="0" rtlCol="0" anchor="ctr">
-            <a:normAutofit/>
-          </a:bodyPr>
-          <a:lstStyle/>
-          <a:p>
-            <a:pPr indent="0" marL="0">
-              <a:buNone/>
-            </a:pPr>
-            <a:r>
-              <a:rPr lang="en-US" sz="2600" b="1" dirty="0">
+          <a:bodyPr wrap="square" lIns="0" tIns="0" rIns="0" bIns="0" rtlCol="0" anchor="t"/>
+          <a:lstStyle/>
+          <a:p>
+            <a:pPr indent="0" marL="0">
+              <a:buNone/>
+            </a:pPr>
+            <a:r>
+              <a:rPr lang="en-US" sz="1500" dirty="0">
+                <a:solidFill>
+                  <a:srgbClr val="1A1A1A"/>
+                </a:solidFill>
+                <a:latin typeface="Inter" pitchFamily="34" charset="0"/>
+                <a:ea typeface="Inter" pitchFamily="34" charset="-122"/>
+                <a:cs typeface="Inter" pitchFamily="34" charset="-120"/>
+              </a:rPr>
+              <a:t>How many labor hours did the technician produce compared with their total available time?</a:t>
+            </a:r>
+            <a:endParaRPr lang="en-US" sz="1500" dirty="0"/>
+          </a:p>
+        </p:txBody>
+      </p:sp>
+      <p:sp>
+        <p:nvSpPr>
+          <p:cNvPr id="27" name="Shape 25"/>
+          <p:cNvSpPr/>
+          <p:nvPr/>
+        </p:nvSpPr>
+        <p:spPr>
+          <a:xfrm>
+            <a:off x="8205216" y="3584448"/>
+            <a:ext cx="3087624" cy="10973"/>
+          </a:xfrm>
+          <a:prstGeom prst="rect">
+            <a:avLst/>
+          </a:prstGeom>
+          <a:solidFill>
+            <a:srgbClr val="D9D9D9"/>
+          </a:solidFill>
+          <a:ln/>
+        </p:spPr>
+      </p:sp>
+      <p:sp>
+        <p:nvSpPr>
+          <p:cNvPr id="28" name="Text 26"/>
+          <p:cNvSpPr txBox="1"/>
+          <p:nvPr/>
+        </p:nvSpPr>
+        <p:spPr>
+          <a:xfrm>
+            <a:off x="8205216" y="3657600"/>
+            <a:ext cx="3087624" cy="310896"/>
+          </a:xfrm>
+          <a:prstGeom prst="rect">
+            <a:avLst/>
+          </a:prstGeom>
+          <a:noFill/>
+          <a:ln/>
+        </p:spPr>
+        <p:txBody>
+          <a:bodyPr wrap="square" lIns="0" tIns="0" rIns="0" bIns="0" rtlCol="0" anchor="ctr"/>
+          <a:lstStyle/>
+          <a:p>
+            <a:pPr indent="0" marL="0">
+              <a:buNone/>
+            </a:pPr>
+            <a:r>
+              <a:rPr lang="en-US" sz="1600" b="1" dirty="0">
                 <a:solidFill>
                   <a:srgbClr val="0B2C4A"/>
                 </a:solidFill>
@@ -8039,38 +8486,38 @@
                 <a:ea typeface="Inter" pitchFamily="34" charset="-122"/>
                 <a:cs typeface="Inter" pitchFamily="34" charset="-120"/>
               </a:rPr>
-              <a:t>Sold hours ÷ hours on ROs</a:t>
-            </a:r>
-            <a:endParaRPr lang="en-US" sz="2600" dirty="0"/>
-          </a:p>
-        </p:txBody>
-      </p:sp>
-      <p:sp>
-        <p:nvSpPr>
-          <p:cNvPr id="15" name="Text 13"/>
-          <p:cNvSpPr txBox="1"/>
-          <p:nvPr/>
-        </p:nvSpPr>
-        <p:spPr>
-          <a:xfrm>
-            <a:off x="4550664" y="3200400"/>
-            <a:ext cx="3087624" cy="1188720"/>
-          </a:xfrm>
-          <a:prstGeom prst="rect">
-            <a:avLst/>
-          </a:prstGeom>
-          <a:noFill/>
-          <a:ln/>
-        </p:spPr>
-        <p:txBody>
-          <a:bodyPr wrap="square" lIns="0" tIns="0" rIns="0" bIns="0" rtlCol="0" anchor="t"/>
-          <a:lstStyle/>
-          <a:p>
-            <a:pPr indent="0" marL="0">
-              <a:buNone/>
-            </a:pPr>
-            <a:r>
-              <a:rPr lang="en-US" sz="1500" dirty="0">
+              <a:t>Example: 7.5 ÷ 8 = 93.75%</a:t>
+            </a:r>
+            <a:endParaRPr lang="en-US" sz="1600" dirty="0"/>
+          </a:p>
+        </p:txBody>
+      </p:sp>
+      <p:sp>
+        <p:nvSpPr>
+          <p:cNvPr id="29" name="Text 27"/>
+          <p:cNvSpPr txBox="1"/>
+          <p:nvPr/>
+        </p:nvSpPr>
+        <p:spPr>
+          <a:xfrm>
+            <a:off x="8205216" y="3977640"/>
+            <a:ext cx="3087624" cy="274320"/>
+          </a:xfrm>
+          <a:prstGeom prst="rect">
+            <a:avLst/>
+          </a:prstGeom>
+          <a:noFill/>
+          <a:ln/>
+        </p:spPr>
+        <p:txBody>
+          <a:bodyPr wrap="square" lIns="0" tIns="0" rIns="0" bIns="0" rtlCol="0" anchor="ctr"/>
+          <a:lstStyle/>
+          <a:p>
+            <a:pPr indent="0" marL="0">
+              <a:buNone/>
+            </a:pPr>
+            <a:r>
+              <a:rPr lang="en-US" sz="1400" b="1" dirty="0">
                 <a:solidFill>
                   <a:srgbClr val="1A1A1A"/>
                 </a:solidFill>
@@ -8078,119 +8525,195 @@
                 <a:ea typeface="Inter" pitchFamily="34" charset="-122"/>
                 <a:cs typeface="Inter" pitchFamily="34" charset="-120"/>
               </a:rPr>
-              <a:t>How fast a tech does the work: hours flagged against the time actually clocked on repair orders. Over 100% beats book time.</a:t>
-            </a:r>
-            <a:endParaRPr lang="en-US" sz="1500" dirty="0"/>
-          </a:p>
-        </p:txBody>
-      </p:sp>
-      <p:sp>
-        <p:nvSpPr>
-          <p:cNvPr id="16" name="Shape 14"/>
+              <a:t>Target 85% · group 94.7%</a:t>
+            </a:r>
+            <a:endParaRPr lang="en-US" sz="1400" dirty="0"/>
+          </a:p>
+        </p:txBody>
+      </p:sp>
+      <p:sp>
+        <p:nvSpPr>
+          <p:cNvPr id="30" name="Shape 28"/>
           <p:cNvSpPr/>
           <p:nvPr/>
         </p:nvSpPr>
         <p:spPr>
           <a:xfrm>
-            <a:off x="8022336" y="1481328"/>
-            <a:ext cx="3453384" cy="3017520"/>
-          </a:xfrm>
-          <a:prstGeom prst="rect">
-            <a:avLst/>
-          </a:prstGeom>
-          <a:solidFill>
-            <a:srgbClr val="F7F7F7"/>
-          </a:solidFill>
-          <a:ln/>
-        </p:spPr>
-      </p:sp>
-      <p:sp>
-        <p:nvSpPr>
-          <p:cNvPr id="17" name="Shape 15"/>
+            <a:off x="713232" y="4526280"/>
+            <a:ext cx="10762488" cy="1097280"/>
+          </a:xfrm>
+          <a:prstGeom prst="rect">
+            <a:avLst/>
+          </a:prstGeom>
+          <a:solidFill>
+            <a:srgbClr val="EDF4FA"/>
+          </a:solidFill>
+          <a:ln/>
+        </p:spPr>
+      </p:sp>
+      <p:sp>
+        <p:nvSpPr>
+          <p:cNvPr id="31" name="Text 29"/>
+          <p:cNvSpPr txBox="1"/>
+          <p:nvPr/>
+        </p:nvSpPr>
+        <p:spPr>
+          <a:xfrm>
+            <a:off x="896112" y="4654296"/>
+            <a:ext cx="10396728" cy="256032"/>
+          </a:xfrm>
+          <a:prstGeom prst="rect">
+            <a:avLst/>
+          </a:prstGeom>
+          <a:noFill/>
+          <a:ln/>
+        </p:spPr>
+        <p:txBody>
+          <a:bodyPr wrap="square" lIns="0" tIns="0" rIns="0" bIns="0" rtlCol="0" anchor="ctr"/>
+          <a:lstStyle/>
+          <a:p>
+            <a:pPr indent="0" marL="0">
+              <a:buNone/>
+            </a:pPr>
+            <a:r>
+              <a:rPr lang="en-US" sz="1400" b="1" spc="80" kern="0" dirty="0">
+                <a:solidFill>
+                  <a:srgbClr val="595959"/>
+                </a:solidFill>
+                <a:latin typeface="Inter" pitchFamily="34" charset="0"/>
+                <a:ea typeface="Inter" pitchFamily="34" charset="-122"/>
+                <a:cs typeface="Inter" pitchFamily="34" charset="-120"/>
+              </a:rPr>
+              <a:t>ILLUSTRATIVE EXAMPLE</a:t>
+            </a:r>
+            <a:endParaRPr lang="en-US" sz="1400" dirty="0"/>
+          </a:p>
+        </p:txBody>
+      </p:sp>
+      <p:sp>
+        <p:nvSpPr>
+          <p:cNvPr id="32" name="Text 30"/>
+          <p:cNvSpPr txBox="1"/>
+          <p:nvPr/>
+        </p:nvSpPr>
+        <p:spPr>
+          <a:xfrm>
+            <a:off x="896112" y="4946904"/>
+            <a:ext cx="10396728" cy="292608"/>
+          </a:xfrm>
+          <a:prstGeom prst="rect">
+            <a:avLst/>
+          </a:prstGeom>
+          <a:noFill/>
+          <a:ln/>
+        </p:spPr>
+        <p:txBody>
+          <a:bodyPr wrap="square" lIns="0" tIns="0" rIns="0" bIns="0" rtlCol="0" anchor="ctr"/>
+          <a:lstStyle/>
+          <a:p>
+            <a:pPr indent="0" marL="0">
+              <a:buNone/>
+            </a:pPr>
+            <a:r>
+              <a:rPr lang="en-US" sz="1600" dirty="0">
+                <a:solidFill>
+                  <a:srgbClr val="1A1A1A"/>
+                </a:solidFill>
+                <a:latin typeface="Inter" pitchFamily="34" charset="0"/>
+                <a:ea typeface="Inter" pitchFamily="34" charset="-122"/>
+                <a:cs typeface="Inter" pitchFamily="34" charset="-120"/>
+              </a:rPr>
+              <a:t>A technician has 8 available hours, clocks 6 hours to repair orders and flags 7.5 hours.</a:t>
+            </a:r>
+            <a:endParaRPr lang="en-US" sz="1600" dirty="0"/>
+          </a:p>
+        </p:txBody>
+      </p:sp>
+      <p:sp>
+        <p:nvSpPr>
+          <p:cNvPr id="33" name="Text 31"/>
+          <p:cNvSpPr txBox="1"/>
+          <p:nvPr/>
+        </p:nvSpPr>
+        <p:spPr>
+          <a:xfrm>
+            <a:off x="896112" y="5257800"/>
+            <a:ext cx="10396728" cy="292608"/>
+          </a:xfrm>
+          <a:prstGeom prst="rect">
+            <a:avLst/>
+          </a:prstGeom>
+          <a:noFill/>
+          <a:ln/>
+        </p:spPr>
+        <p:txBody>
+          <a:bodyPr wrap="square" lIns="0" tIns="0" rIns="0" bIns="0" rtlCol="0" anchor="ctr"/>
+          <a:lstStyle/>
+          <a:p>
+            <a:pPr indent="0" marL="0">
+              <a:buNone/>
+            </a:pPr>
+            <a:r>
+              <a:rPr lang="en-US" sz="1600" b="1" dirty="0">
+                <a:solidFill>
+                  <a:srgbClr val="0B2C4A"/>
+                </a:solidFill>
+                <a:latin typeface="Inter" pitchFamily="34" charset="0"/>
+                <a:ea typeface="Inter" pitchFamily="34" charset="-122"/>
+                <a:cs typeface="Inter" pitchFamily="34" charset="-120"/>
+              </a:rPr>
+              <a:t>Productivity × efficiency = proficiency:  75% × 125% = 93.75%</a:t>
+            </a:r>
+            <a:endParaRPr lang="en-US" sz="1600" dirty="0"/>
+          </a:p>
+        </p:txBody>
+      </p:sp>
+      <p:sp>
+        <p:nvSpPr>
+          <p:cNvPr id="34" name="Shape 32"/>
           <p:cNvSpPr/>
           <p:nvPr/>
         </p:nvSpPr>
         <p:spPr>
           <a:xfrm>
-            <a:off x="8022336" y="1481328"/>
-            <a:ext cx="3453384" cy="64008"/>
-          </a:xfrm>
-          <a:prstGeom prst="rect">
-            <a:avLst/>
-          </a:prstGeom>
-          <a:solidFill>
-            <a:srgbClr val="2587C5"/>
-          </a:solidFill>
-          <a:ln/>
-        </p:spPr>
-      </p:sp>
-      <p:sp>
-        <p:nvSpPr>
-          <p:cNvPr id="18" name="Text 16"/>
-          <p:cNvSpPr txBox="1"/>
-          <p:nvPr/>
-        </p:nvSpPr>
-        <p:spPr>
-          <a:xfrm>
-            <a:off x="8205216" y="1691640"/>
-            <a:ext cx="3087624" cy="566928"/>
-          </a:xfrm>
-          <a:prstGeom prst="rect">
-            <a:avLst/>
-          </a:prstGeom>
-          <a:noFill/>
-          <a:ln/>
-        </p:spPr>
-        <p:txBody>
-          <a:bodyPr wrap="square" lIns="0" tIns="0" rIns="0" bIns="0" rtlCol="0" anchor="t"/>
-          <a:lstStyle/>
-          <a:p>
-            <a:pPr indent="0" marL="0">
-              <a:buNone/>
-            </a:pPr>
-            <a:r>
-              <a:rPr lang="en-US" sz="1400" b="1" spc="80" kern="0" dirty="0">
-                <a:solidFill>
-                  <a:srgbClr val="595959"/>
-                </a:solidFill>
-                <a:latin typeface="Inter" pitchFamily="34" charset="0"/>
-                <a:ea typeface="Inter" pitchFamily="34" charset="-122"/>
-                <a:cs typeface="Inter" pitchFamily="34" charset="-120"/>
-              </a:rPr>
-              <a:t>PRODUCTIVITY</a:t>
-            </a:r>
-            <a:endParaRPr lang="en-US" sz="1400" dirty="0"/>
-          </a:p>
-        </p:txBody>
-      </p:sp>
-      <p:sp>
-        <p:nvSpPr>
-          <p:cNvPr id="19" name="Text 17"/>
-          <p:cNvSpPr txBox="1"/>
-          <p:nvPr/>
-        </p:nvSpPr>
-        <p:spPr>
-          <a:xfrm>
-            <a:off x="8205216" y="2286000"/>
-            <a:ext cx="3087624" cy="868680"/>
-          </a:xfrm>
-          <a:prstGeom prst="rect">
-            <a:avLst/>
-          </a:prstGeom>
-          <a:noFill/>
-          <a:ln/>
-        </p:spPr>
-        <p:txBody>
-          <a:bodyPr wrap="square" lIns="0" tIns="0" rIns="0" bIns="0" rtlCol="0" anchor="ctr">
-            <a:normAutofit/>
-          </a:bodyPr>
-          <a:lstStyle/>
-          <a:p>
-            <a:pPr indent="0" marL="0">
-              <a:buNone/>
-            </a:pPr>
-            <a:r>
-              <a:rPr lang="en-US" sz="2600" b="1" dirty="0">
+            <a:off x="457200" y="6126480"/>
+            <a:ext cx="11274552" cy="615696"/>
+          </a:xfrm>
+          <a:prstGeom prst="rect">
+            <a:avLst/>
+          </a:prstGeom>
+          <a:solidFill>
+            <a:srgbClr val="EDF4FA"/>
+          </a:solidFill>
+          <a:ln/>
+        </p:spPr>
+      </p:sp>
+      <p:sp>
+        <p:nvSpPr>
+          <p:cNvPr id="35" name="Text 33"/>
+          <p:cNvSpPr txBox="1"/>
+          <p:nvPr/>
+        </p:nvSpPr>
+        <p:spPr>
+          <a:xfrm>
+            <a:off x="658368" y="6144768"/>
+            <a:ext cx="10927080" cy="579120"/>
+          </a:xfrm>
+          <a:prstGeom prst="rect">
+            <a:avLst/>
+          </a:prstGeom>
+          <a:noFill/>
+          <a:ln/>
+        </p:spPr>
+        <p:txBody>
+          <a:bodyPr wrap="square" lIns="0" tIns="0" rIns="0" bIns="0" rtlCol="0" anchor="ctr"/>
+          <a:lstStyle/>
+          <a:p>
+            <a:pPr indent="0" marL="0">
+              <a:buNone/>
+            </a:pPr>
+            <a:r>
+              <a:rPr lang="en-US" sz="1600" b="1" dirty="0">
                 <a:solidFill>
                   <a:srgbClr val="0B2C4A"/>
                 </a:solidFill>
@@ -8198,87 +8721,9 @@
                 <a:ea typeface="Inter" pitchFamily="34" charset="-122"/>
                 <a:cs typeface="Inter" pitchFamily="34" charset="-120"/>
               </a:rPr>
-              <a:t>Hours on ROs ÷ hours worked</a:t>
-            </a:r>
-            <a:endParaRPr lang="en-US" sz="2600" dirty="0"/>
-          </a:p>
-        </p:txBody>
-      </p:sp>
-      <p:sp>
-        <p:nvSpPr>
-          <p:cNvPr id="20" name="Text 18"/>
-          <p:cNvSpPr txBox="1"/>
-          <p:nvPr/>
-        </p:nvSpPr>
-        <p:spPr>
-          <a:xfrm>
-            <a:off x="8205216" y="3200400"/>
-            <a:ext cx="3087624" cy="1188720"/>
-          </a:xfrm>
-          <a:prstGeom prst="rect">
-            <a:avLst/>
-          </a:prstGeom>
-          <a:noFill/>
-          <a:ln/>
-        </p:spPr>
-        <p:txBody>
-          <a:bodyPr wrap="square" lIns="0" tIns="0" rIns="0" bIns="0" rtlCol="0" anchor="t"/>
-          <a:lstStyle/>
-          <a:p>
-            <a:pPr indent="0" marL="0">
-              <a:buNone/>
-            </a:pPr>
-            <a:r>
-              <a:rPr lang="en-US" sz="1500" dirty="0">
-                <a:solidFill>
-                  <a:srgbClr val="1A1A1A"/>
-                </a:solidFill>
-                <a:latin typeface="Inter" pitchFamily="34" charset="0"/>
-                <a:ea typeface="Inter" pitchFamily="34" charset="-122"/>
-                <a:cs typeface="Inter" pitchFamily="34" charset="-120"/>
-              </a:rPr>
-              <a:t>How much of the day a tech spends on customer work instead of waiting on parts, dispatch or approvals.</a:t>
-            </a:r>
-            <a:endParaRPr lang="en-US" sz="1500" dirty="0"/>
-          </a:p>
-        </p:txBody>
-      </p:sp>
-      <p:sp>
-        <p:nvSpPr>
-          <p:cNvPr id="21" name="Text 19"/>
-          <p:cNvSpPr txBox="1"/>
-          <p:nvPr/>
-        </p:nvSpPr>
-        <p:spPr>
-          <a:xfrm>
-            <a:off x="713232" y="4709160"/>
-            <a:ext cx="10762488" cy="914400"/>
-          </a:xfrm>
-          <a:prstGeom prst="rect">
-            <a:avLst/>
-          </a:prstGeom>
-          <a:noFill/>
-          <a:ln/>
-        </p:spPr>
-        <p:txBody>
-          <a:bodyPr wrap="square" lIns="0" tIns="0" rIns="0" bIns="0" rtlCol="0" anchor="ctr"/>
-          <a:lstStyle/>
-          <a:p>
-            <a:pPr indent="0" marL="0">
-              <a:buNone/>
-            </a:pPr>
-            <a:r>
-              <a:rPr lang="en-US" sz="1700" dirty="0">
-                <a:solidFill>
-                  <a:srgbClr val="1A1A1A"/>
-                </a:solidFill>
-                <a:latin typeface="Inter" pitchFamily="34" charset="0"/>
-                <a:ea typeface="Inter" pitchFamily="34" charset="-122"/>
-                <a:cs typeface="Inter" pitchFamily="34" charset="-120"/>
-              </a:rPr>
-              <a:t>Proficiency = efficiency × productivity. A fast tech with nothing to work on is efficient but not proficient: the fix is dispatch, parts and approvals, not the tech.</a:t>
-            </a:r>
-            <a:endParaRPr lang="en-US" sz="1700" dirty="0"/>
+              <a:t>Productivity measures time spent on repair orders; efficiency measures hours flagged against time on repair orders; proficiency measures total hours flagged against available time.</a:t>
+            </a:r>
+            <a:endParaRPr lang="en-US" sz="1600" dirty="0"/>
           </a:p>
         </p:txBody>
       </p:sp>

</xml_diff>

<commit_message>
Definitions slide: drop status lines and band, rename example box
Co-Authored-By: Claude Opus 5.5 <noreply@anthropic.com>
Claude-Session: https://claude.ai/code/session_01Xa4nFVxuQGXmHARGph9WhS
</commit_message>
<xml_diff>
--- a/day2-deck/decks/Metric Explainers - Review.pptx
+++ b/day2-deck/decks/Metric Explainers - Review.pptx
@@ -7755,7 +7755,7 @@
         <p:spPr>
           <a:xfrm>
             <a:off x="457200" y="1207008"/>
-            <a:ext cx="11274552" cy="4782312"/>
+            <a:ext cx="11274552" cy="5148072"/>
           </a:xfrm>
           <a:prstGeom prst="rect">
             <a:avLst/>
@@ -7774,8 +7774,8 @@
         </p:nvSpPr>
         <p:spPr>
           <a:xfrm>
-            <a:off x="713232" y="1417320"/>
-            <a:ext cx="3453384" cy="2926080"/>
+            <a:off x="713232" y="1463040"/>
+            <a:ext cx="3453384" cy="3063240"/>
           </a:xfrm>
           <a:prstGeom prst="rect">
             <a:avLst/>
@@ -7794,7 +7794,7 @@
         </p:nvSpPr>
         <p:spPr>
           <a:xfrm>
-            <a:off x="713232" y="1417320"/>
+            <a:off x="713232" y="1463040"/>
             <a:ext cx="3453384" cy="64008"/>
           </a:xfrm>
           <a:prstGeom prst="rect">
@@ -7814,7 +7814,7 @@
         </p:nvSpPr>
         <p:spPr>
           <a:xfrm>
-            <a:off x="896112" y="1600200"/>
+            <a:off x="896112" y="1645920"/>
             <a:ext cx="3087624" cy="274320"/>
           </a:xfrm>
           <a:prstGeom prst="rect">
@@ -7853,8 +7853,8 @@
         </p:nvSpPr>
         <p:spPr>
           <a:xfrm>
-            <a:off x="896112" y="1920240"/>
-            <a:ext cx="3087624" cy="685800"/>
+            <a:off x="896112" y="1965960"/>
+            <a:ext cx="3087624" cy="749808"/>
           </a:xfrm>
           <a:prstGeom prst="rect">
             <a:avLst/>
@@ -7870,7 +7870,7 @@
               <a:buNone/>
             </a:pPr>
             <a:r>
-              <a:rPr lang="en-US" sz="1800" b="1" dirty="0">
+              <a:rPr lang="en-US" sz="2000" b="1" dirty="0">
                 <a:solidFill>
                   <a:srgbClr val="0B2C4A"/>
                 </a:solidFill>
@@ -7880,7 +7880,7 @@
               </a:rPr>
               <a:t>Hours clocked to repair orders ÷ available hours</a:t>
             </a:r>
-            <a:endParaRPr lang="en-US" sz="1800" dirty="0"/>
+            <a:endParaRPr lang="en-US" sz="2000" dirty="0"/>
           </a:p>
         </p:txBody>
       </p:sp>
@@ -7892,8 +7892,8 @@
         </p:nvSpPr>
         <p:spPr>
           <a:xfrm>
-            <a:off x="896112" y="2679192"/>
-            <a:ext cx="3087624" cy="868680"/>
+            <a:off x="896112" y="2807208"/>
+            <a:ext cx="3087624" cy="960120"/>
           </a:xfrm>
           <a:prstGeom prst="rect">
             <a:avLst/>
@@ -7909,7 +7909,7 @@
               <a:buNone/>
             </a:pPr>
             <a:r>
-              <a:rPr lang="en-US" sz="1500" dirty="0">
+              <a:rPr lang="en-US" sz="1600" dirty="0">
                 <a:solidFill>
                   <a:srgbClr val="1A1A1A"/>
                 </a:solidFill>
@@ -7919,7 +7919,7 @@
               </a:rPr>
               <a:t>How much of the technician's available time was spent on repair orders?</a:t>
             </a:r>
-            <a:endParaRPr lang="en-US" sz="1500" dirty="0"/>
+            <a:endParaRPr lang="en-US" sz="1600" dirty="0"/>
           </a:p>
         </p:txBody>
       </p:sp>
@@ -7931,7 +7931,7 @@
         </p:nvSpPr>
         <p:spPr>
           <a:xfrm>
-            <a:off x="896112" y="3584448"/>
+            <a:off x="896112" y="3858768"/>
             <a:ext cx="3087624" cy="10973"/>
           </a:xfrm>
           <a:prstGeom prst="rect">
@@ -7951,8 +7951,8 @@
         </p:nvSpPr>
         <p:spPr>
           <a:xfrm>
-            <a:off x="896112" y="3657600"/>
-            <a:ext cx="3087624" cy="310896"/>
+            <a:off x="896112" y="3950208"/>
+            <a:ext cx="3087624" cy="411480"/>
           </a:xfrm>
           <a:prstGeom prst="rect">
             <a:avLst/>
@@ -7968,7 +7968,7 @@
               <a:buNone/>
             </a:pPr>
             <a:r>
-              <a:rPr lang="en-US" sz="1600" b="1" dirty="0">
+              <a:rPr lang="en-US" sz="1800" b="1" dirty="0">
                 <a:solidFill>
                   <a:srgbClr val="0B2C4A"/>
                 </a:solidFill>
@@ -7978,48 +7978,29 @@
               </a:rPr>
               <a:t>Example: 6 ÷ 8 = 75%</a:t>
             </a:r>
-            <a:endParaRPr lang="en-US" sz="1600" dirty="0"/>
-          </a:p>
-        </p:txBody>
-      </p:sp>
-      <p:sp>
-        <p:nvSpPr>
-          <p:cNvPr id="13" name="Text 11"/>
-          <p:cNvSpPr txBox="1"/>
-          <p:nvPr/>
-        </p:nvSpPr>
-        <p:spPr>
-          <a:xfrm>
-            <a:off x="896112" y="3977640"/>
-            <a:ext cx="3087624" cy="274320"/>
-          </a:xfrm>
-          <a:prstGeom prst="rect">
-            <a:avLst/>
-          </a:prstGeom>
-          <a:noFill/>
-          <a:ln/>
-        </p:spPr>
-        <p:txBody>
-          <a:bodyPr wrap="square" lIns="0" tIns="0" rIns="0" bIns="0" rtlCol="0" anchor="ctr"/>
-          <a:lstStyle/>
-          <a:p>
-            <a:pPr indent="0" marL="0">
-              <a:buNone/>
-            </a:pPr>
-            <a:r>
-              <a:rPr lang="en-US" sz="1400" dirty="0">
-                <a:solidFill>
-                  <a:srgbClr val="595959"/>
-                </a:solidFill>
-                <a:latin typeface="Inter" pitchFamily="34" charset="0"/>
-                <a:ea typeface="Inter" pitchFamily="34" charset="-122"/>
-                <a:cs typeface="Inter" pitchFamily="34" charset="-120"/>
-              </a:rPr>
-              <a:t>Not measured in our data</a:t>
-            </a:r>
-            <a:endParaRPr lang="en-US" sz="1400" dirty="0"/>
-          </a:p>
-        </p:txBody>
+            <a:endParaRPr lang="en-US" sz="1800" dirty="0"/>
+          </a:p>
+        </p:txBody>
+      </p:sp>
+      <p:sp>
+        <p:nvSpPr>
+          <p:cNvPr id="13" name="Shape 11"/>
+          <p:cNvSpPr/>
+          <p:nvPr/>
+        </p:nvSpPr>
+        <p:spPr>
+          <a:xfrm>
+            <a:off x="4367784" y="1463040"/>
+            <a:ext cx="3453384" cy="3063240"/>
+          </a:xfrm>
+          <a:prstGeom prst="rect">
+            <a:avLst/>
+          </a:prstGeom>
+          <a:solidFill>
+            <a:srgbClr val="F7F7F7"/>
+          </a:solidFill>
+          <a:ln/>
+        </p:spPr>
       </p:sp>
       <p:sp>
         <p:nvSpPr>
@@ -8029,8 +8010,204 @@
         </p:nvSpPr>
         <p:spPr>
           <a:xfrm>
-            <a:off x="4367784" y="1417320"/>
-            <a:ext cx="3453384" cy="2926080"/>
+            <a:off x="4367784" y="1463040"/>
+            <a:ext cx="3453384" cy="64008"/>
+          </a:xfrm>
+          <a:prstGeom prst="rect">
+            <a:avLst/>
+          </a:prstGeom>
+          <a:solidFill>
+            <a:srgbClr val="2587C5"/>
+          </a:solidFill>
+          <a:ln/>
+        </p:spPr>
+      </p:sp>
+      <p:sp>
+        <p:nvSpPr>
+          <p:cNvPr id="15" name="Text 13"/>
+          <p:cNvSpPr txBox="1"/>
+          <p:nvPr/>
+        </p:nvSpPr>
+        <p:spPr>
+          <a:xfrm>
+            <a:off x="4550664" y="1645920"/>
+            <a:ext cx="3087624" cy="274320"/>
+          </a:xfrm>
+          <a:prstGeom prst="rect">
+            <a:avLst/>
+          </a:prstGeom>
+          <a:noFill/>
+          <a:ln/>
+        </p:spPr>
+        <p:txBody>
+          <a:bodyPr wrap="square" lIns="0" tIns="0" rIns="0" bIns="0" rtlCol="0" anchor="ctr"/>
+          <a:lstStyle/>
+          <a:p>
+            <a:pPr indent="0" marL="0">
+              <a:buNone/>
+            </a:pPr>
+            <a:r>
+              <a:rPr lang="en-US" sz="1400" b="1" spc="80" kern="0" dirty="0">
+                <a:solidFill>
+                  <a:srgbClr val="595959"/>
+                </a:solidFill>
+                <a:latin typeface="Inter" pitchFamily="34" charset="0"/>
+                <a:ea typeface="Inter" pitchFamily="34" charset="-122"/>
+                <a:cs typeface="Inter" pitchFamily="34" charset="-120"/>
+              </a:rPr>
+              <a:t>EFFICIENCY</a:t>
+            </a:r>
+            <a:endParaRPr lang="en-US" sz="1400" dirty="0"/>
+          </a:p>
+        </p:txBody>
+      </p:sp>
+      <p:sp>
+        <p:nvSpPr>
+          <p:cNvPr id="16" name="Text 14"/>
+          <p:cNvSpPr txBox="1"/>
+          <p:nvPr/>
+        </p:nvSpPr>
+        <p:spPr>
+          <a:xfrm>
+            <a:off x="4550664" y="1965960"/>
+            <a:ext cx="3087624" cy="749808"/>
+          </a:xfrm>
+          <a:prstGeom prst="rect">
+            <a:avLst/>
+          </a:prstGeom>
+          <a:noFill/>
+          <a:ln/>
+        </p:spPr>
+        <p:txBody>
+          <a:bodyPr wrap="square" lIns="0" tIns="0" rIns="0" bIns="0" rtlCol="0" anchor="t"/>
+          <a:lstStyle/>
+          <a:p>
+            <a:pPr indent="0" marL="0">
+              <a:buNone/>
+            </a:pPr>
+            <a:r>
+              <a:rPr lang="en-US" sz="2000" b="1" dirty="0">
+                <a:solidFill>
+                  <a:srgbClr val="0B2C4A"/>
+                </a:solidFill>
+                <a:latin typeface="Inter" pitchFamily="34" charset="0"/>
+                <a:ea typeface="Inter" pitchFamily="34" charset="-122"/>
+                <a:cs typeface="Inter" pitchFamily="34" charset="-120"/>
+              </a:rPr>
+              <a:t>Hours flagged ÷ hours clocked to repair orders</a:t>
+            </a:r>
+            <a:endParaRPr lang="en-US" sz="2000" dirty="0"/>
+          </a:p>
+        </p:txBody>
+      </p:sp>
+      <p:sp>
+        <p:nvSpPr>
+          <p:cNvPr id="17" name="Text 15"/>
+          <p:cNvSpPr txBox="1"/>
+          <p:nvPr/>
+        </p:nvSpPr>
+        <p:spPr>
+          <a:xfrm>
+            <a:off x="4550664" y="2807208"/>
+            <a:ext cx="3087624" cy="960120"/>
+          </a:xfrm>
+          <a:prstGeom prst="rect">
+            <a:avLst/>
+          </a:prstGeom>
+          <a:noFill/>
+          <a:ln/>
+        </p:spPr>
+        <p:txBody>
+          <a:bodyPr wrap="square" lIns="0" tIns="0" rIns="0" bIns="0" rtlCol="0" anchor="t"/>
+          <a:lstStyle/>
+          <a:p>
+            <a:pPr indent="0" marL="0">
+              <a:buNone/>
+            </a:pPr>
+            <a:r>
+              <a:rPr lang="en-US" sz="1600" dirty="0">
+                <a:solidFill>
+                  <a:srgbClr val="1A1A1A"/>
+                </a:solidFill>
+                <a:latin typeface="Inter" pitchFamily="34" charset="0"/>
+                <a:ea typeface="Inter" pitchFamily="34" charset="-122"/>
+                <a:cs typeface="Inter" pitchFamily="34" charset="-120"/>
+              </a:rPr>
+              <a:t>How many labor hours did the technician produce for each hour clocked to repair orders?</a:t>
+            </a:r>
+            <a:endParaRPr lang="en-US" sz="1600" dirty="0"/>
+          </a:p>
+        </p:txBody>
+      </p:sp>
+      <p:sp>
+        <p:nvSpPr>
+          <p:cNvPr id="18" name="Shape 16"/>
+          <p:cNvSpPr/>
+          <p:nvPr/>
+        </p:nvSpPr>
+        <p:spPr>
+          <a:xfrm>
+            <a:off x="4550664" y="3858768"/>
+            <a:ext cx="3087624" cy="10973"/>
+          </a:xfrm>
+          <a:prstGeom prst="rect">
+            <a:avLst/>
+          </a:prstGeom>
+          <a:solidFill>
+            <a:srgbClr val="D9D9D9"/>
+          </a:solidFill>
+          <a:ln/>
+        </p:spPr>
+      </p:sp>
+      <p:sp>
+        <p:nvSpPr>
+          <p:cNvPr id="19" name="Text 17"/>
+          <p:cNvSpPr txBox="1"/>
+          <p:nvPr/>
+        </p:nvSpPr>
+        <p:spPr>
+          <a:xfrm>
+            <a:off x="4550664" y="3950208"/>
+            <a:ext cx="3087624" cy="411480"/>
+          </a:xfrm>
+          <a:prstGeom prst="rect">
+            <a:avLst/>
+          </a:prstGeom>
+          <a:noFill/>
+          <a:ln/>
+        </p:spPr>
+        <p:txBody>
+          <a:bodyPr wrap="square" lIns="0" tIns="0" rIns="0" bIns="0" rtlCol="0" anchor="ctr"/>
+          <a:lstStyle/>
+          <a:p>
+            <a:pPr indent="0" marL="0">
+              <a:buNone/>
+            </a:pPr>
+            <a:r>
+              <a:rPr lang="en-US" sz="1800" b="1" dirty="0">
+                <a:solidFill>
+                  <a:srgbClr val="0B2C4A"/>
+                </a:solidFill>
+                <a:latin typeface="Inter" pitchFamily="34" charset="0"/>
+                <a:ea typeface="Inter" pitchFamily="34" charset="-122"/>
+                <a:cs typeface="Inter" pitchFamily="34" charset="-120"/>
+              </a:rPr>
+              <a:t>Example: 7.5 ÷ 6 = 125%</a:t>
+            </a:r>
+            <a:endParaRPr lang="en-US" sz="1800" dirty="0"/>
+          </a:p>
+        </p:txBody>
+      </p:sp>
+      <p:sp>
+        <p:nvSpPr>
+          <p:cNvPr id="20" name="Shape 18"/>
+          <p:cNvSpPr/>
+          <p:nvPr/>
+        </p:nvSpPr>
+        <p:spPr>
+          <a:xfrm>
+            <a:off x="8022336" y="1463040"/>
+            <a:ext cx="3453384" cy="3063240"/>
           </a:xfrm>
           <a:prstGeom prst="rect">
             <a:avLst/>
@@ -8043,13 +8220,13 @@
       </p:sp>
       <p:sp>
         <p:nvSpPr>
-          <p:cNvPr id="15" name="Shape 13"/>
+          <p:cNvPr id="21" name="Shape 19"/>
           <p:cNvSpPr/>
           <p:nvPr/>
         </p:nvSpPr>
         <p:spPr>
           <a:xfrm>
-            <a:off x="4367784" y="1417320"/>
+            <a:off x="8022336" y="1463040"/>
             <a:ext cx="3453384" cy="64008"/>
           </a:xfrm>
           <a:prstGeom prst="rect">
@@ -8063,13 +8240,13 @@
       </p:sp>
       <p:sp>
         <p:nvSpPr>
-          <p:cNvPr id="16" name="Text 14"/>
-          <p:cNvSpPr txBox="1"/>
-          <p:nvPr/>
-        </p:nvSpPr>
-        <p:spPr>
-          <a:xfrm>
-            <a:off x="4550664" y="1600200"/>
+          <p:cNvPr id="22" name="Text 20"/>
+          <p:cNvSpPr txBox="1"/>
+          <p:nvPr/>
+        </p:nvSpPr>
+        <p:spPr>
+          <a:xfrm>
+            <a:off x="8205216" y="1645920"/>
             <a:ext cx="3087624" cy="274320"/>
           </a:xfrm>
           <a:prstGeom prst="rect">
@@ -8094,22 +8271,22 @@
                 <a:ea typeface="Inter" pitchFamily="34" charset="-122"/>
                 <a:cs typeface="Inter" pitchFamily="34" charset="-120"/>
               </a:rPr>
-              <a:t>EFFICIENCY</a:t>
-            </a:r>
-            <a:endParaRPr lang="en-US" sz="1400" dirty="0"/>
-          </a:p>
-        </p:txBody>
-      </p:sp>
-      <p:sp>
-        <p:nvSpPr>
-          <p:cNvPr id="17" name="Text 15"/>
-          <p:cNvSpPr txBox="1"/>
-          <p:nvPr/>
-        </p:nvSpPr>
-        <p:spPr>
-          <a:xfrm>
-            <a:off x="4550664" y="1920240"/>
-            <a:ext cx="3087624" cy="685800"/>
+              <a:t>PROFICIENCY</a:t>
+            </a:r>
+            <a:endParaRPr lang="en-US" sz="1400" dirty="0"/>
+          </a:p>
+        </p:txBody>
+      </p:sp>
+      <p:sp>
+        <p:nvSpPr>
+          <p:cNvPr id="23" name="Text 21"/>
+          <p:cNvSpPr txBox="1"/>
+          <p:nvPr/>
+        </p:nvSpPr>
+        <p:spPr>
+          <a:xfrm>
+            <a:off x="8205216" y="1965960"/>
+            <a:ext cx="3087624" cy="749808"/>
           </a:xfrm>
           <a:prstGeom prst="rect">
             <a:avLst/>
@@ -8125,6 +8302,104 @@
               <a:buNone/>
             </a:pPr>
             <a:r>
+              <a:rPr lang="en-US" sz="2000" b="1" dirty="0">
+                <a:solidFill>
+                  <a:srgbClr val="0B2C4A"/>
+                </a:solidFill>
+                <a:latin typeface="Inter" pitchFamily="34" charset="0"/>
+                <a:ea typeface="Inter" pitchFamily="34" charset="-122"/>
+                <a:cs typeface="Inter" pitchFamily="34" charset="-120"/>
+              </a:rPr>
+              <a:t>Hours flagged ÷ available hours</a:t>
+            </a:r>
+            <a:endParaRPr lang="en-US" sz="2000" dirty="0"/>
+          </a:p>
+        </p:txBody>
+      </p:sp>
+      <p:sp>
+        <p:nvSpPr>
+          <p:cNvPr id="24" name="Text 22"/>
+          <p:cNvSpPr txBox="1"/>
+          <p:nvPr/>
+        </p:nvSpPr>
+        <p:spPr>
+          <a:xfrm>
+            <a:off x="8205216" y="2807208"/>
+            <a:ext cx="3087624" cy="960120"/>
+          </a:xfrm>
+          <a:prstGeom prst="rect">
+            <a:avLst/>
+          </a:prstGeom>
+          <a:noFill/>
+          <a:ln/>
+        </p:spPr>
+        <p:txBody>
+          <a:bodyPr wrap="square" lIns="0" tIns="0" rIns="0" bIns="0" rtlCol="0" anchor="t"/>
+          <a:lstStyle/>
+          <a:p>
+            <a:pPr indent="0" marL="0">
+              <a:buNone/>
+            </a:pPr>
+            <a:r>
+              <a:rPr lang="en-US" sz="1600" dirty="0">
+                <a:solidFill>
+                  <a:srgbClr val="1A1A1A"/>
+                </a:solidFill>
+                <a:latin typeface="Inter" pitchFamily="34" charset="0"/>
+                <a:ea typeface="Inter" pitchFamily="34" charset="-122"/>
+                <a:cs typeface="Inter" pitchFamily="34" charset="-120"/>
+              </a:rPr>
+              <a:t>How many labor hours did the technician produce compared with their total available time?</a:t>
+            </a:r>
+            <a:endParaRPr lang="en-US" sz="1600" dirty="0"/>
+          </a:p>
+        </p:txBody>
+      </p:sp>
+      <p:sp>
+        <p:nvSpPr>
+          <p:cNvPr id="25" name="Shape 23"/>
+          <p:cNvSpPr/>
+          <p:nvPr/>
+        </p:nvSpPr>
+        <p:spPr>
+          <a:xfrm>
+            <a:off x="8205216" y="3858768"/>
+            <a:ext cx="3087624" cy="10973"/>
+          </a:xfrm>
+          <a:prstGeom prst="rect">
+            <a:avLst/>
+          </a:prstGeom>
+          <a:solidFill>
+            <a:srgbClr val="D9D9D9"/>
+          </a:solidFill>
+          <a:ln/>
+        </p:spPr>
+      </p:sp>
+      <p:sp>
+        <p:nvSpPr>
+          <p:cNvPr id="26" name="Text 24"/>
+          <p:cNvSpPr txBox="1"/>
+          <p:nvPr/>
+        </p:nvSpPr>
+        <p:spPr>
+          <a:xfrm>
+            <a:off x="8205216" y="3950208"/>
+            <a:ext cx="3087624" cy="411480"/>
+          </a:xfrm>
+          <a:prstGeom prst="rect">
+            <a:avLst/>
+          </a:prstGeom>
+          <a:noFill/>
+          <a:ln/>
+        </p:spPr>
+        <p:txBody>
+          <a:bodyPr wrap="square" lIns="0" tIns="0" rIns="0" bIns="0" rtlCol="0" anchor="ctr"/>
+          <a:lstStyle/>
+          <a:p>
+            <a:pPr indent="0" marL="0">
+              <a:buNone/>
+            </a:pPr>
+            <a:r>
               <a:rPr lang="en-US" sz="1800" b="1" dirty="0">
                 <a:solidFill>
                   <a:srgbClr val="0B2C4A"/>
@@ -8133,303 +8408,9 @@
                 <a:ea typeface="Inter" pitchFamily="34" charset="-122"/>
                 <a:cs typeface="Inter" pitchFamily="34" charset="-120"/>
               </a:rPr>
-              <a:t>Hours flagged ÷ hours clocked to repair orders</a:t>
+              <a:t>Example: 7.5 ÷ 8 = 93.75%</a:t>
             </a:r>
             <a:endParaRPr lang="en-US" sz="1800" dirty="0"/>
-          </a:p>
-        </p:txBody>
-      </p:sp>
-      <p:sp>
-        <p:nvSpPr>
-          <p:cNvPr id="18" name="Text 16"/>
-          <p:cNvSpPr txBox="1"/>
-          <p:nvPr/>
-        </p:nvSpPr>
-        <p:spPr>
-          <a:xfrm>
-            <a:off x="4550664" y="2679192"/>
-            <a:ext cx="3087624" cy="868680"/>
-          </a:xfrm>
-          <a:prstGeom prst="rect">
-            <a:avLst/>
-          </a:prstGeom>
-          <a:noFill/>
-          <a:ln/>
-        </p:spPr>
-        <p:txBody>
-          <a:bodyPr wrap="square" lIns="0" tIns="0" rIns="0" bIns="0" rtlCol="0" anchor="t"/>
-          <a:lstStyle/>
-          <a:p>
-            <a:pPr indent="0" marL="0">
-              <a:buNone/>
-            </a:pPr>
-            <a:r>
-              <a:rPr lang="en-US" sz="1500" dirty="0">
-                <a:solidFill>
-                  <a:srgbClr val="1A1A1A"/>
-                </a:solidFill>
-                <a:latin typeface="Inter" pitchFamily="34" charset="0"/>
-                <a:ea typeface="Inter" pitchFamily="34" charset="-122"/>
-                <a:cs typeface="Inter" pitchFamily="34" charset="-120"/>
-              </a:rPr>
-              <a:t>How many labor hours did the technician produce for each hour clocked to repair orders?</a:t>
-            </a:r>
-            <a:endParaRPr lang="en-US" sz="1500" dirty="0"/>
-          </a:p>
-        </p:txBody>
-      </p:sp>
-      <p:sp>
-        <p:nvSpPr>
-          <p:cNvPr id="19" name="Shape 17"/>
-          <p:cNvSpPr/>
-          <p:nvPr/>
-        </p:nvSpPr>
-        <p:spPr>
-          <a:xfrm>
-            <a:off x="4550664" y="3584448"/>
-            <a:ext cx="3087624" cy="10973"/>
-          </a:xfrm>
-          <a:prstGeom prst="rect">
-            <a:avLst/>
-          </a:prstGeom>
-          <a:solidFill>
-            <a:srgbClr val="D9D9D9"/>
-          </a:solidFill>
-          <a:ln/>
-        </p:spPr>
-      </p:sp>
-      <p:sp>
-        <p:nvSpPr>
-          <p:cNvPr id="20" name="Text 18"/>
-          <p:cNvSpPr txBox="1"/>
-          <p:nvPr/>
-        </p:nvSpPr>
-        <p:spPr>
-          <a:xfrm>
-            <a:off x="4550664" y="3657600"/>
-            <a:ext cx="3087624" cy="310896"/>
-          </a:xfrm>
-          <a:prstGeom prst="rect">
-            <a:avLst/>
-          </a:prstGeom>
-          <a:noFill/>
-          <a:ln/>
-        </p:spPr>
-        <p:txBody>
-          <a:bodyPr wrap="square" lIns="0" tIns="0" rIns="0" bIns="0" rtlCol="0" anchor="ctr"/>
-          <a:lstStyle/>
-          <a:p>
-            <a:pPr indent="0" marL="0">
-              <a:buNone/>
-            </a:pPr>
-            <a:r>
-              <a:rPr lang="en-US" sz="1600" b="1" dirty="0">
-                <a:solidFill>
-                  <a:srgbClr val="0B2C4A"/>
-                </a:solidFill>
-                <a:latin typeface="Inter" pitchFamily="34" charset="0"/>
-                <a:ea typeface="Inter" pitchFamily="34" charset="-122"/>
-                <a:cs typeface="Inter" pitchFamily="34" charset="-120"/>
-              </a:rPr>
-              <a:t>Example: 7.5 ÷ 6 = 125%</a:t>
-            </a:r>
-            <a:endParaRPr lang="en-US" sz="1600" dirty="0"/>
-          </a:p>
-        </p:txBody>
-      </p:sp>
-      <p:sp>
-        <p:nvSpPr>
-          <p:cNvPr id="21" name="Text 19"/>
-          <p:cNvSpPr txBox="1"/>
-          <p:nvPr/>
-        </p:nvSpPr>
-        <p:spPr>
-          <a:xfrm>
-            <a:off x="4550664" y="3977640"/>
-            <a:ext cx="3087624" cy="274320"/>
-          </a:xfrm>
-          <a:prstGeom prst="rect">
-            <a:avLst/>
-          </a:prstGeom>
-          <a:noFill/>
-          <a:ln/>
-        </p:spPr>
-        <p:txBody>
-          <a:bodyPr wrap="square" lIns="0" tIns="0" rIns="0" bIns="0" rtlCol="0" anchor="ctr"/>
-          <a:lstStyle/>
-          <a:p>
-            <a:pPr indent="0" marL="0">
-              <a:buNone/>
-            </a:pPr>
-            <a:r>
-              <a:rPr lang="en-US" sz="1400" dirty="0">
-                <a:solidFill>
-                  <a:srgbClr val="595959"/>
-                </a:solidFill>
-                <a:latin typeface="Inter" pitchFamily="34" charset="0"/>
-                <a:ea typeface="Inter" pitchFamily="34" charset="-122"/>
-                <a:cs typeface="Inter" pitchFamily="34" charset="-120"/>
-              </a:rPr>
-              <a:t>Not measured in our data</a:t>
-            </a:r>
-            <a:endParaRPr lang="en-US" sz="1400" dirty="0"/>
-          </a:p>
-        </p:txBody>
-      </p:sp>
-      <p:sp>
-        <p:nvSpPr>
-          <p:cNvPr id="22" name="Shape 20"/>
-          <p:cNvSpPr/>
-          <p:nvPr/>
-        </p:nvSpPr>
-        <p:spPr>
-          <a:xfrm>
-            <a:off x="8022336" y="1417320"/>
-            <a:ext cx="3453384" cy="2926080"/>
-          </a:xfrm>
-          <a:prstGeom prst="rect">
-            <a:avLst/>
-          </a:prstGeom>
-          <a:solidFill>
-            <a:srgbClr val="F7F7F7"/>
-          </a:solidFill>
-          <a:ln/>
-        </p:spPr>
-      </p:sp>
-      <p:sp>
-        <p:nvSpPr>
-          <p:cNvPr id="23" name="Shape 21"/>
-          <p:cNvSpPr/>
-          <p:nvPr/>
-        </p:nvSpPr>
-        <p:spPr>
-          <a:xfrm>
-            <a:off x="8022336" y="1417320"/>
-            <a:ext cx="3453384" cy="64008"/>
-          </a:xfrm>
-          <a:prstGeom prst="rect">
-            <a:avLst/>
-          </a:prstGeom>
-          <a:solidFill>
-            <a:srgbClr val="2587C5"/>
-          </a:solidFill>
-          <a:ln/>
-        </p:spPr>
-      </p:sp>
-      <p:sp>
-        <p:nvSpPr>
-          <p:cNvPr id="24" name="Text 22"/>
-          <p:cNvSpPr txBox="1"/>
-          <p:nvPr/>
-        </p:nvSpPr>
-        <p:spPr>
-          <a:xfrm>
-            <a:off x="8205216" y="1600200"/>
-            <a:ext cx="3087624" cy="274320"/>
-          </a:xfrm>
-          <a:prstGeom prst="rect">
-            <a:avLst/>
-          </a:prstGeom>
-          <a:noFill/>
-          <a:ln/>
-        </p:spPr>
-        <p:txBody>
-          <a:bodyPr wrap="square" lIns="0" tIns="0" rIns="0" bIns="0" rtlCol="0" anchor="ctr"/>
-          <a:lstStyle/>
-          <a:p>
-            <a:pPr indent="0" marL="0">
-              <a:buNone/>
-            </a:pPr>
-            <a:r>
-              <a:rPr lang="en-US" sz="1400" b="1" spc="80" kern="0" dirty="0">
-                <a:solidFill>
-                  <a:srgbClr val="595959"/>
-                </a:solidFill>
-                <a:latin typeface="Inter" pitchFamily="34" charset="0"/>
-                <a:ea typeface="Inter" pitchFamily="34" charset="-122"/>
-                <a:cs typeface="Inter" pitchFamily="34" charset="-120"/>
-              </a:rPr>
-              <a:t>PROFICIENCY</a:t>
-            </a:r>
-            <a:endParaRPr lang="en-US" sz="1400" dirty="0"/>
-          </a:p>
-        </p:txBody>
-      </p:sp>
-      <p:sp>
-        <p:nvSpPr>
-          <p:cNvPr id="25" name="Text 23"/>
-          <p:cNvSpPr txBox="1"/>
-          <p:nvPr/>
-        </p:nvSpPr>
-        <p:spPr>
-          <a:xfrm>
-            <a:off x="8205216" y="1920240"/>
-            <a:ext cx="3087624" cy="685800"/>
-          </a:xfrm>
-          <a:prstGeom prst="rect">
-            <a:avLst/>
-          </a:prstGeom>
-          <a:noFill/>
-          <a:ln/>
-        </p:spPr>
-        <p:txBody>
-          <a:bodyPr wrap="square" lIns="0" tIns="0" rIns="0" bIns="0" rtlCol="0" anchor="t"/>
-          <a:lstStyle/>
-          <a:p>
-            <a:pPr indent="0" marL="0">
-              <a:buNone/>
-            </a:pPr>
-            <a:r>
-              <a:rPr lang="en-US" sz="1800" b="1" dirty="0">
-                <a:solidFill>
-                  <a:srgbClr val="0B2C4A"/>
-                </a:solidFill>
-                <a:latin typeface="Inter" pitchFamily="34" charset="0"/>
-                <a:ea typeface="Inter" pitchFamily="34" charset="-122"/>
-                <a:cs typeface="Inter" pitchFamily="34" charset="-120"/>
-              </a:rPr>
-              <a:t>Hours flagged ÷ available hours</a:t>
-            </a:r>
-            <a:endParaRPr lang="en-US" sz="1800" dirty="0"/>
-          </a:p>
-        </p:txBody>
-      </p:sp>
-      <p:sp>
-        <p:nvSpPr>
-          <p:cNvPr id="26" name="Text 24"/>
-          <p:cNvSpPr txBox="1"/>
-          <p:nvPr/>
-        </p:nvSpPr>
-        <p:spPr>
-          <a:xfrm>
-            <a:off x="8205216" y="2679192"/>
-            <a:ext cx="3087624" cy="868680"/>
-          </a:xfrm>
-          <a:prstGeom prst="rect">
-            <a:avLst/>
-          </a:prstGeom>
-          <a:noFill/>
-          <a:ln/>
-        </p:spPr>
-        <p:txBody>
-          <a:bodyPr wrap="square" lIns="0" tIns="0" rIns="0" bIns="0" rtlCol="0" anchor="t"/>
-          <a:lstStyle/>
-          <a:p>
-            <a:pPr indent="0" marL="0">
-              <a:buNone/>
-            </a:pPr>
-            <a:r>
-              <a:rPr lang="en-US" sz="1500" dirty="0">
-                <a:solidFill>
-                  <a:srgbClr val="1A1A1A"/>
-                </a:solidFill>
-                <a:latin typeface="Inter" pitchFamily="34" charset="0"/>
-                <a:ea typeface="Inter" pitchFamily="34" charset="-122"/>
-                <a:cs typeface="Inter" pitchFamily="34" charset="-120"/>
-              </a:rPr>
-              <a:t>How many labor hours did the technician produce compared with their total available time?</a:t>
-            </a:r>
-            <a:endParaRPr lang="en-US" sz="1500" dirty="0"/>
           </a:p>
         </p:txBody>
       </p:sp>
@@ -8441,14 +8422,14 @@
         </p:nvSpPr>
         <p:spPr>
           <a:xfrm>
-            <a:off x="8205216" y="3584448"/>
-            <a:ext cx="3087624" cy="10973"/>
-          </a:xfrm>
-          <a:prstGeom prst="rect">
-            <a:avLst/>
-          </a:prstGeom>
-          <a:solidFill>
-            <a:srgbClr val="D9D9D9"/>
+            <a:off x="713232" y="4754880"/>
+            <a:ext cx="10762488" cy="1261872"/>
+          </a:xfrm>
+          <a:prstGeom prst="rect">
+            <a:avLst/>
+          </a:prstGeom>
+          <a:solidFill>
+            <a:srgbClr val="EDF4FA"/>
           </a:solidFill>
           <a:ln/>
         </p:spPr>
@@ -8461,8 +8442,8 @@
         </p:nvSpPr>
         <p:spPr>
           <a:xfrm>
-            <a:off x="8205216" y="3657600"/>
-            <a:ext cx="3087624" cy="310896"/>
+            <a:off x="896112" y="4901184"/>
+            <a:ext cx="10396728" cy="256032"/>
           </a:xfrm>
           <a:prstGeom prst="rect">
             <a:avLst/>
@@ -8478,7 +8459,85 @@
               <a:buNone/>
             </a:pPr>
             <a:r>
-              <a:rPr lang="en-US" sz="1600" b="1" dirty="0">
+              <a:rPr lang="en-US" sz="1400" b="1" spc="80" kern="0" dirty="0">
+                <a:solidFill>
+                  <a:srgbClr val="595959"/>
+                </a:solidFill>
+                <a:latin typeface="Inter" pitchFamily="34" charset="0"/>
+                <a:ea typeface="Inter" pitchFamily="34" charset="-122"/>
+                <a:cs typeface="Inter" pitchFamily="34" charset="-120"/>
+              </a:rPr>
+              <a:t>PUTTING IT TOGETHER: ONE TECHNICIAN, ONE DAY</a:t>
+            </a:r>
+            <a:endParaRPr lang="en-US" sz="1400" dirty="0"/>
+          </a:p>
+        </p:txBody>
+      </p:sp>
+      <p:sp>
+        <p:nvSpPr>
+          <p:cNvPr id="29" name="Text 27"/>
+          <p:cNvSpPr txBox="1"/>
+          <p:nvPr/>
+        </p:nvSpPr>
+        <p:spPr>
+          <a:xfrm>
+            <a:off x="896112" y="5212080"/>
+            <a:ext cx="10396728" cy="329184"/>
+          </a:xfrm>
+          <a:prstGeom prst="rect">
+            <a:avLst/>
+          </a:prstGeom>
+          <a:noFill/>
+          <a:ln/>
+        </p:spPr>
+        <p:txBody>
+          <a:bodyPr wrap="square" lIns="0" tIns="0" rIns="0" bIns="0" rtlCol="0" anchor="ctr"/>
+          <a:lstStyle/>
+          <a:p>
+            <a:pPr indent="0" marL="0">
+              <a:buNone/>
+            </a:pPr>
+            <a:r>
+              <a:rPr lang="en-US" sz="1800" dirty="0">
+                <a:solidFill>
+                  <a:srgbClr val="1A1A1A"/>
+                </a:solidFill>
+                <a:latin typeface="Inter" pitchFamily="34" charset="0"/>
+                <a:ea typeface="Inter" pitchFamily="34" charset="-122"/>
+                <a:cs typeface="Inter" pitchFamily="34" charset="-120"/>
+              </a:rPr>
+              <a:t>A technician has 8 available hours, clocks 6 hours to repair orders and flags 7.5 hours.</a:t>
+            </a:r>
+            <a:endParaRPr lang="en-US" sz="1800" dirty="0"/>
+          </a:p>
+        </p:txBody>
+      </p:sp>
+      <p:sp>
+        <p:nvSpPr>
+          <p:cNvPr id="30" name="Text 28"/>
+          <p:cNvSpPr txBox="1"/>
+          <p:nvPr/>
+        </p:nvSpPr>
+        <p:spPr>
+          <a:xfrm>
+            <a:off x="896112" y="5577840"/>
+            <a:ext cx="10396728" cy="329184"/>
+          </a:xfrm>
+          <a:prstGeom prst="rect">
+            <a:avLst/>
+          </a:prstGeom>
+          <a:noFill/>
+          <a:ln/>
+        </p:spPr>
+        <p:txBody>
+          <a:bodyPr wrap="square" lIns="0" tIns="0" rIns="0" bIns="0" rtlCol="0" anchor="ctr"/>
+          <a:lstStyle/>
+          <a:p>
+            <a:pPr indent="0" marL="0">
+              <a:buNone/>
+            </a:pPr>
+            <a:r>
+              <a:rPr lang="en-US" sz="1800" b="1" dirty="0">
                 <a:solidFill>
                   <a:srgbClr val="0B2C4A"/>
                 </a:solidFill>
@@ -8486,244 +8545,9 @@
                 <a:ea typeface="Inter" pitchFamily="34" charset="-122"/>
                 <a:cs typeface="Inter" pitchFamily="34" charset="-120"/>
               </a:rPr>
-              <a:t>Example: 7.5 ÷ 8 = 93.75%</a:t>
-            </a:r>
-            <a:endParaRPr lang="en-US" sz="1600" dirty="0"/>
-          </a:p>
-        </p:txBody>
-      </p:sp>
-      <p:sp>
-        <p:nvSpPr>
-          <p:cNvPr id="29" name="Text 27"/>
-          <p:cNvSpPr txBox="1"/>
-          <p:nvPr/>
-        </p:nvSpPr>
-        <p:spPr>
-          <a:xfrm>
-            <a:off x="8205216" y="3977640"/>
-            <a:ext cx="3087624" cy="274320"/>
-          </a:xfrm>
-          <a:prstGeom prst="rect">
-            <a:avLst/>
-          </a:prstGeom>
-          <a:noFill/>
-          <a:ln/>
-        </p:spPr>
-        <p:txBody>
-          <a:bodyPr wrap="square" lIns="0" tIns="0" rIns="0" bIns="0" rtlCol="0" anchor="ctr"/>
-          <a:lstStyle/>
-          <a:p>
-            <a:pPr indent="0" marL="0">
-              <a:buNone/>
-            </a:pPr>
-            <a:r>
-              <a:rPr lang="en-US" sz="1400" b="1" dirty="0">
-                <a:solidFill>
-                  <a:srgbClr val="1A1A1A"/>
-                </a:solidFill>
-                <a:latin typeface="Inter" pitchFamily="34" charset="0"/>
-                <a:ea typeface="Inter" pitchFamily="34" charset="-122"/>
-                <a:cs typeface="Inter" pitchFamily="34" charset="-120"/>
-              </a:rPr>
-              <a:t>Target 85% · group 94.7%</a:t>
-            </a:r>
-            <a:endParaRPr lang="en-US" sz="1400" dirty="0"/>
-          </a:p>
-        </p:txBody>
-      </p:sp>
-      <p:sp>
-        <p:nvSpPr>
-          <p:cNvPr id="30" name="Shape 28"/>
-          <p:cNvSpPr/>
-          <p:nvPr/>
-        </p:nvSpPr>
-        <p:spPr>
-          <a:xfrm>
-            <a:off x="713232" y="4526280"/>
-            <a:ext cx="10762488" cy="1097280"/>
-          </a:xfrm>
-          <a:prstGeom prst="rect">
-            <a:avLst/>
-          </a:prstGeom>
-          <a:solidFill>
-            <a:srgbClr val="EDF4FA"/>
-          </a:solidFill>
-          <a:ln/>
-        </p:spPr>
-      </p:sp>
-      <p:sp>
-        <p:nvSpPr>
-          <p:cNvPr id="31" name="Text 29"/>
-          <p:cNvSpPr txBox="1"/>
-          <p:nvPr/>
-        </p:nvSpPr>
-        <p:spPr>
-          <a:xfrm>
-            <a:off x="896112" y="4654296"/>
-            <a:ext cx="10396728" cy="256032"/>
-          </a:xfrm>
-          <a:prstGeom prst="rect">
-            <a:avLst/>
-          </a:prstGeom>
-          <a:noFill/>
-          <a:ln/>
-        </p:spPr>
-        <p:txBody>
-          <a:bodyPr wrap="square" lIns="0" tIns="0" rIns="0" bIns="0" rtlCol="0" anchor="ctr"/>
-          <a:lstStyle/>
-          <a:p>
-            <a:pPr indent="0" marL="0">
-              <a:buNone/>
-            </a:pPr>
-            <a:r>
-              <a:rPr lang="en-US" sz="1400" b="1" spc="80" kern="0" dirty="0">
-                <a:solidFill>
-                  <a:srgbClr val="595959"/>
-                </a:solidFill>
-                <a:latin typeface="Inter" pitchFamily="34" charset="0"/>
-                <a:ea typeface="Inter" pitchFamily="34" charset="-122"/>
-                <a:cs typeface="Inter" pitchFamily="34" charset="-120"/>
-              </a:rPr>
-              <a:t>ILLUSTRATIVE EXAMPLE</a:t>
-            </a:r>
-            <a:endParaRPr lang="en-US" sz="1400" dirty="0"/>
-          </a:p>
-        </p:txBody>
-      </p:sp>
-      <p:sp>
-        <p:nvSpPr>
-          <p:cNvPr id="32" name="Text 30"/>
-          <p:cNvSpPr txBox="1"/>
-          <p:nvPr/>
-        </p:nvSpPr>
-        <p:spPr>
-          <a:xfrm>
-            <a:off x="896112" y="4946904"/>
-            <a:ext cx="10396728" cy="292608"/>
-          </a:xfrm>
-          <a:prstGeom prst="rect">
-            <a:avLst/>
-          </a:prstGeom>
-          <a:noFill/>
-          <a:ln/>
-        </p:spPr>
-        <p:txBody>
-          <a:bodyPr wrap="square" lIns="0" tIns="0" rIns="0" bIns="0" rtlCol="0" anchor="ctr"/>
-          <a:lstStyle/>
-          <a:p>
-            <a:pPr indent="0" marL="0">
-              <a:buNone/>
-            </a:pPr>
-            <a:r>
-              <a:rPr lang="en-US" sz="1600" dirty="0">
-                <a:solidFill>
-                  <a:srgbClr val="1A1A1A"/>
-                </a:solidFill>
-                <a:latin typeface="Inter" pitchFamily="34" charset="0"/>
-                <a:ea typeface="Inter" pitchFamily="34" charset="-122"/>
-                <a:cs typeface="Inter" pitchFamily="34" charset="-120"/>
-              </a:rPr>
-              <a:t>A technician has 8 available hours, clocks 6 hours to repair orders and flags 7.5 hours.</a:t>
-            </a:r>
-            <a:endParaRPr lang="en-US" sz="1600" dirty="0"/>
-          </a:p>
-        </p:txBody>
-      </p:sp>
-      <p:sp>
-        <p:nvSpPr>
-          <p:cNvPr id="33" name="Text 31"/>
-          <p:cNvSpPr txBox="1"/>
-          <p:nvPr/>
-        </p:nvSpPr>
-        <p:spPr>
-          <a:xfrm>
-            <a:off x="896112" y="5257800"/>
-            <a:ext cx="10396728" cy="292608"/>
-          </a:xfrm>
-          <a:prstGeom prst="rect">
-            <a:avLst/>
-          </a:prstGeom>
-          <a:noFill/>
-          <a:ln/>
-        </p:spPr>
-        <p:txBody>
-          <a:bodyPr wrap="square" lIns="0" tIns="0" rIns="0" bIns="0" rtlCol="0" anchor="ctr"/>
-          <a:lstStyle/>
-          <a:p>
-            <a:pPr indent="0" marL="0">
-              <a:buNone/>
-            </a:pPr>
-            <a:r>
-              <a:rPr lang="en-US" sz="1600" b="1" dirty="0">
-                <a:solidFill>
-                  <a:srgbClr val="0B2C4A"/>
-                </a:solidFill>
-                <a:latin typeface="Inter" pitchFamily="34" charset="0"/>
-                <a:ea typeface="Inter" pitchFamily="34" charset="-122"/>
-                <a:cs typeface="Inter" pitchFamily="34" charset="-120"/>
-              </a:rPr>
               <a:t>Productivity × efficiency = proficiency:  75% × 125% = 93.75%</a:t>
             </a:r>
-            <a:endParaRPr lang="en-US" sz="1600" dirty="0"/>
-          </a:p>
-        </p:txBody>
-      </p:sp>
-      <p:sp>
-        <p:nvSpPr>
-          <p:cNvPr id="34" name="Shape 32"/>
-          <p:cNvSpPr/>
-          <p:nvPr/>
-        </p:nvSpPr>
-        <p:spPr>
-          <a:xfrm>
-            <a:off x="457200" y="6126480"/>
-            <a:ext cx="11274552" cy="615696"/>
-          </a:xfrm>
-          <a:prstGeom prst="rect">
-            <a:avLst/>
-          </a:prstGeom>
-          <a:solidFill>
-            <a:srgbClr val="EDF4FA"/>
-          </a:solidFill>
-          <a:ln/>
-        </p:spPr>
-      </p:sp>
-      <p:sp>
-        <p:nvSpPr>
-          <p:cNvPr id="35" name="Text 33"/>
-          <p:cNvSpPr txBox="1"/>
-          <p:nvPr/>
-        </p:nvSpPr>
-        <p:spPr>
-          <a:xfrm>
-            <a:off x="658368" y="6144768"/>
-            <a:ext cx="10927080" cy="579120"/>
-          </a:xfrm>
-          <a:prstGeom prst="rect">
-            <a:avLst/>
-          </a:prstGeom>
-          <a:noFill/>
-          <a:ln/>
-        </p:spPr>
-        <p:txBody>
-          <a:bodyPr wrap="square" lIns="0" tIns="0" rIns="0" bIns="0" rtlCol="0" anchor="ctr"/>
-          <a:lstStyle/>
-          <a:p>
-            <a:pPr indent="0" marL="0">
-              <a:buNone/>
-            </a:pPr>
-            <a:r>
-              <a:rPr lang="en-US" sz="1600" b="1" dirty="0">
-                <a:solidFill>
-                  <a:srgbClr val="0B2C4A"/>
-                </a:solidFill>
-                <a:latin typeface="Inter" pitchFamily="34" charset="0"/>
-                <a:ea typeface="Inter" pitchFamily="34" charset="-122"/>
-                <a:cs typeface="Inter" pitchFamily="34" charset="-120"/>
-              </a:rPr>
-              <a:t>Productivity measures time spent on repair orders; efficiency measures hours flagged against time on repair orders; proficiency measures total hours flagged against available time.</a:t>
-            </a:r>
-            <a:endParaRPr lang="en-US" sz="1600" dirty="0"/>
+            <a:endParaRPr lang="en-US" sz="1800" dirty="0"/>
           </a:p>
         </p:txBody>
       </p:sp>

</xml_diff>

<commit_message>
Drop bottom bands on CP RO count, hours per RO, ELR explainers and CP ELR chart
Co-Authored-By: Claude Opus 5.5 <noreply@anthropic.com>
Claude-Session: https://claude.ai/code/session_01Xa4nFVxuQGXmHARGph9WhS
</commit_message>
<xml_diff>
--- a/day2-deck/decks/Metric Explainers - Review.pptx
+++ b/day2-deck/decks/Metric Explainers - Review.pptx
@@ -2285,7 +2285,7 @@
         <p:spPr>
           <a:xfrm>
             <a:off x="457200" y="2340864"/>
-            <a:ext cx="4343400" cy="3648456"/>
+            <a:ext cx="4343400" cy="4014216"/>
           </a:xfrm>
           <a:prstGeom prst="rect">
             <a:avLst/>
@@ -2305,7 +2305,7 @@
         <p:spPr>
           <a:xfrm>
             <a:off x="4937760" y="2340864"/>
-            <a:ext cx="6793992" cy="3648456"/>
+            <a:ext cx="6793992" cy="4014216"/>
           </a:xfrm>
           <a:prstGeom prst="rect">
             <a:avLst/>
@@ -2403,7 +2403,7 @@
         <p:spPr>
           <a:xfrm>
             <a:off x="658368" y="2843784"/>
-            <a:ext cx="3977640" cy="3008376"/>
+            <a:ext cx="3977640" cy="3374136"/>
           </a:xfrm>
           <a:prstGeom prst="rect">
             <a:avLst/>
@@ -2488,7 +2488,7 @@
         <p:spPr>
           <a:xfrm>
             <a:off x="5138928" y="2843784"/>
-            <a:ext cx="45720" cy="801942"/>
+            <a:ext cx="45720" cy="911125"/>
           </a:xfrm>
           <a:prstGeom prst="rect">
             <a:avLst/>
@@ -2508,7 +2508,7 @@
         <p:spPr>
           <a:xfrm>
             <a:off x="5266944" y="2843784"/>
-            <a:ext cx="2962656" cy="801942"/>
+            <a:ext cx="2962656" cy="911125"/>
           </a:xfrm>
           <a:prstGeom prst="rect">
             <a:avLst/>
@@ -2564,7 +2564,7 @@
         <p:spPr>
           <a:xfrm>
             <a:off x="8394192" y="2843784"/>
-            <a:ext cx="45720" cy="801942"/>
+            <a:ext cx="45720" cy="911125"/>
           </a:xfrm>
           <a:prstGeom prst="rect">
             <a:avLst/>
@@ -2584,7 +2584,7 @@
         <p:spPr>
           <a:xfrm>
             <a:off x="8522208" y="2843784"/>
-            <a:ext cx="2962656" cy="801942"/>
+            <a:ext cx="2962656" cy="911125"/>
           </a:xfrm>
           <a:prstGeom prst="rect">
             <a:avLst/>
@@ -2639,8 +2639,8 @@
         </p:nvSpPr>
         <p:spPr>
           <a:xfrm>
-            <a:off x="5138928" y="3755454"/>
-            <a:ext cx="45720" cy="1121027"/>
+            <a:off x="5138928" y="3864637"/>
+            <a:ext cx="45720" cy="1268423"/>
           </a:xfrm>
           <a:prstGeom prst="rect">
             <a:avLst/>
@@ -2659,8 +2659,8 @@
         </p:nvSpPr>
         <p:spPr>
           <a:xfrm>
-            <a:off x="5266944" y="3755454"/>
-            <a:ext cx="2962656" cy="1121027"/>
+            <a:off x="5266944" y="3864637"/>
+            <a:ext cx="2962656" cy="1268423"/>
           </a:xfrm>
           <a:prstGeom prst="rect">
             <a:avLst/>
@@ -2715,8 +2715,8 @@
         </p:nvSpPr>
         <p:spPr>
           <a:xfrm>
-            <a:off x="8394192" y="3755454"/>
-            <a:ext cx="45720" cy="1121027"/>
+            <a:off x="8394192" y="3864637"/>
+            <a:ext cx="45720" cy="1268423"/>
           </a:xfrm>
           <a:prstGeom prst="rect">
             <a:avLst/>
@@ -2735,8 +2735,8 @@
         </p:nvSpPr>
         <p:spPr>
           <a:xfrm>
-            <a:off x="8522208" y="3755454"/>
-            <a:ext cx="2962656" cy="1121027"/>
+            <a:off x="8522208" y="3864637"/>
+            <a:ext cx="2962656" cy="1268423"/>
           </a:xfrm>
           <a:prstGeom prst="rect">
             <a:avLst/>
@@ -2791,8 +2791,8 @@
         </p:nvSpPr>
         <p:spPr>
           <a:xfrm>
-            <a:off x="5138928" y="4986210"/>
-            <a:ext cx="45720" cy="801942"/>
+            <a:off x="5138928" y="5242787"/>
+            <a:ext cx="45720" cy="911125"/>
           </a:xfrm>
           <a:prstGeom prst="rect">
             <a:avLst/>
@@ -2811,8 +2811,8 @@
         </p:nvSpPr>
         <p:spPr>
           <a:xfrm>
-            <a:off x="5266944" y="4986210"/>
-            <a:ext cx="2962656" cy="801942"/>
+            <a:off x="5266944" y="5242787"/>
+            <a:ext cx="2962656" cy="911125"/>
           </a:xfrm>
           <a:prstGeom prst="rect">
             <a:avLst/>
@@ -2867,8 +2867,8 @@
         </p:nvSpPr>
         <p:spPr>
           <a:xfrm>
-            <a:off x="8394192" y="4986210"/>
-            <a:ext cx="45720" cy="801942"/>
+            <a:off x="8394192" y="5242787"/>
+            <a:ext cx="45720" cy="911125"/>
           </a:xfrm>
           <a:prstGeom prst="rect">
             <a:avLst/>
@@ -2887,8 +2887,8 @@
         </p:nvSpPr>
         <p:spPr>
           <a:xfrm>
-            <a:off x="8522208" y="4986210"/>
-            <a:ext cx="2962656" cy="801942"/>
+            <a:off x="8522208" y="5242787"/>
+            <a:ext cx="2962656" cy="911125"/>
           </a:xfrm>
           <a:prstGeom prst="rect">
             <a:avLst/>
@@ -2932,65 +2932,6 @@
               <a:t>Fixed ops budget, keyword search, OEM and third-party reminders</a:t>
             </a:r>
             <a:endParaRPr lang="en-US" sz="1400" dirty="0"/>
-          </a:p>
-        </p:txBody>
-      </p:sp>
-      <p:sp>
-        <p:nvSpPr>
-          <p:cNvPr id="25" name="Shape 23"/>
-          <p:cNvSpPr/>
-          <p:nvPr/>
-        </p:nvSpPr>
-        <p:spPr>
-          <a:xfrm>
-            <a:off x="457200" y="6126480"/>
-            <a:ext cx="11274552" cy="371856"/>
-          </a:xfrm>
-          <a:prstGeom prst="rect">
-            <a:avLst/>
-          </a:prstGeom>
-          <a:solidFill>
-            <a:srgbClr val="EDF4FA"/>
-          </a:solidFill>
-          <a:ln/>
-        </p:spPr>
-      </p:sp>
-      <p:sp>
-        <p:nvSpPr>
-          <p:cNvPr id="26" name="Text 24"/>
-          <p:cNvSpPr txBox="1"/>
-          <p:nvPr/>
-        </p:nvSpPr>
-        <p:spPr>
-          <a:xfrm>
-            <a:off x="658368" y="6144768"/>
-            <a:ext cx="10927080" cy="335280"/>
-          </a:xfrm>
-          <a:prstGeom prst="rect">
-            <a:avLst/>
-          </a:prstGeom>
-          <a:noFill/>
-          <a:ln/>
-        </p:spPr>
-        <p:txBody>
-          <a:bodyPr wrap="square" lIns="0" tIns="0" rIns="0" bIns="0" rtlCol="0" anchor="ctr"/>
-          <a:lstStyle/>
-          <a:p>
-            <a:pPr indent="0" marL="0">
-              <a:buNone/>
-            </a:pPr>
-            <a:r>
-              <a:rPr lang="en-US" sz="1600" b="1" dirty="0">
-                <a:solidFill>
-                  <a:srgbClr val="0B2C4A"/>
-                </a:solidFill>
-                <a:latin typeface="Inter" pitchFamily="34" charset="0"/>
-                <a:ea typeface="Inter" pitchFamily="34" charset="-122"/>
-                <a:cs typeface="Inter" pitchFamily="34" charset="-120"/>
-              </a:rPr>
-              <a:t>Group: 279,756 CP ROs, up 456 from 2025. Volume is flat.</a:t>
-            </a:r>
-            <a:endParaRPr lang="en-US" sz="1600" dirty="0"/>
           </a:p>
         </p:txBody>
       </p:sp>
@@ -9084,7 +9025,7 @@
         <p:spPr>
           <a:xfrm>
             <a:off x="457200" y="2907792"/>
-            <a:ext cx="4343400" cy="3081528"/>
+            <a:ext cx="4343400" cy="3447288"/>
           </a:xfrm>
           <a:prstGeom prst="rect">
             <a:avLst/>
@@ -9104,7 +9045,7 @@
         <p:spPr>
           <a:xfrm>
             <a:off x="4937760" y="2907792"/>
-            <a:ext cx="6793992" cy="3081528"/>
+            <a:ext cx="6793992" cy="3447288"/>
           </a:xfrm>
           <a:prstGeom prst="rect">
             <a:avLst/>
@@ -9202,7 +9143,7 @@
         <p:spPr>
           <a:xfrm>
             <a:off x="658368" y="3410712"/>
-            <a:ext cx="3977640" cy="2441448"/>
+            <a:ext cx="3977640" cy="2807208"/>
           </a:xfrm>
           <a:prstGeom prst="rect">
             <a:avLst/>
@@ -9222,7 +9163,7 @@
               <a:buChar char="•"/>
             </a:pPr>
             <a:r>
-              <a:rPr lang="en-US" sz="1500" dirty="0">
+              <a:rPr lang="en-US" sz="1600" dirty="0">
                 <a:solidFill>
                   <a:srgbClr val="1A1A1A"/>
                 </a:solidFill>
@@ -9232,7 +9173,7 @@
               </a:rPr>
               <a:t>It cannot be manipulated: it is the work we sell.</a:t>
             </a:r>
-            <a:endParaRPr lang="en-US" sz="1500" dirty="0"/>
+            <a:endParaRPr lang="en-US" sz="1600" dirty="0"/>
           </a:p>
           <a:p>
             <a:pPr marL="203200" indent="-203200">
@@ -9243,7 +9184,7 @@
               <a:buChar char="•"/>
             </a:pPr>
             <a:r>
-              <a:rPr lang="en-US" sz="1500" dirty="0">
+              <a:rPr lang="en-US" sz="1600" dirty="0">
                 <a:solidFill>
                   <a:srgbClr val="1A1A1A"/>
                 </a:solidFill>
@@ -9253,7 +9194,7 @@
               </a:rPr>
               <a:t>It shows where the lift came from: if labor sales per RO go up but hours per RO stay flat, we are charging more, not selling more.</a:t>
             </a:r>
-            <a:endParaRPr lang="en-US" sz="1500" dirty="0"/>
+            <a:endParaRPr lang="en-US" sz="1600" dirty="0"/>
           </a:p>
           <a:p>
             <a:pPr marL="203200" indent="-203200">
@@ -9264,7 +9205,7 @@
               <a:buChar char="•"/>
             </a:pPr>
             <a:r>
-              <a:rPr lang="en-US" sz="1500" dirty="0">
+              <a:rPr lang="en-US" sz="1600" dirty="0">
                 <a:solidFill>
                   <a:srgbClr val="1A1A1A"/>
                 </a:solidFill>
@@ -9274,7 +9215,7 @@
               </a:rPr>
               <a:t>Selling more hours also sells parts.</a:t>
             </a:r>
-            <a:endParaRPr lang="en-US" sz="1500" dirty="0"/>
+            <a:endParaRPr lang="en-US" sz="1600" dirty="0"/>
           </a:p>
         </p:txBody>
       </p:sp>
@@ -9287,7 +9228,7 @@
         <p:spPr>
           <a:xfrm>
             <a:off x="5138928" y="3410712"/>
-            <a:ext cx="45720" cy="1133856"/>
+            <a:ext cx="45720" cy="841248"/>
           </a:xfrm>
           <a:prstGeom prst="rect">
             <a:avLst/>
@@ -9307,7 +9248,7 @@
         <p:spPr>
           <a:xfrm>
             <a:off x="5266944" y="3410712"/>
-            <a:ext cx="1877568" cy="1133856"/>
+            <a:ext cx="2962656" cy="841248"/>
           </a:xfrm>
           <a:prstGeom prst="rect">
             <a:avLst/>
@@ -9362,8 +9303,8 @@
         </p:nvSpPr>
         <p:spPr>
           <a:xfrm>
-            <a:off x="7309104" y="3410712"/>
-            <a:ext cx="45720" cy="1133856"/>
+            <a:off x="8394192" y="3410712"/>
+            <a:ext cx="45720" cy="841248"/>
           </a:xfrm>
           <a:prstGeom prst="rect">
             <a:avLst/>
@@ -9382,8 +9323,8 @@
         </p:nvSpPr>
         <p:spPr>
           <a:xfrm>
-            <a:off x="7437120" y="3410712"/>
-            <a:ext cx="1877568" cy="1133856"/>
+            <a:off x="8522208" y="3410712"/>
+            <a:ext cx="2962656" cy="841248"/>
           </a:xfrm>
           <a:prstGeom prst="rect">
             <a:avLst/>
@@ -9438,8 +9379,8 @@
         </p:nvSpPr>
         <p:spPr>
           <a:xfrm>
-            <a:off x="9479280" y="3410712"/>
-            <a:ext cx="45720" cy="1133856"/>
+            <a:off x="5138928" y="4361688"/>
+            <a:ext cx="45720" cy="841248"/>
           </a:xfrm>
           <a:prstGeom prst="rect">
             <a:avLst/>
@@ -9458,8 +9399,8 @@
         </p:nvSpPr>
         <p:spPr>
           <a:xfrm>
-            <a:off x="9607296" y="3410712"/>
-            <a:ext cx="1877568" cy="1133856"/>
+            <a:off x="5266944" y="4361688"/>
+            <a:ext cx="2962656" cy="841248"/>
           </a:xfrm>
           <a:prstGeom prst="rect">
             <a:avLst/>
@@ -9514,8 +9455,8 @@
         </p:nvSpPr>
         <p:spPr>
           <a:xfrm>
-            <a:off x="5138928" y="4654296"/>
-            <a:ext cx="45720" cy="1133856"/>
+            <a:off x="8394192" y="4361688"/>
+            <a:ext cx="45720" cy="841248"/>
           </a:xfrm>
           <a:prstGeom prst="rect">
             <a:avLst/>
@@ -9534,8 +9475,8 @@
         </p:nvSpPr>
         <p:spPr>
           <a:xfrm>
-            <a:off x="5266944" y="4654296"/>
-            <a:ext cx="1877568" cy="1133856"/>
+            <a:off x="8522208" y="4361688"/>
+            <a:ext cx="2962656" cy="841248"/>
           </a:xfrm>
           <a:prstGeom prst="rect">
             <a:avLst/>
@@ -9590,8 +9531,8 @@
         </p:nvSpPr>
         <p:spPr>
           <a:xfrm>
-            <a:off x="7309104" y="4654296"/>
-            <a:ext cx="45720" cy="1133856"/>
+            <a:off x="5138928" y="5312664"/>
+            <a:ext cx="45720" cy="841248"/>
           </a:xfrm>
           <a:prstGeom prst="rect">
             <a:avLst/>
@@ -9610,8 +9551,8 @@
         </p:nvSpPr>
         <p:spPr>
           <a:xfrm>
-            <a:off x="7437120" y="4654296"/>
-            <a:ext cx="1877568" cy="1133856"/>
+            <a:off x="5266944" y="5312664"/>
+            <a:ext cx="2962656" cy="841248"/>
           </a:xfrm>
           <a:prstGeom prst="rect">
             <a:avLst/>
@@ -9666,8 +9607,8 @@
         </p:nvSpPr>
         <p:spPr>
           <a:xfrm>
-            <a:off x="9479280" y="4654296"/>
-            <a:ext cx="45720" cy="1133856"/>
+            <a:off x="8394192" y="5312664"/>
+            <a:ext cx="45720" cy="841248"/>
           </a:xfrm>
           <a:prstGeom prst="rect">
             <a:avLst/>
@@ -9686,8 +9627,8 @@
         </p:nvSpPr>
         <p:spPr>
           <a:xfrm>
-            <a:off x="9607296" y="4654296"/>
-            <a:ext cx="1877568" cy="1133856"/>
+            <a:off x="8522208" y="5312664"/>
+            <a:ext cx="2962656" cy="841248"/>
           </a:xfrm>
           <a:prstGeom prst="rect">
             <a:avLst/>
@@ -9731,65 +9672,6 @@
               <a:t>High-mileage and repair work to the techs who find it</a:t>
             </a:r>
             <a:endParaRPr lang="en-US" sz="1400" dirty="0"/>
-          </a:p>
-        </p:txBody>
-      </p:sp>
-      <p:sp>
-        <p:nvSpPr>
-          <p:cNvPr id="30" name="Shape 28"/>
-          <p:cNvSpPr/>
-          <p:nvPr/>
-        </p:nvSpPr>
-        <p:spPr>
-          <a:xfrm>
-            <a:off x="457200" y="6126480"/>
-            <a:ext cx="11274552" cy="371856"/>
-          </a:xfrm>
-          <a:prstGeom prst="rect">
-            <a:avLst/>
-          </a:prstGeom>
-          <a:solidFill>
-            <a:srgbClr val="E6F6EE"/>
-          </a:solidFill>
-          <a:ln/>
-        </p:spPr>
-      </p:sp>
-      <p:sp>
-        <p:nvSpPr>
-          <p:cNvPr id="31" name="Text 29"/>
-          <p:cNvSpPr txBox="1"/>
-          <p:nvPr/>
-        </p:nvSpPr>
-        <p:spPr>
-          <a:xfrm>
-            <a:off x="658368" y="6144768"/>
-            <a:ext cx="10927080" cy="335280"/>
-          </a:xfrm>
-          <a:prstGeom prst="rect">
-            <a:avLst/>
-          </a:prstGeom>
-          <a:noFill/>
-          <a:ln/>
-        </p:spPr>
-        <p:txBody>
-          <a:bodyPr wrap="square" lIns="0" tIns="0" rIns="0" bIns="0" rtlCol="0" anchor="ctr"/>
-          <a:lstStyle/>
-          <a:p>
-            <a:pPr indent="0" marL="0">
-              <a:buNone/>
-            </a:pPr>
-            <a:r>
-              <a:rPr lang="en-US" sz="1600" b="1" dirty="0">
-                <a:solidFill>
-                  <a:srgbClr val="0B7A4A"/>
-                </a:solidFill>
-                <a:latin typeface="Inter" pitchFamily="34" charset="0"/>
-                <a:ea typeface="Inter" pitchFamily="34" charset="-122"/>
-                <a:cs typeface="Inter" pitchFamily="34" charset="-120"/>
-              </a:rPr>
-              <a:t>Group: 1.87 CP hours per RO, up 0.07 and ahead of 2025 in all nine months.</a:t>
-            </a:r>
-            <a:endParaRPr lang="en-US" sz="1600" dirty="0"/>
           </a:p>
         </p:txBody>
       </p:sp>
@@ -10088,7 +9970,7 @@
         <p:spPr>
           <a:xfrm>
             <a:off x="457200" y="2340864"/>
-            <a:ext cx="4343400" cy="3648456"/>
+            <a:ext cx="4343400" cy="4014216"/>
           </a:xfrm>
           <a:prstGeom prst="rect">
             <a:avLst/>
@@ -10108,7 +9990,7 @@
         <p:spPr>
           <a:xfrm>
             <a:off x="4937760" y="2340864"/>
-            <a:ext cx="6793992" cy="3648456"/>
+            <a:ext cx="6793992" cy="4014216"/>
           </a:xfrm>
           <a:prstGeom prst="rect">
             <a:avLst/>
@@ -10206,7 +10088,7 @@
         <p:spPr>
           <a:xfrm>
             <a:off x="658368" y="2843784"/>
-            <a:ext cx="3977640" cy="3008376"/>
+            <a:ext cx="3977640" cy="3374136"/>
           </a:xfrm>
           <a:prstGeom prst="rect">
             <a:avLst/>
@@ -10291,7 +10173,7 @@
         <p:spPr>
           <a:xfrm>
             <a:off x="5138928" y="2843784"/>
-            <a:ext cx="45720" cy="1064924"/>
+            <a:ext cx="45720" cy="1205601"/>
           </a:xfrm>
           <a:prstGeom prst="rect">
             <a:avLst/>
@@ -10311,7 +10193,7 @@
         <p:spPr>
           <a:xfrm>
             <a:off x="5266944" y="2843784"/>
-            <a:ext cx="2962656" cy="1064924"/>
+            <a:ext cx="2962656" cy="1205601"/>
           </a:xfrm>
           <a:prstGeom prst="rect">
             <a:avLst/>
@@ -10367,7 +10249,7 @@
         <p:spPr>
           <a:xfrm>
             <a:off x="8394192" y="2843784"/>
-            <a:ext cx="45720" cy="1064924"/>
+            <a:ext cx="45720" cy="1205601"/>
           </a:xfrm>
           <a:prstGeom prst="rect">
             <a:avLst/>
@@ -10387,7 +10269,7 @@
         <p:spPr>
           <a:xfrm>
             <a:off x="8522208" y="2843784"/>
-            <a:ext cx="2962656" cy="1064924"/>
+            <a:ext cx="2962656" cy="1205601"/>
           </a:xfrm>
           <a:prstGeom prst="rect">
             <a:avLst/>
@@ -10442,8 +10324,8 @@
         </p:nvSpPr>
         <p:spPr>
           <a:xfrm>
-            <a:off x="5138928" y="4018436"/>
-            <a:ext cx="45720" cy="829994"/>
+            <a:off x="5138928" y="4159113"/>
+            <a:ext cx="45720" cy="942535"/>
           </a:xfrm>
           <a:prstGeom prst="rect">
             <a:avLst/>
@@ -10462,8 +10344,8 @@
         </p:nvSpPr>
         <p:spPr>
           <a:xfrm>
-            <a:off x="5266944" y="4018436"/>
-            <a:ext cx="2962656" cy="829994"/>
+            <a:off x="5266944" y="4159113"/>
+            <a:ext cx="2962656" cy="942535"/>
           </a:xfrm>
           <a:prstGeom prst="rect">
             <a:avLst/>
@@ -10518,8 +10400,8 @@
         </p:nvSpPr>
         <p:spPr>
           <a:xfrm>
-            <a:off x="8394192" y="4018436"/>
-            <a:ext cx="45720" cy="829994"/>
+            <a:off x="8394192" y="4159113"/>
+            <a:ext cx="45720" cy="942535"/>
           </a:xfrm>
           <a:prstGeom prst="rect">
             <a:avLst/>
@@ -10538,8 +10420,8 @@
         </p:nvSpPr>
         <p:spPr>
           <a:xfrm>
-            <a:off x="8522208" y="4018436"/>
-            <a:ext cx="2962656" cy="829994"/>
+            <a:off x="8522208" y="4159113"/>
+            <a:ext cx="2962656" cy="942535"/>
           </a:xfrm>
           <a:prstGeom prst="rect">
             <a:avLst/>
@@ -10594,8 +10476,8 @@
         </p:nvSpPr>
         <p:spPr>
           <a:xfrm>
-            <a:off x="5138928" y="4958158"/>
-            <a:ext cx="45720" cy="829994"/>
+            <a:off x="5138928" y="5211377"/>
+            <a:ext cx="45720" cy="942535"/>
           </a:xfrm>
           <a:prstGeom prst="rect">
             <a:avLst/>
@@ -10614,8 +10496,8 @@
         </p:nvSpPr>
         <p:spPr>
           <a:xfrm>
-            <a:off x="5266944" y="4958158"/>
-            <a:ext cx="2962656" cy="829994"/>
+            <a:off x="5266944" y="5211377"/>
+            <a:ext cx="2962656" cy="942535"/>
           </a:xfrm>
           <a:prstGeom prst="rect">
             <a:avLst/>
@@ -10670,8 +10552,8 @@
         </p:nvSpPr>
         <p:spPr>
           <a:xfrm>
-            <a:off x="8394192" y="4958158"/>
-            <a:ext cx="45720" cy="829994"/>
+            <a:off x="8394192" y="5211377"/>
+            <a:ext cx="45720" cy="942535"/>
           </a:xfrm>
           <a:prstGeom prst="rect">
             <a:avLst/>
@@ -10690,8 +10572,8 @@
         </p:nvSpPr>
         <p:spPr>
           <a:xfrm>
-            <a:off x="8522208" y="4958158"/>
-            <a:ext cx="2962656" cy="829994"/>
+            <a:off x="8522208" y="5211377"/>
+            <a:ext cx="2962656" cy="942535"/>
           </a:xfrm>
           <a:prstGeom prst="rect">
             <a:avLst/>
@@ -10735,65 +10617,6 @@
               <a:t>The hours we set and pay the tech on menu jobs; repair times come from labor guides</a:t>
             </a:r>
             <a:endParaRPr lang="en-US" sz="1400" dirty="0"/>
-          </a:p>
-        </p:txBody>
-      </p:sp>
-      <p:sp>
-        <p:nvSpPr>
-          <p:cNvPr id="25" name="Shape 23"/>
-          <p:cNvSpPr/>
-          <p:nvPr/>
-        </p:nvSpPr>
-        <p:spPr>
-          <a:xfrm>
-            <a:off x="457200" y="6126480"/>
-            <a:ext cx="11274552" cy="364236"/>
-          </a:xfrm>
-          <a:prstGeom prst="rect">
-            <a:avLst/>
-          </a:prstGeom>
-          <a:solidFill>
-            <a:srgbClr val="E6F6EE"/>
-          </a:solidFill>
-          <a:ln/>
-        </p:spPr>
-      </p:sp>
-      <p:sp>
-        <p:nvSpPr>
-          <p:cNvPr id="26" name="Text 24"/>
-          <p:cNvSpPr txBox="1"/>
-          <p:nvPr/>
-        </p:nvSpPr>
-        <p:spPr>
-          <a:xfrm>
-            <a:off x="658368" y="6144768"/>
-            <a:ext cx="10927080" cy="327660"/>
-          </a:xfrm>
-          <a:prstGeom prst="rect">
-            <a:avLst/>
-          </a:prstGeom>
-          <a:noFill/>
-          <a:ln/>
-        </p:spPr>
-        <p:txBody>
-          <a:bodyPr wrap="square" lIns="0" tIns="0" rIns="0" bIns="0" rtlCol="0" anchor="ctr"/>
-          <a:lstStyle/>
-          <a:p>
-            <a:pPr indent="0" marL="0">
-              <a:buNone/>
-            </a:pPr>
-            <a:r>
-              <a:rPr lang="en-US" sz="1550" b="1" dirty="0">
-                <a:solidFill>
-                  <a:srgbClr val="0B7A4A"/>
-                </a:solidFill>
-                <a:latin typeface="Inter" pitchFamily="34" charset="0"/>
-                <a:ea typeface="Inter" pitchFamily="34" charset="-122"/>
-                <a:cs typeface="Inter" pitchFamily="34" charset="-120"/>
-              </a:rPr>
-              <a:t>Group: $162.42 CP ELR, up $3.56. Jul-Sep it ran 74.7% of door rate; 25 of 33 stores at or above 70%.</a:t>
-            </a:r>
-            <a:endParaRPr lang="en-US" sz="1550" dirty="0"/>
           </a:p>
         </p:txBody>
       </p:sp>

</xml_diff>

<commit_message>
Pay Yourself First wording; clocked-hours line moved to How We Measured It
Co-Authored-By: Claude Opus 5.5 <noreply@anthropic.com>
Claude-Session: https://claude.ai/code/session_01Xa4nFVxuQGXmHARGph9WhS
</commit_message>
<xml_diff>
--- a/day2-deck/decks/Metric Explainers - Review.pptx
+++ b/day2-deck/decks/Metric Explainers - Review.pptx
@@ -5681,7 +5681,7 @@
                 <a:ea typeface="Inter" pitchFamily="34" charset="-122"/>
                 <a:cs typeface="Inter" pitchFamily="34" charset="-120"/>
               </a:rPr>
-              <a:t>January through September 2026, year to date. Vacation, paid time off and holiday pay are excluded from clocked hours. Store = total hours flagged ÷ total clocked hours.</a:t>
+              <a:t>January through September 2026, year to date. Clocked hours exclude vacation, paid time off and holiday pay. Store = total hours flagged ÷ total clocked hours.</a:t>
             </a:r>
             <a:endParaRPr lang="en-US" sz="1400" dirty="0"/>
           </a:p>
@@ -8364,7 +8364,7 @@
         <p:spPr>
           <a:xfrm>
             <a:off x="713232" y="4709160"/>
-            <a:ext cx="10762488" cy="1572768"/>
+            <a:ext cx="10762488" cy="1261872"/>
           </a:xfrm>
           <a:prstGeom prst="rect">
             <a:avLst/>
@@ -8489,45 +8489,6 @@
               <a:t>Productivity × efficiency = proficiency:  75% × 125% = 93.75%</a:t>
             </a:r>
             <a:endParaRPr lang="en-US" sz="1800" dirty="0"/>
-          </a:p>
-        </p:txBody>
-      </p:sp>
-      <p:sp>
-        <p:nvSpPr>
-          <p:cNvPr id="31" name="Text 29"/>
-          <p:cNvSpPr txBox="1"/>
-          <p:nvPr/>
-        </p:nvSpPr>
-        <p:spPr>
-          <a:xfrm>
-            <a:off x="896112" y="5897880"/>
-            <a:ext cx="10396728" cy="292608"/>
-          </a:xfrm>
-          <a:prstGeom prst="rect">
-            <a:avLst/>
-          </a:prstGeom>
-          <a:noFill/>
-          <a:ln/>
-        </p:spPr>
-        <p:txBody>
-          <a:bodyPr wrap="square" lIns="0" tIns="0" rIns="0" bIns="0" rtlCol="0" anchor="ctr"/>
-          <a:lstStyle/>
-          <a:p>
-            <a:pPr indent="0" marL="0">
-              <a:buNone/>
-            </a:pPr>
-            <a:r>
-              <a:rPr lang="en-US" sz="1500" dirty="0">
-                <a:solidFill>
-                  <a:srgbClr val="595959"/>
-                </a:solidFill>
-                <a:latin typeface="Inter" pitchFamily="34" charset="0"/>
-                <a:ea typeface="Inter" pitchFamily="34" charset="-122"/>
-                <a:cs typeface="Inter" pitchFamily="34" charset="-120"/>
-              </a:rPr>
-              <a:t>Clocked hours exclude vacation, paid time off and holiday pay.</a:t>
-            </a:r>
-            <a:endParaRPr lang="en-US" sz="1500" dirty="0"/>
           </a:p>
         </p:txBody>
       </p:sp>

</xml_diff>